<commit_message>
Update measured performance points in deck
</commit_message>
<xml_diff>
--- a/ds4_gb10/docs/gb10-ds4-migration-two-pages.pptx
+++ b/ds4_gb10/docs/gb10-ds4-migration-two-pages.pptx
@@ -2,14 +2,14 @@
 <file path=ppt/presentation.xml><?xml version="1.0" encoding="utf-8"?>
 <p:presentation xmlns:p="http://schemas.openxmlformats.org/presentationml/2006/main">
   <p:sldMasterIdLst>
-    <p:sldMasterId xmlns:r="http://schemas.openxmlformats.org/officeDocument/2006/relationships" id="2147483648" r:id="Rbd42ea17cafe42ed"/>
+    <p:sldMasterId xmlns:r="http://schemas.openxmlformats.org/officeDocument/2006/relationships" id="2147483648" r:id="R29b08657ead74185"/>
   </p:sldMasterIdLst>
   <p:notesMasterIdLst>
-    <p:notesMasterId xmlns:r="http://schemas.openxmlformats.org/officeDocument/2006/relationships" r:id="R34b4cbc7c8914dac"/>
+    <p:notesMasterId xmlns:r="http://schemas.openxmlformats.org/officeDocument/2006/relationships" r:id="Ra3c759952d7640f9"/>
   </p:notesMasterIdLst>
   <p:sldIdLst>
-    <p:sldId xmlns:r="http://schemas.openxmlformats.org/officeDocument/2006/relationships" id="256" r:id="Rc253a3c4b6884b5b"/>
-    <p:sldId xmlns:r="http://schemas.openxmlformats.org/officeDocument/2006/relationships" id="257" r:id="R0fe578bb7dbb4ef3"/>
+    <p:sldId xmlns:r="http://schemas.openxmlformats.org/officeDocument/2006/relationships" id="256" r:id="R357ac94701b44363"/>
+    <p:sldId xmlns:r="http://schemas.openxmlformats.org/officeDocument/2006/relationships" id="257" r:id="Rae83bf24a5b34b4d"/>
   </p:sldIdLst>
   <p:sldSz cx="12192000" cy="6858000"/>
   <p:notesSz cx="6858000" cy="9144000"/>
@@ -573,7 +573,7 @@
   </p:cSld>
   <p:clrMap bg1="lt1" tx1="dk1" bg2="lt2" tx2="dk2" accent1="accent1" accent2="accent2" accent3="accent3" accent4="accent4" accent5="accent5" accent6="accent6" hlink="hlink" folHlink="folHlink"/>
   <p:sldLayoutIdLst>
-    <p:sldLayoutId xmlns:r="http://schemas.openxmlformats.org/officeDocument/2006/relationships" id="2147483649" r:id="R33f0f1d7f9984b54"/>
+    <p:sldLayoutId xmlns:r="http://schemas.openxmlformats.org/officeDocument/2006/relationships" id="2147483649" r:id="Rfdfa6c84b0984d7a"/>
   </p:sldLayoutIdLst>
   <p:txStyles>
     <p:titleStyle>
@@ -1117,7 +1117,7 @@
           <p:cNvPr id="110" name="">
             <a:extLst xmlns:a="http://schemas.openxmlformats.org/drawingml/2006/main">
               <a:ext uri="{FF2B5EF4-FFF2-40B4-BE49-F238E27FC236}">
-                <a16:creationId xmlns:a16="http://schemas.microsoft.com/office/drawing/2014/main" id="{A048A9F3-B498-4E50-9EA4-FCC3EA308C13}"/>
+                <a16:creationId xmlns:a16="http://schemas.microsoft.com/office/drawing/2014/main" id="{F2310050-268A-4ADF-8115-C9150D7DA81A}"/>
               </a:ext>
             </a:extLst>
           </p:cNvPr>
@@ -1181,7 +1181,7 @@
           <p:cNvPr id="2" name="">
             <a:extLst xmlns:a="http://schemas.openxmlformats.org/drawingml/2006/main">
               <a:ext uri="{FF2B5EF4-FFF2-40B4-BE49-F238E27FC236}">
-                <a16:creationId xmlns:a16="http://schemas.microsoft.com/office/drawing/2014/main" id="{E7D20BA0-80B5-4F3E-B8DE-5469B807D786}"/>
+                <a16:creationId xmlns:a16="http://schemas.microsoft.com/office/drawing/2014/main" id="{B135C0E8-68E2-4F1F-9BC6-AE8FF0922BCC}"/>
               </a:ext>
             </a:extLst>
           </p:cNvPr>
@@ -1214,7 +1214,7 @@
           <p:cNvPr id="3" name="">
             <a:extLst xmlns:a="http://schemas.openxmlformats.org/drawingml/2006/main">
               <a:ext uri="{FF2B5EF4-FFF2-40B4-BE49-F238E27FC236}">
-                <a16:creationId xmlns:a16="http://schemas.microsoft.com/office/drawing/2014/main" id="{78845839-7415-4AF0-B9C5-C3DB5627F071}"/>
+                <a16:creationId xmlns:a16="http://schemas.microsoft.com/office/drawing/2014/main" id="{2CCE102D-7A1D-4187-957A-0E37F2862595}"/>
               </a:ext>
             </a:extLst>
           </p:cNvPr>
@@ -1247,7 +1247,7 @@
           <p:cNvPr id="4" name="">
             <a:extLst xmlns:a="http://schemas.openxmlformats.org/drawingml/2006/main">
               <a:ext uri="{FF2B5EF4-FFF2-40B4-BE49-F238E27FC236}">
-                <a16:creationId xmlns:a16="http://schemas.microsoft.com/office/drawing/2014/main" id="{DEA2FFD7-691A-44A2-9932-FC9127182925}"/>
+                <a16:creationId xmlns:a16="http://schemas.microsoft.com/office/drawing/2014/main" id="{EADC4432-D9F7-4669-8B76-CD0DAFFF807E}"/>
               </a:ext>
             </a:extLst>
           </p:cNvPr>
@@ -1280,7 +1280,7 @@
           <p:cNvPr id="5" name="">
             <a:extLst xmlns:a="http://schemas.openxmlformats.org/drawingml/2006/main">
               <a:ext uri="{FF2B5EF4-FFF2-40B4-BE49-F238E27FC236}">
-                <a16:creationId xmlns:a16="http://schemas.microsoft.com/office/drawing/2014/main" id="{78999D2A-68C9-43D1-AE28-D6ECA5F6CB68}"/>
+                <a16:creationId xmlns:a16="http://schemas.microsoft.com/office/drawing/2014/main" id="{09716034-84AD-4028-A4C0-39BC80EEEDE4}"/>
               </a:ext>
             </a:extLst>
           </p:cNvPr>
@@ -1344,7 +1344,7 @@
           <p:cNvPr id="6" name="">
             <a:extLst xmlns:a="http://schemas.openxmlformats.org/drawingml/2006/main">
               <a:ext uri="{FF2B5EF4-FFF2-40B4-BE49-F238E27FC236}">
-                <a16:creationId xmlns:a16="http://schemas.microsoft.com/office/drawing/2014/main" id="{5F647150-5753-438A-AFE0-15E3F1C4F5D7}"/>
+                <a16:creationId xmlns:a16="http://schemas.microsoft.com/office/drawing/2014/main" id="{FC02A4C7-9E84-49EF-B9D7-E490A1E8A927}"/>
               </a:ext>
             </a:extLst>
           </p:cNvPr>
@@ -1377,7 +1377,7 @@
           <p:cNvPr id="7" name="">
             <a:extLst xmlns:a="http://schemas.openxmlformats.org/drawingml/2006/main">
               <a:ext uri="{FF2B5EF4-FFF2-40B4-BE49-F238E27FC236}">
-                <a16:creationId xmlns:a16="http://schemas.microsoft.com/office/drawing/2014/main" id="{F9A69B43-6965-437A-A687-59C615315827}"/>
+                <a16:creationId xmlns:a16="http://schemas.microsoft.com/office/drawing/2014/main" id="{12328275-6D33-4C91-8B83-FCFCF5A72F57}"/>
               </a:ext>
             </a:extLst>
           </p:cNvPr>
@@ -1410,7 +1410,7 @@
           <p:cNvPr id="8" name="">
             <a:extLst xmlns:a="http://schemas.openxmlformats.org/drawingml/2006/main">
               <a:ext uri="{FF2B5EF4-FFF2-40B4-BE49-F238E27FC236}">
-                <a16:creationId xmlns:a16="http://schemas.microsoft.com/office/drawing/2014/main" id="{ADC76DA7-86EE-44BC-A841-E2C71202E49A}"/>
+                <a16:creationId xmlns:a16="http://schemas.microsoft.com/office/drawing/2014/main" id="{36E3A58E-9E0B-4CD3-A322-D32AEC2784C9}"/>
               </a:ext>
             </a:extLst>
           </p:cNvPr>
@@ -1474,7 +1474,7 @@
           <p:cNvPr id="9" name="">
             <a:extLst xmlns:a="http://schemas.openxmlformats.org/drawingml/2006/main">
               <a:ext uri="{FF2B5EF4-FFF2-40B4-BE49-F238E27FC236}">
-                <a16:creationId xmlns:a16="http://schemas.microsoft.com/office/drawing/2014/main" id="{70BA5DB4-09B2-4D9C-B833-B6764A57828D}"/>
+                <a16:creationId xmlns:a16="http://schemas.microsoft.com/office/drawing/2014/main" id="{44BF5955-47A2-4234-9F7A-04EC4C4A60E2}"/>
               </a:ext>
             </a:extLst>
           </p:cNvPr>
@@ -1507,7 +1507,7 @@
           <p:cNvPr id="10" name="">
             <a:extLst xmlns:a="http://schemas.openxmlformats.org/drawingml/2006/main">
               <a:ext uri="{FF2B5EF4-FFF2-40B4-BE49-F238E27FC236}">
-                <a16:creationId xmlns:a16="http://schemas.microsoft.com/office/drawing/2014/main" id="{66EDDC96-EF58-4EE0-8BF1-DE31089139F3}"/>
+                <a16:creationId xmlns:a16="http://schemas.microsoft.com/office/drawing/2014/main" id="{E89EFAEA-A97D-4753-94B8-5D2B91F7DF96}"/>
               </a:ext>
             </a:extLst>
           </p:cNvPr>
@@ -1540,7 +1540,7 @@
           <p:cNvPr id="11" name="">
             <a:extLst xmlns:a="http://schemas.openxmlformats.org/drawingml/2006/main">
               <a:ext uri="{FF2B5EF4-FFF2-40B4-BE49-F238E27FC236}">
-                <a16:creationId xmlns:a16="http://schemas.microsoft.com/office/drawing/2014/main" id="{EFB948C1-D85B-4FDE-9E34-79CC4ED54661}"/>
+                <a16:creationId xmlns:a16="http://schemas.microsoft.com/office/drawing/2014/main" id="{0EDE3A81-6B3A-4542-9284-81F759EC8290}"/>
               </a:ext>
             </a:extLst>
           </p:cNvPr>
@@ -1604,7 +1604,7 @@
           <p:cNvPr id="12" name="">
             <a:extLst xmlns:a="http://schemas.openxmlformats.org/drawingml/2006/main">
               <a:ext uri="{FF2B5EF4-FFF2-40B4-BE49-F238E27FC236}">
-                <a16:creationId xmlns:a16="http://schemas.microsoft.com/office/drawing/2014/main" id="{881FA403-48A1-4291-AE9C-88644CB877D9}"/>
+                <a16:creationId xmlns:a16="http://schemas.microsoft.com/office/drawing/2014/main" id="{FE49C16B-70CB-4992-A2CE-8507BCF2A62E}"/>
               </a:ext>
             </a:extLst>
           </p:cNvPr>
@@ -1668,7 +1668,7 @@
           <p:cNvPr id="13" name="">
             <a:extLst xmlns:a="http://schemas.openxmlformats.org/drawingml/2006/main">
               <a:ext uri="{FF2B5EF4-FFF2-40B4-BE49-F238E27FC236}">
-                <a16:creationId xmlns:a16="http://schemas.microsoft.com/office/drawing/2014/main" id="{0C1843E7-03A9-450E-914E-0A7737AFECF7}"/>
+                <a16:creationId xmlns:a16="http://schemas.microsoft.com/office/drawing/2014/main" id="{49D5A625-30CA-491A-BCC7-3776135B87F0}"/>
               </a:ext>
             </a:extLst>
           </p:cNvPr>
@@ -1701,7 +1701,7 @@
           <p:cNvPr id="14" name="">
             <a:extLst xmlns:a="http://schemas.openxmlformats.org/drawingml/2006/main">
               <a:ext uri="{FF2B5EF4-FFF2-40B4-BE49-F238E27FC236}">
-                <a16:creationId xmlns:a16="http://schemas.microsoft.com/office/drawing/2014/main" id="{A88CD078-7110-4D31-B314-5C460171CE8D}"/>
+                <a16:creationId xmlns:a16="http://schemas.microsoft.com/office/drawing/2014/main" id="{CF7028EF-2114-4D87-8E72-E0923F300B2C}"/>
               </a:ext>
             </a:extLst>
           </p:cNvPr>
@@ -1734,7 +1734,7 @@
           <p:cNvPr id="15" name="">
             <a:extLst xmlns:a="http://schemas.openxmlformats.org/drawingml/2006/main">
               <a:ext uri="{FF2B5EF4-FFF2-40B4-BE49-F238E27FC236}">
-                <a16:creationId xmlns:a16="http://schemas.microsoft.com/office/drawing/2014/main" id="{04C257A2-3E7D-40AE-8C49-870FB7F30FC5}"/>
+                <a16:creationId xmlns:a16="http://schemas.microsoft.com/office/drawing/2014/main" id="{2FBF251F-890F-49F0-8E62-C034A71CF492}"/>
               </a:ext>
             </a:extLst>
           </p:cNvPr>
@@ -1798,7 +1798,7 @@
           <p:cNvPr id="16" name="">
             <a:extLst xmlns:a="http://schemas.openxmlformats.org/drawingml/2006/main">
               <a:ext uri="{FF2B5EF4-FFF2-40B4-BE49-F238E27FC236}">
-                <a16:creationId xmlns:a16="http://schemas.microsoft.com/office/drawing/2014/main" id="{71F9DF54-1422-4744-BE51-A08334A86EEF}"/>
+                <a16:creationId xmlns:a16="http://schemas.microsoft.com/office/drawing/2014/main" id="{75BEBD12-DDCC-4F48-BDCD-36D7453B56D2}"/>
               </a:ext>
             </a:extLst>
           </p:cNvPr>
@@ -1862,7 +1862,7 @@
           <p:cNvPr id="17" name="">
             <a:extLst xmlns:a="http://schemas.openxmlformats.org/drawingml/2006/main">
               <a:ext uri="{FF2B5EF4-FFF2-40B4-BE49-F238E27FC236}">
-                <a16:creationId xmlns:a16="http://schemas.microsoft.com/office/drawing/2014/main" id="{C86F8EBF-F744-4BFC-8CC1-4E41BDA9F1FD}"/>
+                <a16:creationId xmlns:a16="http://schemas.microsoft.com/office/drawing/2014/main" id="{C849A828-6D3B-40CA-87F4-2C3D380CED68}"/>
               </a:ext>
             </a:extLst>
           </p:cNvPr>
@@ -1895,7 +1895,7 @@
           <p:cNvPr id="18" name="">
             <a:extLst xmlns:a="http://schemas.openxmlformats.org/drawingml/2006/main">
               <a:ext uri="{FF2B5EF4-FFF2-40B4-BE49-F238E27FC236}">
-                <a16:creationId xmlns:a16="http://schemas.microsoft.com/office/drawing/2014/main" id="{1BC04280-96B1-428A-8A2E-540A08065833}"/>
+                <a16:creationId xmlns:a16="http://schemas.microsoft.com/office/drawing/2014/main" id="{AE86DC19-D18F-41F0-AE50-810A98AF2FB5}"/>
               </a:ext>
             </a:extLst>
           </p:cNvPr>
@@ -1928,7 +1928,7 @@
           <p:cNvPr id="19" name="">
             <a:extLst xmlns:a="http://schemas.openxmlformats.org/drawingml/2006/main">
               <a:ext uri="{FF2B5EF4-FFF2-40B4-BE49-F238E27FC236}">
-                <a16:creationId xmlns:a16="http://schemas.microsoft.com/office/drawing/2014/main" id="{7C7D96AB-F2A5-472E-8475-09638A0FD6DB}"/>
+                <a16:creationId xmlns:a16="http://schemas.microsoft.com/office/drawing/2014/main" id="{8ABA5DE0-F621-4BBA-A676-FCAD21A2C146}"/>
               </a:ext>
             </a:extLst>
           </p:cNvPr>
@@ -1992,7 +1992,7 @@
           <p:cNvPr id="20" name="">
             <a:extLst xmlns:a="http://schemas.openxmlformats.org/drawingml/2006/main">
               <a:ext uri="{FF2B5EF4-FFF2-40B4-BE49-F238E27FC236}">
-                <a16:creationId xmlns:a16="http://schemas.microsoft.com/office/drawing/2014/main" id="{E219FA20-F059-4C0B-9B6A-A86A6849A324}"/>
+                <a16:creationId xmlns:a16="http://schemas.microsoft.com/office/drawing/2014/main" id="{9494EF4E-1346-4A2E-B866-78D5C57DC4F9}"/>
               </a:ext>
             </a:extLst>
           </p:cNvPr>
@@ -2056,7 +2056,7 @@
           <p:cNvPr id="21" name="">
             <a:extLst xmlns:a="http://schemas.openxmlformats.org/drawingml/2006/main">
               <a:ext uri="{FF2B5EF4-FFF2-40B4-BE49-F238E27FC236}">
-                <a16:creationId xmlns:a16="http://schemas.microsoft.com/office/drawing/2014/main" id="{B6A7C52E-A045-4C51-977B-5E2A6B3E06F4}"/>
+                <a16:creationId xmlns:a16="http://schemas.microsoft.com/office/drawing/2014/main" id="{CF4F52E8-4483-4DE6-BD48-50960AA1BDB3}"/>
               </a:ext>
             </a:extLst>
           </p:cNvPr>
@@ -2089,7 +2089,7 @@
           <p:cNvPr id="22" name="">
             <a:extLst xmlns:a="http://schemas.openxmlformats.org/drawingml/2006/main">
               <a:ext uri="{FF2B5EF4-FFF2-40B4-BE49-F238E27FC236}">
-                <a16:creationId xmlns:a16="http://schemas.microsoft.com/office/drawing/2014/main" id="{697BC52A-EDB8-4CA2-B382-183DE416938D}"/>
+                <a16:creationId xmlns:a16="http://schemas.microsoft.com/office/drawing/2014/main" id="{E29CD054-2D66-4A2A-85A2-B0F38A0C032E}"/>
               </a:ext>
             </a:extLst>
           </p:cNvPr>
@@ -2122,7 +2122,7 @@
           <p:cNvPr id="23" name="">
             <a:extLst xmlns:a="http://schemas.openxmlformats.org/drawingml/2006/main">
               <a:ext uri="{FF2B5EF4-FFF2-40B4-BE49-F238E27FC236}">
-                <a16:creationId xmlns:a16="http://schemas.microsoft.com/office/drawing/2014/main" id="{02643662-FC73-43B4-9591-008D8088CDA8}"/>
+                <a16:creationId xmlns:a16="http://schemas.microsoft.com/office/drawing/2014/main" id="{51221B6A-D09C-452A-88FB-D6AA7F5C5117}"/>
               </a:ext>
             </a:extLst>
           </p:cNvPr>
@@ -2186,7 +2186,7 @@
           <p:cNvPr id="24" name="">
             <a:extLst xmlns:a="http://schemas.openxmlformats.org/drawingml/2006/main">
               <a:ext uri="{FF2B5EF4-FFF2-40B4-BE49-F238E27FC236}">
-                <a16:creationId xmlns:a16="http://schemas.microsoft.com/office/drawing/2014/main" id="{380AAF37-0964-4D07-A340-32E562848B36}"/>
+                <a16:creationId xmlns:a16="http://schemas.microsoft.com/office/drawing/2014/main" id="{D9E1F727-EA43-4770-A275-EA507A6A96B7}"/>
               </a:ext>
             </a:extLst>
           </p:cNvPr>
@@ -2250,7 +2250,7 @@
           <p:cNvPr id="25" name="">
             <a:extLst xmlns:a="http://schemas.openxmlformats.org/drawingml/2006/main">
               <a:ext uri="{FF2B5EF4-FFF2-40B4-BE49-F238E27FC236}">
-                <a16:creationId xmlns:a16="http://schemas.microsoft.com/office/drawing/2014/main" id="{3D8A0932-0F7C-4BA5-9DC5-F5C3DDE22D33}"/>
+                <a16:creationId xmlns:a16="http://schemas.microsoft.com/office/drawing/2014/main" id="{87577BDA-1420-44D3-8E8B-C2DD2F6C1468}"/>
               </a:ext>
             </a:extLst>
           </p:cNvPr>
@@ -2283,7 +2283,7 @@
           <p:cNvPr id="26" name="">
             <a:extLst xmlns:a="http://schemas.openxmlformats.org/drawingml/2006/main">
               <a:ext uri="{FF2B5EF4-FFF2-40B4-BE49-F238E27FC236}">
-                <a16:creationId xmlns:a16="http://schemas.microsoft.com/office/drawing/2014/main" id="{9271ADEA-60B6-4BA0-8D97-5769E880D9E3}"/>
+                <a16:creationId xmlns:a16="http://schemas.microsoft.com/office/drawing/2014/main" id="{25036067-277C-4F38-A040-5F2DEA30AC32}"/>
               </a:ext>
             </a:extLst>
           </p:cNvPr>
@@ -2316,7 +2316,7 @@
           <p:cNvPr id="27" name="">
             <a:extLst xmlns:a="http://schemas.openxmlformats.org/drawingml/2006/main">
               <a:ext uri="{FF2B5EF4-FFF2-40B4-BE49-F238E27FC236}">
-                <a16:creationId xmlns:a16="http://schemas.microsoft.com/office/drawing/2014/main" id="{C8230F5D-616B-450F-A050-73E75378CA66}"/>
+                <a16:creationId xmlns:a16="http://schemas.microsoft.com/office/drawing/2014/main" id="{30FF1512-CB6F-49B2-8903-7F91A718FF6F}"/>
               </a:ext>
             </a:extLst>
           </p:cNvPr>
@@ -2380,7 +2380,7 @@
           <p:cNvPr id="28" name="">
             <a:extLst xmlns:a="http://schemas.openxmlformats.org/drawingml/2006/main">
               <a:ext uri="{FF2B5EF4-FFF2-40B4-BE49-F238E27FC236}">
-                <a16:creationId xmlns:a16="http://schemas.microsoft.com/office/drawing/2014/main" id="{1BA42903-850E-4ED4-A5A4-D20ECBA590F7}"/>
+                <a16:creationId xmlns:a16="http://schemas.microsoft.com/office/drawing/2014/main" id="{96BD1152-8E04-486D-9C98-CDE1E44BEB72}"/>
               </a:ext>
             </a:extLst>
           </p:cNvPr>
@@ -2444,7 +2444,7 @@
           <p:cNvPr id="29" name="">
             <a:extLst xmlns:a="http://schemas.openxmlformats.org/drawingml/2006/main">
               <a:ext uri="{FF2B5EF4-FFF2-40B4-BE49-F238E27FC236}">
-                <a16:creationId xmlns:a16="http://schemas.microsoft.com/office/drawing/2014/main" id="{BB6DC29C-45E4-4149-AB49-108AED577EFC}"/>
+                <a16:creationId xmlns:a16="http://schemas.microsoft.com/office/drawing/2014/main" id="{48D1170E-D5F1-4524-9483-1AD72EEE7B62}"/>
               </a:ext>
             </a:extLst>
           </p:cNvPr>
@@ -2508,7 +2508,7 @@
           <p:cNvPr id="30" name="">
             <a:extLst xmlns:a="http://schemas.openxmlformats.org/drawingml/2006/main">
               <a:ext uri="{FF2B5EF4-FFF2-40B4-BE49-F238E27FC236}">
-                <a16:creationId xmlns:a16="http://schemas.microsoft.com/office/drawing/2014/main" id="{C4CB9463-9B04-4EFA-848B-85924A6703DB}"/>
+                <a16:creationId xmlns:a16="http://schemas.microsoft.com/office/drawing/2014/main" id="{63BA71C0-7E31-4CC1-B373-84A8C51A553B}"/>
               </a:ext>
             </a:extLst>
           </p:cNvPr>
@@ -2572,7 +2572,7 @@
           <p:cNvPr id="31" name="">
             <a:extLst xmlns:a="http://schemas.openxmlformats.org/drawingml/2006/main">
               <a:ext uri="{FF2B5EF4-FFF2-40B4-BE49-F238E27FC236}">
-                <a16:creationId xmlns:a16="http://schemas.microsoft.com/office/drawing/2014/main" id="{574261E4-9E5D-48E8-B1CE-3451C0ABED81}"/>
+                <a16:creationId xmlns:a16="http://schemas.microsoft.com/office/drawing/2014/main" id="{8456E6D1-9CEE-4785-A61D-3B9FAF895CAE}"/>
               </a:ext>
             </a:extLst>
           </p:cNvPr>
@@ -2636,7 +2636,7 @@
           <p:cNvPr id="32" name="">
             <a:extLst xmlns:a="http://schemas.openxmlformats.org/drawingml/2006/main">
               <a:ext uri="{FF2B5EF4-FFF2-40B4-BE49-F238E27FC236}">
-                <a16:creationId xmlns:a16="http://schemas.microsoft.com/office/drawing/2014/main" id="{872A6BFB-87FD-4C1D-AD02-CED2E4E82B3D}"/>
+                <a16:creationId xmlns:a16="http://schemas.microsoft.com/office/drawing/2014/main" id="{163E994D-181F-4349-9214-B7557466CA67}"/>
               </a:ext>
             </a:extLst>
           </p:cNvPr>
@@ -2700,7 +2700,7 @@
           <p:cNvPr id="33" name="">
             <a:extLst xmlns:a="http://schemas.openxmlformats.org/drawingml/2006/main">
               <a:ext uri="{FF2B5EF4-FFF2-40B4-BE49-F238E27FC236}">
-                <a16:creationId xmlns:a16="http://schemas.microsoft.com/office/drawing/2014/main" id="{2E982FAD-8252-430D-BB8B-6505806989D3}"/>
+                <a16:creationId xmlns:a16="http://schemas.microsoft.com/office/drawing/2014/main" id="{4D341407-C308-441E-859A-6F9F67600642}"/>
               </a:ext>
             </a:extLst>
           </p:cNvPr>
@@ -2764,7 +2764,7 @@
           <p:cNvPr id="34" name="">
             <a:extLst xmlns:a="http://schemas.openxmlformats.org/drawingml/2006/main">
               <a:ext uri="{FF2B5EF4-FFF2-40B4-BE49-F238E27FC236}">
-                <a16:creationId xmlns:a16="http://schemas.microsoft.com/office/drawing/2014/main" id="{8104F485-EF91-440A-A264-0C2B6CB93A14}"/>
+                <a16:creationId xmlns:a16="http://schemas.microsoft.com/office/drawing/2014/main" id="{39DF679B-B3E7-495B-BD50-792F009400C6}"/>
               </a:ext>
             </a:extLst>
           </p:cNvPr>
@@ -2828,7 +2828,7 @@
           <p:cNvPr id="35" name="">
             <a:extLst xmlns:a="http://schemas.openxmlformats.org/drawingml/2006/main">
               <a:ext uri="{FF2B5EF4-FFF2-40B4-BE49-F238E27FC236}">
-                <a16:creationId xmlns:a16="http://schemas.microsoft.com/office/drawing/2014/main" id="{A802FDAB-B9D3-4E6C-BE4D-7291A1304D4D}"/>
+                <a16:creationId xmlns:a16="http://schemas.microsoft.com/office/drawing/2014/main" id="{0D0AF458-B845-44A4-832F-FB5B152ED58D}"/>
               </a:ext>
             </a:extLst>
           </p:cNvPr>
@@ -2861,7 +2861,7 @@
           <p:cNvPr id="36" name="">
             <a:extLst xmlns:a="http://schemas.openxmlformats.org/drawingml/2006/main">
               <a:ext uri="{FF2B5EF4-FFF2-40B4-BE49-F238E27FC236}">
-                <a16:creationId xmlns:a16="http://schemas.microsoft.com/office/drawing/2014/main" id="{B98EB944-C82D-4FD0-8616-E50B400B8A89}"/>
+                <a16:creationId xmlns:a16="http://schemas.microsoft.com/office/drawing/2014/main" id="{3EE18AAE-A6E0-4663-BB9A-B153D2302006}"/>
               </a:ext>
             </a:extLst>
           </p:cNvPr>
@@ -2925,7 +2925,7 @@
           <p:cNvPr id="37" name="">
             <a:extLst xmlns:a="http://schemas.openxmlformats.org/drawingml/2006/main">
               <a:ext uri="{FF2B5EF4-FFF2-40B4-BE49-F238E27FC236}">
-                <a16:creationId xmlns:a16="http://schemas.microsoft.com/office/drawing/2014/main" id="{22B0B251-FD05-4723-ADB4-1EB1CF49EE91}"/>
+                <a16:creationId xmlns:a16="http://schemas.microsoft.com/office/drawing/2014/main" id="{B03F3507-E40E-468A-B873-38ED4106CF78}"/>
               </a:ext>
             </a:extLst>
           </p:cNvPr>
@@ -2958,7 +2958,7 @@
           <p:cNvPr id="38" name="">
             <a:extLst xmlns:a="http://schemas.openxmlformats.org/drawingml/2006/main">
               <a:ext uri="{FF2B5EF4-FFF2-40B4-BE49-F238E27FC236}">
-                <a16:creationId xmlns:a16="http://schemas.microsoft.com/office/drawing/2014/main" id="{8E04BC3C-4F74-4C61-B2FC-CB286DB5F436}"/>
+                <a16:creationId xmlns:a16="http://schemas.microsoft.com/office/drawing/2014/main" id="{46F3F205-1512-40C4-9DB3-931D59435662}"/>
               </a:ext>
             </a:extLst>
           </p:cNvPr>
@@ -2991,7 +2991,7 @@
           <p:cNvPr id="39" name="">
             <a:extLst xmlns:a="http://schemas.openxmlformats.org/drawingml/2006/main">
               <a:ext uri="{FF2B5EF4-FFF2-40B4-BE49-F238E27FC236}">
-                <a16:creationId xmlns:a16="http://schemas.microsoft.com/office/drawing/2014/main" id="{73DF7723-CDE9-4D6F-AB35-B00F0EA464DB}"/>
+                <a16:creationId xmlns:a16="http://schemas.microsoft.com/office/drawing/2014/main" id="{8D37F5A0-2417-4DA4-96A1-773F60A2D2EC}"/>
               </a:ext>
             </a:extLst>
           </p:cNvPr>
@@ -3055,7 +3055,7 @@
           <p:cNvPr id="40" name="">
             <a:extLst xmlns:a="http://schemas.openxmlformats.org/drawingml/2006/main">
               <a:ext uri="{FF2B5EF4-FFF2-40B4-BE49-F238E27FC236}">
-                <a16:creationId xmlns:a16="http://schemas.microsoft.com/office/drawing/2014/main" id="{94F2EF8E-F389-40CB-AE1B-7D48E5835BE5}"/>
+                <a16:creationId xmlns:a16="http://schemas.microsoft.com/office/drawing/2014/main" id="{0B08B0FC-D843-4E02-A503-AF560CD7ACFC}"/>
               </a:ext>
             </a:extLst>
           </p:cNvPr>
@@ -3088,7 +3088,7 @@
           <p:cNvPr id="41" name="">
             <a:extLst xmlns:a="http://schemas.openxmlformats.org/drawingml/2006/main">
               <a:ext uri="{FF2B5EF4-FFF2-40B4-BE49-F238E27FC236}">
-                <a16:creationId xmlns:a16="http://schemas.microsoft.com/office/drawing/2014/main" id="{97D6EB5A-B7C8-401D-860B-90BC1AA085CD}"/>
+                <a16:creationId xmlns:a16="http://schemas.microsoft.com/office/drawing/2014/main" id="{62BBFCAD-0DEF-45C9-BEEC-47C1990B3BF0}"/>
               </a:ext>
             </a:extLst>
           </p:cNvPr>
@@ -3152,7 +3152,7 @@
           <p:cNvPr id="42" name="">
             <a:extLst xmlns:a="http://schemas.openxmlformats.org/drawingml/2006/main">
               <a:ext uri="{FF2B5EF4-FFF2-40B4-BE49-F238E27FC236}">
-                <a16:creationId xmlns:a16="http://schemas.microsoft.com/office/drawing/2014/main" id="{E10E59E5-4C34-4E3C-9B83-677B75E44D4C}"/>
+                <a16:creationId xmlns:a16="http://schemas.microsoft.com/office/drawing/2014/main" id="{228BE421-50B6-45B8-AE5C-BD0605CE8C4F}"/>
               </a:ext>
             </a:extLst>
           </p:cNvPr>
@@ -3185,7 +3185,7 @@
           <p:cNvPr id="43" name="">
             <a:extLst xmlns:a="http://schemas.openxmlformats.org/drawingml/2006/main">
               <a:ext uri="{FF2B5EF4-FFF2-40B4-BE49-F238E27FC236}">
-                <a16:creationId xmlns:a16="http://schemas.microsoft.com/office/drawing/2014/main" id="{34643725-E38F-4550-9070-7CC0F3902BAD}"/>
+                <a16:creationId xmlns:a16="http://schemas.microsoft.com/office/drawing/2014/main" id="{BB51D294-2B42-4D8F-B69C-48200D79066B}"/>
               </a:ext>
             </a:extLst>
           </p:cNvPr>
@@ -3249,7 +3249,7 @@
           <p:cNvPr id="44" name="">
             <a:extLst xmlns:a="http://schemas.openxmlformats.org/drawingml/2006/main">
               <a:ext uri="{FF2B5EF4-FFF2-40B4-BE49-F238E27FC236}">
-                <a16:creationId xmlns:a16="http://schemas.microsoft.com/office/drawing/2014/main" id="{9A8EF47E-2874-4AAD-9C0B-673C6FD08884}"/>
+                <a16:creationId xmlns:a16="http://schemas.microsoft.com/office/drawing/2014/main" id="{7855520E-E882-47EF-83B6-7A7B9501E001}"/>
               </a:ext>
             </a:extLst>
           </p:cNvPr>
@@ -3282,7 +3282,7 @@
           <p:cNvPr id="45" name="">
             <a:extLst xmlns:a="http://schemas.openxmlformats.org/drawingml/2006/main">
               <a:ext uri="{FF2B5EF4-FFF2-40B4-BE49-F238E27FC236}">
-                <a16:creationId xmlns:a16="http://schemas.microsoft.com/office/drawing/2014/main" id="{9941E6E0-2A26-475C-9516-055218BECEFB}"/>
+                <a16:creationId xmlns:a16="http://schemas.microsoft.com/office/drawing/2014/main" id="{BBF747F9-AB60-47B6-99EF-4F8BEA42556F}"/>
               </a:ext>
             </a:extLst>
           </p:cNvPr>
@@ -3346,7 +3346,7 @@
           <p:cNvPr id="46" name="">
             <a:extLst xmlns:a="http://schemas.openxmlformats.org/drawingml/2006/main">
               <a:ext uri="{FF2B5EF4-FFF2-40B4-BE49-F238E27FC236}">
-                <a16:creationId xmlns:a16="http://schemas.microsoft.com/office/drawing/2014/main" id="{946CA79B-D661-4972-AE49-E7C885E87C21}"/>
+                <a16:creationId xmlns:a16="http://schemas.microsoft.com/office/drawing/2014/main" id="{5047E0B9-FB6C-4A20-AAEA-3C5F9FD5D977}"/>
               </a:ext>
             </a:extLst>
           </p:cNvPr>
@@ -3379,7 +3379,7 @@
           <p:cNvPr id="47" name="">
             <a:extLst xmlns:a="http://schemas.openxmlformats.org/drawingml/2006/main">
               <a:ext uri="{FF2B5EF4-FFF2-40B4-BE49-F238E27FC236}">
-                <a16:creationId xmlns:a16="http://schemas.microsoft.com/office/drawing/2014/main" id="{232B309A-1DF4-4969-988F-84EE9AD49DC0}"/>
+                <a16:creationId xmlns:a16="http://schemas.microsoft.com/office/drawing/2014/main" id="{7DE253F3-7158-4C93-A917-58641AFBA731}"/>
               </a:ext>
             </a:extLst>
           </p:cNvPr>
@@ -3443,7 +3443,7 @@
           <p:cNvPr id="48" name="">
             <a:extLst xmlns:a="http://schemas.openxmlformats.org/drawingml/2006/main">
               <a:ext uri="{FF2B5EF4-FFF2-40B4-BE49-F238E27FC236}">
-                <a16:creationId xmlns:a16="http://schemas.microsoft.com/office/drawing/2014/main" id="{BD5B1D4B-240B-42D3-AD0C-010D4E09677E}"/>
+                <a16:creationId xmlns:a16="http://schemas.microsoft.com/office/drawing/2014/main" id="{21A2E979-DA6A-4E35-994B-1865F8297CF0}"/>
               </a:ext>
             </a:extLst>
           </p:cNvPr>
@@ -3476,7 +3476,7 @@
           <p:cNvPr id="49" name="">
             <a:extLst xmlns:a="http://schemas.openxmlformats.org/drawingml/2006/main">
               <a:ext uri="{FF2B5EF4-FFF2-40B4-BE49-F238E27FC236}">
-                <a16:creationId xmlns:a16="http://schemas.microsoft.com/office/drawing/2014/main" id="{EA8F389A-8668-4018-B730-ED044DC5F879}"/>
+                <a16:creationId xmlns:a16="http://schemas.microsoft.com/office/drawing/2014/main" id="{6FB9AB7B-0CEF-45E5-BFAE-E93B8E38055F}"/>
               </a:ext>
             </a:extLst>
           </p:cNvPr>
@@ -3540,7 +3540,7 @@
           <p:cNvPr id="50" name="">
             <a:extLst xmlns:a="http://schemas.openxmlformats.org/drawingml/2006/main">
               <a:ext uri="{FF2B5EF4-FFF2-40B4-BE49-F238E27FC236}">
-                <a16:creationId xmlns:a16="http://schemas.microsoft.com/office/drawing/2014/main" id="{D4BCDD69-2002-472A-A770-78BA803D41FC}"/>
+                <a16:creationId xmlns:a16="http://schemas.microsoft.com/office/drawing/2014/main" id="{309E1C51-93EA-46F5-A0F4-5AD2613E48C9}"/>
               </a:ext>
             </a:extLst>
           </p:cNvPr>
@@ -3573,7 +3573,7 @@
           <p:cNvPr id="51" name="">
             <a:extLst xmlns:a="http://schemas.openxmlformats.org/drawingml/2006/main">
               <a:ext uri="{FF2B5EF4-FFF2-40B4-BE49-F238E27FC236}">
-                <a16:creationId xmlns:a16="http://schemas.microsoft.com/office/drawing/2014/main" id="{D504E896-D934-4E50-A094-1F144414AE81}"/>
+                <a16:creationId xmlns:a16="http://schemas.microsoft.com/office/drawing/2014/main" id="{E4AF3F4E-F781-4DCF-BC04-E36D9D9D077B}"/>
               </a:ext>
             </a:extLst>
           </p:cNvPr>
@@ -3637,7 +3637,7 @@
           <p:cNvPr id="52" name="">
             <a:extLst xmlns:a="http://schemas.openxmlformats.org/drawingml/2006/main">
               <a:ext uri="{FF2B5EF4-FFF2-40B4-BE49-F238E27FC236}">
-                <a16:creationId xmlns:a16="http://schemas.microsoft.com/office/drawing/2014/main" id="{AD608697-4C14-4B8C-901A-0ED8BEFC2FBA}"/>
+                <a16:creationId xmlns:a16="http://schemas.microsoft.com/office/drawing/2014/main" id="{B797B60F-0D64-4BE3-B0C1-0D1F3029A24F}"/>
               </a:ext>
             </a:extLst>
           </p:cNvPr>
@@ -3670,7 +3670,7 @@
           <p:cNvPr id="53" name="">
             <a:extLst xmlns:a="http://schemas.openxmlformats.org/drawingml/2006/main">
               <a:ext uri="{FF2B5EF4-FFF2-40B4-BE49-F238E27FC236}">
-                <a16:creationId xmlns:a16="http://schemas.microsoft.com/office/drawing/2014/main" id="{3A3A69DA-9BA5-4FF6-AA7A-332D8454114B}"/>
+                <a16:creationId xmlns:a16="http://schemas.microsoft.com/office/drawing/2014/main" id="{596FFCF0-0EA2-4F59-A131-91ABFE0F7C5B}"/>
               </a:ext>
             </a:extLst>
           </p:cNvPr>
@@ -3734,7 +3734,7 @@
           <p:cNvPr id="54" name="">
             <a:extLst xmlns:a="http://schemas.openxmlformats.org/drawingml/2006/main">
               <a:ext uri="{FF2B5EF4-FFF2-40B4-BE49-F238E27FC236}">
-                <a16:creationId xmlns:a16="http://schemas.microsoft.com/office/drawing/2014/main" id="{F6C978CE-3AD6-49DC-9E55-FC81AC95F2E9}"/>
+                <a16:creationId xmlns:a16="http://schemas.microsoft.com/office/drawing/2014/main" id="{7091789F-EF95-4701-8CB1-014F09B14B58}"/>
               </a:ext>
             </a:extLst>
           </p:cNvPr>
@@ -3767,7 +3767,7 @@
           <p:cNvPr id="55" name="">
             <a:extLst xmlns:a="http://schemas.openxmlformats.org/drawingml/2006/main">
               <a:ext uri="{FF2B5EF4-FFF2-40B4-BE49-F238E27FC236}">
-                <a16:creationId xmlns:a16="http://schemas.microsoft.com/office/drawing/2014/main" id="{9EEEF4E6-5B41-4AFC-8C9C-9E1F7417BD04}"/>
+                <a16:creationId xmlns:a16="http://schemas.microsoft.com/office/drawing/2014/main" id="{A5F8AF9F-F2D6-4951-A1E8-5CA6424432AF}"/>
               </a:ext>
             </a:extLst>
           </p:cNvPr>
@@ -3831,7 +3831,7 @@
           <p:cNvPr id="56" name="">
             <a:extLst xmlns:a="http://schemas.openxmlformats.org/drawingml/2006/main">
               <a:ext uri="{FF2B5EF4-FFF2-40B4-BE49-F238E27FC236}">
-                <a16:creationId xmlns:a16="http://schemas.microsoft.com/office/drawing/2014/main" id="{1FE2AFD8-0502-4751-9ACC-ABA867E0A008}"/>
+                <a16:creationId xmlns:a16="http://schemas.microsoft.com/office/drawing/2014/main" id="{B4D880CA-4404-445A-81A1-CA982E64FE00}"/>
               </a:ext>
             </a:extLst>
           </p:cNvPr>
@@ -3864,7 +3864,7 @@
           <p:cNvPr id="57" name="">
             <a:extLst xmlns:a="http://schemas.openxmlformats.org/drawingml/2006/main">
               <a:ext uri="{FF2B5EF4-FFF2-40B4-BE49-F238E27FC236}">
-                <a16:creationId xmlns:a16="http://schemas.microsoft.com/office/drawing/2014/main" id="{3E756E53-06E7-45A3-B09A-C5FB7282EE48}"/>
+                <a16:creationId xmlns:a16="http://schemas.microsoft.com/office/drawing/2014/main" id="{F36F6820-F1EB-4E50-9E42-2ADFDDBC28FD}"/>
               </a:ext>
             </a:extLst>
           </p:cNvPr>
@@ -3928,7 +3928,7 @@
           <p:cNvPr id="58" name="">
             <a:extLst xmlns:a="http://schemas.openxmlformats.org/drawingml/2006/main">
               <a:ext uri="{FF2B5EF4-FFF2-40B4-BE49-F238E27FC236}">
-                <a16:creationId xmlns:a16="http://schemas.microsoft.com/office/drawing/2014/main" id="{19962BFE-075F-4758-AE9B-01728D904295}"/>
+                <a16:creationId xmlns:a16="http://schemas.microsoft.com/office/drawing/2014/main" id="{1DFF23D0-93BC-4F62-8820-9D1D1CC02DB7}"/>
               </a:ext>
             </a:extLst>
           </p:cNvPr>
@@ -3961,7 +3961,7 @@
           <p:cNvPr id="59" name="">
             <a:extLst xmlns:a="http://schemas.openxmlformats.org/drawingml/2006/main">
               <a:ext uri="{FF2B5EF4-FFF2-40B4-BE49-F238E27FC236}">
-                <a16:creationId xmlns:a16="http://schemas.microsoft.com/office/drawing/2014/main" id="{A373AF2F-F077-4AFD-8223-4975F78CBCF6}"/>
+                <a16:creationId xmlns:a16="http://schemas.microsoft.com/office/drawing/2014/main" id="{3CE6B67D-9111-4525-8FC7-692EDC2D2704}"/>
               </a:ext>
             </a:extLst>
           </p:cNvPr>
@@ -4025,7 +4025,7 @@
           <p:cNvPr id="60" name="">
             <a:extLst xmlns:a="http://schemas.openxmlformats.org/drawingml/2006/main">
               <a:ext uri="{FF2B5EF4-FFF2-40B4-BE49-F238E27FC236}">
-                <a16:creationId xmlns:a16="http://schemas.microsoft.com/office/drawing/2014/main" id="{0F32AE6E-0313-4E5B-AC89-0C5A39D0BAFF}"/>
+                <a16:creationId xmlns:a16="http://schemas.microsoft.com/office/drawing/2014/main" id="{AF1A7623-FE7F-481B-B573-B5CC6305D408}"/>
               </a:ext>
             </a:extLst>
           </p:cNvPr>
@@ -4058,7 +4058,7 @@
           <p:cNvPr id="61" name="">
             <a:extLst xmlns:a="http://schemas.openxmlformats.org/drawingml/2006/main">
               <a:ext uri="{FF2B5EF4-FFF2-40B4-BE49-F238E27FC236}">
-                <a16:creationId xmlns:a16="http://schemas.microsoft.com/office/drawing/2014/main" id="{5135713A-2EC1-4097-A7D6-FEED86E26260}"/>
+                <a16:creationId xmlns:a16="http://schemas.microsoft.com/office/drawing/2014/main" id="{40480731-5175-4767-933C-FE6363A37D2B}"/>
               </a:ext>
             </a:extLst>
           </p:cNvPr>
@@ -4122,7 +4122,7 @@
           <p:cNvPr id="62" name="">
             <a:extLst xmlns:a="http://schemas.openxmlformats.org/drawingml/2006/main">
               <a:ext uri="{FF2B5EF4-FFF2-40B4-BE49-F238E27FC236}">
-                <a16:creationId xmlns:a16="http://schemas.microsoft.com/office/drawing/2014/main" id="{F16BEC2B-A0D0-439B-B570-1D00624391CF}"/>
+                <a16:creationId xmlns:a16="http://schemas.microsoft.com/office/drawing/2014/main" id="{7125538E-345A-4717-9AB9-EBE2068C7290}"/>
               </a:ext>
             </a:extLst>
           </p:cNvPr>
@@ -4155,7 +4155,7 @@
           <p:cNvPr id="63" name="">
             <a:extLst xmlns:a="http://schemas.openxmlformats.org/drawingml/2006/main">
               <a:ext uri="{FF2B5EF4-FFF2-40B4-BE49-F238E27FC236}">
-                <a16:creationId xmlns:a16="http://schemas.microsoft.com/office/drawing/2014/main" id="{1FAF0E23-B87F-42C9-9F8D-76F407A0AE4F}"/>
+                <a16:creationId xmlns:a16="http://schemas.microsoft.com/office/drawing/2014/main" id="{2C983262-3AF2-47F6-BE3F-32DAB311294F}"/>
               </a:ext>
             </a:extLst>
           </p:cNvPr>
@@ -4219,7 +4219,7 @@
           <p:cNvPr id="64" name="">
             <a:extLst xmlns:a="http://schemas.openxmlformats.org/drawingml/2006/main">
               <a:ext uri="{FF2B5EF4-FFF2-40B4-BE49-F238E27FC236}">
-                <a16:creationId xmlns:a16="http://schemas.microsoft.com/office/drawing/2014/main" id="{54FAEF8D-0F38-4758-AD25-20EE560A1652}"/>
+                <a16:creationId xmlns:a16="http://schemas.microsoft.com/office/drawing/2014/main" id="{4099A8BB-8C71-42A1-A0CE-B448496BEDBB}"/>
               </a:ext>
             </a:extLst>
           </p:cNvPr>
@@ -4252,7 +4252,7 @@
           <p:cNvPr id="65" name="">
             <a:extLst xmlns:a="http://schemas.openxmlformats.org/drawingml/2006/main">
               <a:ext uri="{FF2B5EF4-FFF2-40B4-BE49-F238E27FC236}">
-                <a16:creationId xmlns:a16="http://schemas.microsoft.com/office/drawing/2014/main" id="{8BE95A8A-3A5A-4897-8DC2-7758C01CC1FA}"/>
+                <a16:creationId xmlns:a16="http://schemas.microsoft.com/office/drawing/2014/main" id="{A3F5AFBC-EB15-4227-BCA4-CD3D6939B42E}"/>
               </a:ext>
             </a:extLst>
           </p:cNvPr>
@@ -4316,7 +4316,7 @@
           <p:cNvPr id="66" name="">
             <a:extLst xmlns:a="http://schemas.openxmlformats.org/drawingml/2006/main">
               <a:ext uri="{FF2B5EF4-FFF2-40B4-BE49-F238E27FC236}">
-                <a16:creationId xmlns:a16="http://schemas.microsoft.com/office/drawing/2014/main" id="{4EC0AB7A-DF7A-4AC9-B9DF-8C83445092F8}"/>
+                <a16:creationId xmlns:a16="http://schemas.microsoft.com/office/drawing/2014/main" id="{5B6EF25D-BD25-4239-BF50-287DC095143E}"/>
               </a:ext>
             </a:extLst>
           </p:cNvPr>
@@ -4349,7 +4349,7 @@
           <p:cNvPr id="67" name="">
             <a:extLst xmlns:a="http://schemas.openxmlformats.org/drawingml/2006/main">
               <a:ext uri="{FF2B5EF4-FFF2-40B4-BE49-F238E27FC236}">
-                <a16:creationId xmlns:a16="http://schemas.microsoft.com/office/drawing/2014/main" id="{28541FE7-3EAF-4C2B-A254-5456B146478F}"/>
+                <a16:creationId xmlns:a16="http://schemas.microsoft.com/office/drawing/2014/main" id="{1633EF54-0FE2-4132-ABB9-6B64CDA3C5F8}"/>
               </a:ext>
             </a:extLst>
           </p:cNvPr>
@@ -4413,7 +4413,7 @@
           <p:cNvPr id="68" name="">
             <a:extLst xmlns:a="http://schemas.openxmlformats.org/drawingml/2006/main">
               <a:ext uri="{FF2B5EF4-FFF2-40B4-BE49-F238E27FC236}">
-                <a16:creationId xmlns:a16="http://schemas.microsoft.com/office/drawing/2014/main" id="{A23950D4-C86F-4D54-9DB4-CE6514F68750}"/>
+                <a16:creationId xmlns:a16="http://schemas.microsoft.com/office/drawing/2014/main" id="{4988BFC1-25FF-4A02-8B42-BF96135F428F}"/>
               </a:ext>
             </a:extLst>
           </p:cNvPr>
@@ -4446,7 +4446,7 @@
           <p:cNvPr id="69" name="">
             <a:extLst xmlns:a="http://schemas.openxmlformats.org/drawingml/2006/main">
               <a:ext uri="{FF2B5EF4-FFF2-40B4-BE49-F238E27FC236}">
-                <a16:creationId xmlns:a16="http://schemas.microsoft.com/office/drawing/2014/main" id="{BF70EE83-8272-4EE3-BCD3-8373FA263A46}"/>
+                <a16:creationId xmlns:a16="http://schemas.microsoft.com/office/drawing/2014/main" id="{03AE781A-3447-4704-8D88-0DF2426E0238}"/>
               </a:ext>
             </a:extLst>
           </p:cNvPr>
@@ -4510,7 +4510,7 @@
           <p:cNvPr id="70" name="">
             <a:extLst xmlns:a="http://schemas.openxmlformats.org/drawingml/2006/main">
               <a:ext uri="{FF2B5EF4-FFF2-40B4-BE49-F238E27FC236}">
-                <a16:creationId xmlns:a16="http://schemas.microsoft.com/office/drawing/2014/main" id="{F68B8959-4F51-45F5-9B15-011A66727C34}"/>
+                <a16:creationId xmlns:a16="http://schemas.microsoft.com/office/drawing/2014/main" id="{14C4E3FC-08B7-41D2-88E8-8B984C72C7A9}"/>
               </a:ext>
             </a:extLst>
           </p:cNvPr>
@@ -4543,7 +4543,7 @@
           <p:cNvPr id="71" name="">
             <a:extLst xmlns:a="http://schemas.openxmlformats.org/drawingml/2006/main">
               <a:ext uri="{FF2B5EF4-FFF2-40B4-BE49-F238E27FC236}">
-                <a16:creationId xmlns:a16="http://schemas.microsoft.com/office/drawing/2014/main" id="{0CF3985B-5B07-4A5B-9346-C8F8938DEFD5}"/>
+                <a16:creationId xmlns:a16="http://schemas.microsoft.com/office/drawing/2014/main" id="{BF0F706F-F8D4-4E21-9D03-3FB21C6007D2}"/>
               </a:ext>
             </a:extLst>
           </p:cNvPr>
@@ -4607,7 +4607,7 @@
           <p:cNvPr id="72" name="">
             <a:extLst xmlns:a="http://schemas.openxmlformats.org/drawingml/2006/main">
               <a:ext uri="{FF2B5EF4-FFF2-40B4-BE49-F238E27FC236}">
-                <a16:creationId xmlns:a16="http://schemas.microsoft.com/office/drawing/2014/main" id="{8DBFBC41-1A9E-4D92-909C-6CB7DE76D95B}"/>
+                <a16:creationId xmlns:a16="http://schemas.microsoft.com/office/drawing/2014/main" id="{48413B7E-61FC-4DD3-9FC4-3AC293861EA8}"/>
               </a:ext>
             </a:extLst>
           </p:cNvPr>
@@ -4640,7 +4640,7 @@
           <p:cNvPr id="73" name="">
             <a:extLst xmlns:a="http://schemas.openxmlformats.org/drawingml/2006/main">
               <a:ext uri="{FF2B5EF4-FFF2-40B4-BE49-F238E27FC236}">
-                <a16:creationId xmlns:a16="http://schemas.microsoft.com/office/drawing/2014/main" id="{049F37B3-D620-4130-A813-2321D4BD0537}"/>
+                <a16:creationId xmlns:a16="http://schemas.microsoft.com/office/drawing/2014/main" id="{8B8B13B3-4872-421D-90A6-AF7CC6166B89}"/>
               </a:ext>
             </a:extLst>
           </p:cNvPr>
@@ -4704,7 +4704,7 @@
           <p:cNvPr id="74" name="">
             <a:extLst xmlns:a="http://schemas.openxmlformats.org/drawingml/2006/main">
               <a:ext uri="{FF2B5EF4-FFF2-40B4-BE49-F238E27FC236}">
-                <a16:creationId xmlns:a16="http://schemas.microsoft.com/office/drawing/2014/main" id="{C12A8677-62E3-48C3-B59C-72D45B5F5C8D}"/>
+                <a16:creationId xmlns:a16="http://schemas.microsoft.com/office/drawing/2014/main" id="{6AFBE373-2D9F-4D4E-A3C8-AD0EF961C312}"/>
               </a:ext>
             </a:extLst>
           </p:cNvPr>
@@ -4737,7 +4737,7 @@
           <p:cNvPr id="75" name="">
             <a:extLst xmlns:a="http://schemas.openxmlformats.org/drawingml/2006/main">
               <a:ext uri="{FF2B5EF4-FFF2-40B4-BE49-F238E27FC236}">
-                <a16:creationId xmlns:a16="http://schemas.microsoft.com/office/drawing/2014/main" id="{82C8D1F6-F421-4D42-9D4A-800C24F02624}"/>
+                <a16:creationId xmlns:a16="http://schemas.microsoft.com/office/drawing/2014/main" id="{0E02A8C4-C6CB-4090-8260-3A7F4F5984AC}"/>
               </a:ext>
             </a:extLst>
           </p:cNvPr>
@@ -4801,7 +4801,7 @@
           <p:cNvPr id="76" name="">
             <a:extLst xmlns:a="http://schemas.openxmlformats.org/drawingml/2006/main">
               <a:ext uri="{FF2B5EF4-FFF2-40B4-BE49-F238E27FC236}">
-                <a16:creationId xmlns:a16="http://schemas.microsoft.com/office/drawing/2014/main" id="{91BCEBF9-53BF-429F-9B09-F13578545478}"/>
+                <a16:creationId xmlns:a16="http://schemas.microsoft.com/office/drawing/2014/main" id="{678B086C-A19F-4EE2-BE50-43972D5ED03D}"/>
               </a:ext>
             </a:extLst>
           </p:cNvPr>
@@ -4834,7 +4834,7 @@
           <p:cNvPr id="77" name="">
             <a:extLst xmlns:a="http://schemas.openxmlformats.org/drawingml/2006/main">
               <a:ext uri="{FF2B5EF4-FFF2-40B4-BE49-F238E27FC236}">
-                <a16:creationId xmlns:a16="http://schemas.microsoft.com/office/drawing/2014/main" id="{A7AFABEF-4287-4905-8BEF-89DE5FAF5685}"/>
+                <a16:creationId xmlns:a16="http://schemas.microsoft.com/office/drawing/2014/main" id="{9345B9B9-14FE-4F75-939F-3997C839E2E5}"/>
               </a:ext>
             </a:extLst>
           </p:cNvPr>
@@ -4898,7 +4898,7 @@
           <p:cNvPr id="78" name="">
             <a:extLst xmlns:a="http://schemas.openxmlformats.org/drawingml/2006/main">
               <a:ext uri="{FF2B5EF4-FFF2-40B4-BE49-F238E27FC236}">
-                <a16:creationId xmlns:a16="http://schemas.microsoft.com/office/drawing/2014/main" id="{97EA8514-A544-457C-949C-943ED7861284}"/>
+                <a16:creationId xmlns:a16="http://schemas.microsoft.com/office/drawing/2014/main" id="{CD4CEDCB-E590-4864-B043-8D9967AC2BD5}"/>
               </a:ext>
             </a:extLst>
           </p:cNvPr>
@@ -4931,7 +4931,7 @@
           <p:cNvPr id="79" name="">
             <a:extLst xmlns:a="http://schemas.openxmlformats.org/drawingml/2006/main">
               <a:ext uri="{FF2B5EF4-FFF2-40B4-BE49-F238E27FC236}">
-                <a16:creationId xmlns:a16="http://schemas.microsoft.com/office/drawing/2014/main" id="{D8E57D97-887C-4AE3-B595-B108700B20C3}"/>
+                <a16:creationId xmlns:a16="http://schemas.microsoft.com/office/drawing/2014/main" id="{3615F81C-2E84-44DE-8864-8ECF900EE454}"/>
               </a:ext>
             </a:extLst>
           </p:cNvPr>
@@ -4995,7 +4995,7 @@
           <p:cNvPr id="80" name="">
             <a:extLst xmlns:a="http://schemas.openxmlformats.org/drawingml/2006/main">
               <a:ext uri="{FF2B5EF4-FFF2-40B4-BE49-F238E27FC236}">
-                <a16:creationId xmlns:a16="http://schemas.microsoft.com/office/drawing/2014/main" id="{53A978C6-F5AF-4462-ACD5-89234CA220D9}"/>
+                <a16:creationId xmlns:a16="http://schemas.microsoft.com/office/drawing/2014/main" id="{18F5A483-5E30-4B05-BDC8-528532F4EE38}"/>
               </a:ext>
             </a:extLst>
           </p:cNvPr>
@@ -5028,7 +5028,7 @@
           <p:cNvPr id="81" name="">
             <a:extLst xmlns:a="http://schemas.openxmlformats.org/drawingml/2006/main">
               <a:ext uri="{FF2B5EF4-FFF2-40B4-BE49-F238E27FC236}">
-                <a16:creationId xmlns:a16="http://schemas.microsoft.com/office/drawing/2014/main" id="{F98E7024-0BC9-43B1-960F-207E2CD30260}"/>
+                <a16:creationId xmlns:a16="http://schemas.microsoft.com/office/drawing/2014/main" id="{8CDDCBDA-190F-4C96-B98A-7A2A36BCF2A4}"/>
               </a:ext>
             </a:extLst>
           </p:cNvPr>
@@ -5092,7 +5092,7 @@
           <p:cNvPr id="82" name="">
             <a:extLst xmlns:a="http://schemas.openxmlformats.org/drawingml/2006/main">
               <a:ext uri="{FF2B5EF4-FFF2-40B4-BE49-F238E27FC236}">
-                <a16:creationId xmlns:a16="http://schemas.microsoft.com/office/drawing/2014/main" id="{B65E4E71-AC35-4BB3-B22F-FC6A0B788ADD}"/>
+                <a16:creationId xmlns:a16="http://schemas.microsoft.com/office/drawing/2014/main" id="{92415921-1D2A-4F69-A20C-715A253C9A25}"/>
               </a:ext>
             </a:extLst>
           </p:cNvPr>
@@ -5125,7 +5125,7 @@
           <p:cNvPr id="83" name="">
             <a:extLst xmlns:a="http://schemas.openxmlformats.org/drawingml/2006/main">
               <a:ext uri="{FF2B5EF4-FFF2-40B4-BE49-F238E27FC236}">
-                <a16:creationId xmlns:a16="http://schemas.microsoft.com/office/drawing/2014/main" id="{2F0E6094-94C2-4115-B69B-5699ED0BD01C}"/>
+                <a16:creationId xmlns:a16="http://schemas.microsoft.com/office/drawing/2014/main" id="{83587149-AF65-49DA-AE20-5AEE8EF5C784}"/>
               </a:ext>
             </a:extLst>
           </p:cNvPr>
@@ -5189,7 +5189,7 @@
           <p:cNvPr id="84" name="">
             <a:extLst xmlns:a="http://schemas.openxmlformats.org/drawingml/2006/main">
               <a:ext uri="{FF2B5EF4-FFF2-40B4-BE49-F238E27FC236}">
-                <a16:creationId xmlns:a16="http://schemas.microsoft.com/office/drawing/2014/main" id="{26D8C1FF-352B-419A-B43A-F8913349556C}"/>
+                <a16:creationId xmlns:a16="http://schemas.microsoft.com/office/drawing/2014/main" id="{EC52CCBD-74E6-4EB9-B090-5176476A4F60}"/>
               </a:ext>
             </a:extLst>
           </p:cNvPr>
@@ -5222,7 +5222,7 @@
           <p:cNvPr id="85" name="">
             <a:extLst xmlns:a="http://schemas.openxmlformats.org/drawingml/2006/main">
               <a:ext uri="{FF2B5EF4-FFF2-40B4-BE49-F238E27FC236}">
-                <a16:creationId xmlns:a16="http://schemas.microsoft.com/office/drawing/2014/main" id="{EE4B0B0F-6404-441C-8D99-97FCDFB17878}"/>
+                <a16:creationId xmlns:a16="http://schemas.microsoft.com/office/drawing/2014/main" id="{AB13D1AA-FA2A-44EF-802C-5A34A9CEE31B}"/>
               </a:ext>
             </a:extLst>
           </p:cNvPr>
@@ -5286,7 +5286,7 @@
           <p:cNvPr id="86" name="">
             <a:extLst xmlns:a="http://schemas.openxmlformats.org/drawingml/2006/main">
               <a:ext uri="{FF2B5EF4-FFF2-40B4-BE49-F238E27FC236}">
-                <a16:creationId xmlns:a16="http://schemas.microsoft.com/office/drawing/2014/main" id="{838C057F-C15F-4E72-95D3-50A336BF60E9}"/>
+                <a16:creationId xmlns:a16="http://schemas.microsoft.com/office/drawing/2014/main" id="{D2D9876C-2AB5-43B6-A3A0-A2AC689AE89E}"/>
               </a:ext>
             </a:extLst>
           </p:cNvPr>
@@ -5319,7 +5319,7 @@
           <p:cNvPr id="87" name="">
             <a:extLst xmlns:a="http://schemas.openxmlformats.org/drawingml/2006/main">
               <a:ext uri="{FF2B5EF4-FFF2-40B4-BE49-F238E27FC236}">
-                <a16:creationId xmlns:a16="http://schemas.microsoft.com/office/drawing/2014/main" id="{E3CEDAF9-569B-4A61-B75A-FB3659D4D35E}"/>
+                <a16:creationId xmlns:a16="http://schemas.microsoft.com/office/drawing/2014/main" id="{007DD538-EA57-48AE-9DBD-BCB82A195BB0}"/>
               </a:ext>
             </a:extLst>
           </p:cNvPr>
@@ -5383,7 +5383,7 @@
           <p:cNvPr id="88" name="">
             <a:extLst xmlns:a="http://schemas.openxmlformats.org/drawingml/2006/main">
               <a:ext uri="{FF2B5EF4-FFF2-40B4-BE49-F238E27FC236}">
-                <a16:creationId xmlns:a16="http://schemas.microsoft.com/office/drawing/2014/main" id="{AE3AA7FE-19B6-41D3-A936-326E2063C652}"/>
+                <a16:creationId xmlns:a16="http://schemas.microsoft.com/office/drawing/2014/main" id="{A8E9643B-E3E5-4A3D-AB00-127E21D3FB2F}"/>
               </a:ext>
             </a:extLst>
           </p:cNvPr>
@@ -5416,7 +5416,7 @@
           <p:cNvPr id="89" name="">
             <a:extLst xmlns:a="http://schemas.openxmlformats.org/drawingml/2006/main">
               <a:ext uri="{FF2B5EF4-FFF2-40B4-BE49-F238E27FC236}">
-                <a16:creationId xmlns:a16="http://schemas.microsoft.com/office/drawing/2014/main" id="{9B4C8926-894D-43A6-9200-2E1FA8F99EAD}"/>
+                <a16:creationId xmlns:a16="http://schemas.microsoft.com/office/drawing/2014/main" id="{88D8138B-D0D3-460E-A3ED-5A0D766E04E3}"/>
               </a:ext>
             </a:extLst>
           </p:cNvPr>
@@ -5480,7 +5480,7 @@
           <p:cNvPr id="90" name="">
             <a:extLst xmlns:a="http://schemas.openxmlformats.org/drawingml/2006/main">
               <a:ext uri="{FF2B5EF4-FFF2-40B4-BE49-F238E27FC236}">
-                <a16:creationId xmlns:a16="http://schemas.microsoft.com/office/drawing/2014/main" id="{E27691F8-6F86-4523-9A1F-46E3613D241C}"/>
+                <a16:creationId xmlns:a16="http://schemas.microsoft.com/office/drawing/2014/main" id="{ABD1CBAE-42DE-40FF-A84E-6A53DEBCE8FC}"/>
               </a:ext>
             </a:extLst>
           </p:cNvPr>
@@ -5513,7 +5513,7 @@
           <p:cNvPr id="91" name="">
             <a:extLst xmlns:a="http://schemas.openxmlformats.org/drawingml/2006/main">
               <a:ext uri="{FF2B5EF4-FFF2-40B4-BE49-F238E27FC236}">
-                <a16:creationId xmlns:a16="http://schemas.microsoft.com/office/drawing/2014/main" id="{8AA193AB-BFB6-4CDF-9C9C-5AE58573788C}"/>
+                <a16:creationId xmlns:a16="http://schemas.microsoft.com/office/drawing/2014/main" id="{06DE5DF2-37EF-4FA6-983B-87405CB6F036}"/>
               </a:ext>
             </a:extLst>
           </p:cNvPr>
@@ -5546,7 +5546,7 @@
           <p:cNvPr id="92" name="">
             <a:extLst xmlns:a="http://schemas.openxmlformats.org/drawingml/2006/main">
               <a:ext uri="{FF2B5EF4-FFF2-40B4-BE49-F238E27FC236}">
-                <a16:creationId xmlns:a16="http://schemas.microsoft.com/office/drawing/2014/main" id="{2070CE82-B58F-434A-8499-0977505D79C4}"/>
+                <a16:creationId xmlns:a16="http://schemas.microsoft.com/office/drawing/2014/main" id="{34F07BD9-0E57-4A26-BC8B-98085C6A4ED5}"/>
               </a:ext>
             </a:extLst>
           </p:cNvPr>
@@ -5610,7 +5610,7 @@
           <p:cNvPr id="93" name="">
             <a:extLst xmlns:a="http://schemas.openxmlformats.org/drawingml/2006/main">
               <a:ext uri="{FF2B5EF4-FFF2-40B4-BE49-F238E27FC236}">
-                <a16:creationId xmlns:a16="http://schemas.microsoft.com/office/drawing/2014/main" id="{034ACC38-4CD8-4C4C-853B-CAE07774BEBA}"/>
+                <a16:creationId xmlns:a16="http://schemas.microsoft.com/office/drawing/2014/main" id="{B9E535C5-B68A-4034-A944-C20AE2817CAB}"/>
               </a:ext>
             </a:extLst>
           </p:cNvPr>
@@ -5643,7 +5643,7 @@
           <p:cNvPr id="94" name="">
             <a:extLst xmlns:a="http://schemas.openxmlformats.org/drawingml/2006/main">
               <a:ext uri="{FF2B5EF4-FFF2-40B4-BE49-F238E27FC236}">
-                <a16:creationId xmlns:a16="http://schemas.microsoft.com/office/drawing/2014/main" id="{0B0884F0-988F-44ED-BB04-EC338804A123}"/>
+                <a16:creationId xmlns:a16="http://schemas.microsoft.com/office/drawing/2014/main" id="{7BB2EE0C-8D62-44C6-A3AF-D867EE7E24EE}"/>
               </a:ext>
             </a:extLst>
           </p:cNvPr>
@@ -5676,7 +5676,7 @@
           <p:cNvPr id="95" name="">
             <a:extLst xmlns:a="http://schemas.openxmlformats.org/drawingml/2006/main">
               <a:ext uri="{FF2B5EF4-FFF2-40B4-BE49-F238E27FC236}">
-                <a16:creationId xmlns:a16="http://schemas.microsoft.com/office/drawing/2014/main" id="{EE270F09-A772-41FF-98A1-C5B2F61B41DB}"/>
+                <a16:creationId xmlns:a16="http://schemas.microsoft.com/office/drawing/2014/main" id="{89D04F56-2612-45A9-9D1B-F73056648350}"/>
               </a:ext>
             </a:extLst>
           </p:cNvPr>
@@ -5740,7 +5740,7 @@
           <p:cNvPr id="96" name="">
             <a:extLst xmlns:a="http://schemas.openxmlformats.org/drawingml/2006/main">
               <a:ext uri="{FF2B5EF4-FFF2-40B4-BE49-F238E27FC236}">
-                <a16:creationId xmlns:a16="http://schemas.microsoft.com/office/drawing/2014/main" id="{9EA3C3E7-B47D-4B87-9918-68928429BF11}"/>
+                <a16:creationId xmlns:a16="http://schemas.microsoft.com/office/drawing/2014/main" id="{3FF281F5-FCAC-4943-9028-FE582F5B851D}"/>
               </a:ext>
             </a:extLst>
           </p:cNvPr>
@@ -5773,7 +5773,7 @@
           <p:cNvPr id="97" name="">
             <a:extLst xmlns:a="http://schemas.openxmlformats.org/drawingml/2006/main">
               <a:ext uri="{FF2B5EF4-FFF2-40B4-BE49-F238E27FC236}">
-                <a16:creationId xmlns:a16="http://schemas.microsoft.com/office/drawing/2014/main" id="{998C9794-C28E-4A66-A1AC-796F36858D97}"/>
+                <a16:creationId xmlns:a16="http://schemas.microsoft.com/office/drawing/2014/main" id="{2D449504-2899-42A7-9444-0B47C0698FFC}"/>
               </a:ext>
             </a:extLst>
           </p:cNvPr>
@@ -5806,7 +5806,7 @@
           <p:cNvPr id="98" name="">
             <a:extLst xmlns:a="http://schemas.openxmlformats.org/drawingml/2006/main">
               <a:ext uri="{FF2B5EF4-FFF2-40B4-BE49-F238E27FC236}">
-                <a16:creationId xmlns:a16="http://schemas.microsoft.com/office/drawing/2014/main" id="{7DC52C87-93B5-4467-AE9E-2F08E2B8C774}"/>
+                <a16:creationId xmlns:a16="http://schemas.microsoft.com/office/drawing/2014/main" id="{48A27054-5719-4615-B45C-31AFCEC02F04}"/>
               </a:ext>
             </a:extLst>
           </p:cNvPr>
@@ -5870,7 +5870,7 @@
           <p:cNvPr id="99" name="">
             <a:extLst xmlns:a="http://schemas.openxmlformats.org/drawingml/2006/main">
               <a:ext uri="{FF2B5EF4-FFF2-40B4-BE49-F238E27FC236}">
-                <a16:creationId xmlns:a16="http://schemas.microsoft.com/office/drawing/2014/main" id="{0F3909F6-39FF-442F-A51F-3C1A7024748B}"/>
+                <a16:creationId xmlns:a16="http://schemas.microsoft.com/office/drawing/2014/main" id="{7E715857-A61B-4901-9FC3-33CF4CFCEDD6}"/>
               </a:ext>
             </a:extLst>
           </p:cNvPr>
@@ -5934,7 +5934,7 @@
           <p:cNvPr id="100" name="">
             <a:extLst xmlns:a="http://schemas.openxmlformats.org/drawingml/2006/main">
               <a:ext uri="{FF2B5EF4-FFF2-40B4-BE49-F238E27FC236}">
-                <a16:creationId xmlns:a16="http://schemas.microsoft.com/office/drawing/2014/main" id="{2658BD4F-5340-48E6-B8F2-A7B1909CD0D2}"/>
+                <a16:creationId xmlns:a16="http://schemas.microsoft.com/office/drawing/2014/main" id="{FB7BDFE4-C8DC-4B2D-9F7C-A01B9746C1B3}"/>
               </a:ext>
             </a:extLst>
           </p:cNvPr>
@@ -5998,7 +5998,7 @@
           <p:cNvPr id="101" name="">
             <a:extLst xmlns:a="http://schemas.openxmlformats.org/drawingml/2006/main">
               <a:ext uri="{FF2B5EF4-FFF2-40B4-BE49-F238E27FC236}">
-                <a16:creationId xmlns:a16="http://schemas.microsoft.com/office/drawing/2014/main" id="{42D61081-0454-40A2-B1AD-203F25ED7CE7}"/>
+                <a16:creationId xmlns:a16="http://schemas.microsoft.com/office/drawing/2014/main" id="{5D25DD39-CCE3-4D44-A446-252B717F2ACA}"/>
               </a:ext>
             </a:extLst>
           </p:cNvPr>
@@ -6062,7 +6062,7 @@
           <p:cNvPr id="102" name="">
             <a:extLst xmlns:a="http://schemas.openxmlformats.org/drawingml/2006/main">
               <a:ext uri="{FF2B5EF4-FFF2-40B4-BE49-F238E27FC236}">
-                <a16:creationId xmlns:a16="http://schemas.microsoft.com/office/drawing/2014/main" id="{5502250C-4635-46FA-AA91-0D7CE9FE28DB}"/>
+                <a16:creationId xmlns:a16="http://schemas.microsoft.com/office/drawing/2014/main" id="{C40B4416-476C-44EF-85BD-14755F92787D}"/>
               </a:ext>
             </a:extLst>
           </p:cNvPr>
@@ -6126,7 +6126,7 @@
           <p:cNvPr id="103" name="">
             <a:extLst xmlns:a="http://schemas.openxmlformats.org/drawingml/2006/main">
               <a:ext uri="{FF2B5EF4-FFF2-40B4-BE49-F238E27FC236}">
-                <a16:creationId xmlns:a16="http://schemas.microsoft.com/office/drawing/2014/main" id="{9A964555-9C96-47E3-A705-C01FFBEE2992}"/>
+                <a16:creationId xmlns:a16="http://schemas.microsoft.com/office/drawing/2014/main" id="{111AAD63-8DE9-4E8A-A2A8-3E17ADBCA030}"/>
               </a:ext>
             </a:extLst>
           </p:cNvPr>
@@ -6190,7 +6190,7 @@
           <p:cNvPr id="104" name="">
             <a:extLst xmlns:a="http://schemas.openxmlformats.org/drawingml/2006/main">
               <a:ext uri="{FF2B5EF4-FFF2-40B4-BE49-F238E27FC236}">
-                <a16:creationId xmlns:a16="http://schemas.microsoft.com/office/drawing/2014/main" id="{F5187510-4B3B-4C06-9318-C4B11E137C8C}"/>
+                <a16:creationId xmlns:a16="http://schemas.microsoft.com/office/drawing/2014/main" id="{E1BA3507-B262-4449-867A-31444C81FC49}"/>
               </a:ext>
             </a:extLst>
           </p:cNvPr>
@@ -6254,7 +6254,7 @@
           <p:cNvPr id="105" name="">
             <a:extLst xmlns:a="http://schemas.openxmlformats.org/drawingml/2006/main">
               <a:ext uri="{FF2B5EF4-FFF2-40B4-BE49-F238E27FC236}">
-                <a16:creationId xmlns:a16="http://schemas.microsoft.com/office/drawing/2014/main" id="{7BEDAEFC-D84D-49D6-9016-B5B9535088A7}"/>
+                <a16:creationId xmlns:a16="http://schemas.microsoft.com/office/drawing/2014/main" id="{2BDCD2A6-F478-418B-B9DD-C531A2ED4D8D}"/>
               </a:ext>
             </a:extLst>
           </p:cNvPr>
@@ -6318,7 +6318,7 @@
           <p:cNvPr id="106" name="">
             <a:extLst xmlns:a="http://schemas.openxmlformats.org/drawingml/2006/main">
               <a:ext uri="{FF2B5EF4-FFF2-40B4-BE49-F238E27FC236}">
-                <a16:creationId xmlns:a16="http://schemas.microsoft.com/office/drawing/2014/main" id="{58470ED9-F7DB-44DC-82E8-3F4028140EBC}"/>
+                <a16:creationId xmlns:a16="http://schemas.microsoft.com/office/drawing/2014/main" id="{AB607783-152C-4553-8406-EA96B18705E6}"/>
               </a:ext>
             </a:extLst>
           </p:cNvPr>
@@ -6382,7 +6382,7 @@
           <p:cNvPr id="107" name="">
             <a:extLst xmlns:a="http://schemas.openxmlformats.org/drawingml/2006/main">
               <a:ext uri="{FF2B5EF4-FFF2-40B4-BE49-F238E27FC236}">
-                <a16:creationId xmlns:a16="http://schemas.microsoft.com/office/drawing/2014/main" id="{6A435006-C614-4B8B-A4B1-0CAB94732801}"/>
+                <a16:creationId xmlns:a16="http://schemas.microsoft.com/office/drawing/2014/main" id="{024F71F7-014B-49DC-8120-6E40BACBFEF1}"/>
               </a:ext>
             </a:extLst>
           </p:cNvPr>
@@ -6446,7 +6446,7 @@
           <p:cNvPr id="108" name="">
             <a:extLst xmlns:a="http://schemas.openxmlformats.org/drawingml/2006/main">
               <a:ext uri="{FF2B5EF4-FFF2-40B4-BE49-F238E27FC236}">
-                <a16:creationId xmlns:a16="http://schemas.microsoft.com/office/drawing/2014/main" id="{B2AA1A26-C741-47D7-8F7C-71CD3A3C8846}"/>
+                <a16:creationId xmlns:a16="http://schemas.microsoft.com/office/drawing/2014/main" id="{4CED8154-BA72-44F1-97CD-7D0D62D3692D}"/>
               </a:ext>
             </a:extLst>
           </p:cNvPr>
@@ -6479,7 +6479,7 @@
           <p:cNvPr id="109" name="">
             <a:extLst xmlns:a="http://schemas.openxmlformats.org/drawingml/2006/main">
               <a:ext uri="{FF2B5EF4-FFF2-40B4-BE49-F238E27FC236}">
-                <a16:creationId xmlns:a16="http://schemas.microsoft.com/office/drawing/2014/main" id="{0499D28E-D968-4F89-B5E0-1E61508D56D6}"/>
+                <a16:creationId xmlns:a16="http://schemas.microsoft.com/office/drawing/2014/main" id="{557A7AC5-DAEA-4C8E-BA17-F3EB677E82A7}"/>
               </a:ext>
             </a:extLst>
           </p:cNvPr>
@@ -6541,7 +6541,7 @@
     </p:spTree>
     <p:extLst>
       <p:ext uri="{BB962C8B-B14F-4D97-AF65-F5344CB8AC3E}">
-        <p14:creationId xmlns:p14="http://schemas.microsoft.com/office/powerpoint/2010/main" val="120734940"/>
+        <p14:creationId xmlns:p14="http://schemas.microsoft.com/office/powerpoint/2010/main" val="266808546"/>
       </p:ext>
     </p:extLst>
   </p:cSld>
@@ -6565,7 +6565,7 @@
           <p:cNvPr id="163" name="">
             <a:extLst xmlns:a="http://schemas.openxmlformats.org/drawingml/2006/main">
               <a:ext uri="{FF2B5EF4-FFF2-40B4-BE49-F238E27FC236}">
-                <a16:creationId xmlns:a16="http://schemas.microsoft.com/office/drawing/2014/main" id="{7BC2388A-AF8C-4AF0-AA9C-E3FE8DD47660}"/>
+                <a16:creationId xmlns:a16="http://schemas.microsoft.com/office/drawing/2014/main" id="{0FE8E039-9C58-40E1-90B0-947EAEB6A0D3}"/>
               </a:ext>
             </a:extLst>
           </p:cNvPr>
@@ -6629,7 +6629,7 @@
           <p:cNvPr id="2" name="">
             <a:extLst xmlns:a="http://schemas.openxmlformats.org/drawingml/2006/main">
               <a:ext uri="{FF2B5EF4-FFF2-40B4-BE49-F238E27FC236}">
-                <a16:creationId xmlns:a16="http://schemas.microsoft.com/office/drawing/2014/main" id="{4DAC6C6D-5467-4469-8B59-FE9AC870D7FD}"/>
+                <a16:creationId xmlns:a16="http://schemas.microsoft.com/office/drawing/2014/main" id="{FD986795-2549-48C2-B3BB-A04C8168B6F0}"/>
               </a:ext>
             </a:extLst>
           </p:cNvPr>
@@ -6662,7 +6662,7 @@
           <p:cNvPr id="3" name="">
             <a:extLst xmlns:a="http://schemas.openxmlformats.org/drawingml/2006/main">
               <a:ext uri="{FF2B5EF4-FFF2-40B4-BE49-F238E27FC236}">
-                <a16:creationId xmlns:a16="http://schemas.microsoft.com/office/drawing/2014/main" id="{DB4CBC5A-4ED6-47BD-9B89-3FABDCC96ED7}"/>
+                <a16:creationId xmlns:a16="http://schemas.microsoft.com/office/drawing/2014/main" id="{29E72067-560C-4BFB-B1F4-0021CF2C81A0}"/>
               </a:ext>
             </a:extLst>
           </p:cNvPr>
@@ -6695,7 +6695,7 @@
           <p:cNvPr id="4" name="">
             <a:extLst xmlns:a="http://schemas.openxmlformats.org/drawingml/2006/main">
               <a:ext uri="{FF2B5EF4-FFF2-40B4-BE49-F238E27FC236}">
-                <a16:creationId xmlns:a16="http://schemas.microsoft.com/office/drawing/2014/main" id="{3A24460F-8E33-4E5C-B3AA-DE99E790B9AB}"/>
+                <a16:creationId xmlns:a16="http://schemas.microsoft.com/office/drawing/2014/main" id="{0E3B795C-258A-45B2-B38A-26C6F9C9776A}"/>
               </a:ext>
             </a:extLst>
           </p:cNvPr>
@@ -6728,7 +6728,7 @@
           <p:cNvPr id="5" name="">
             <a:extLst xmlns:a="http://schemas.openxmlformats.org/drawingml/2006/main">
               <a:ext uri="{FF2B5EF4-FFF2-40B4-BE49-F238E27FC236}">
-                <a16:creationId xmlns:a16="http://schemas.microsoft.com/office/drawing/2014/main" id="{CA890F7B-C64B-418D-AA38-FCFEF40531E5}"/>
+                <a16:creationId xmlns:a16="http://schemas.microsoft.com/office/drawing/2014/main" id="{856B305F-5748-4251-BE11-320A8BE96F58}"/>
               </a:ext>
             </a:extLst>
           </p:cNvPr>
@@ -6792,7 +6792,7 @@
           <p:cNvPr id="6" name="">
             <a:extLst xmlns:a="http://schemas.openxmlformats.org/drawingml/2006/main">
               <a:ext uri="{FF2B5EF4-FFF2-40B4-BE49-F238E27FC236}">
-                <a16:creationId xmlns:a16="http://schemas.microsoft.com/office/drawing/2014/main" id="{EF805DAC-C9DA-42B4-B768-3A0000C3C09F}"/>
+                <a16:creationId xmlns:a16="http://schemas.microsoft.com/office/drawing/2014/main" id="{0BF7909B-4610-45CB-AD65-96C7054BC593}"/>
               </a:ext>
             </a:extLst>
           </p:cNvPr>
@@ -6825,7 +6825,7 @@
           <p:cNvPr id="7" name="">
             <a:extLst xmlns:a="http://schemas.openxmlformats.org/drawingml/2006/main">
               <a:ext uri="{FF2B5EF4-FFF2-40B4-BE49-F238E27FC236}">
-                <a16:creationId xmlns:a16="http://schemas.microsoft.com/office/drawing/2014/main" id="{5A4D0824-AF81-4018-A6C6-426B638CE44A}"/>
+                <a16:creationId xmlns:a16="http://schemas.microsoft.com/office/drawing/2014/main" id="{5D032CEB-DA98-49C8-B20B-5C380C851EF5}"/>
               </a:ext>
             </a:extLst>
           </p:cNvPr>
@@ -6858,7 +6858,7 @@
           <p:cNvPr id="8" name="">
             <a:extLst xmlns:a="http://schemas.openxmlformats.org/drawingml/2006/main">
               <a:ext uri="{FF2B5EF4-FFF2-40B4-BE49-F238E27FC236}">
-                <a16:creationId xmlns:a16="http://schemas.microsoft.com/office/drawing/2014/main" id="{F160549A-8CA0-45B8-84D4-A87D0BD9E0C1}"/>
+                <a16:creationId xmlns:a16="http://schemas.microsoft.com/office/drawing/2014/main" id="{4801D5A7-F3DE-4256-B573-B8C3FAA7CB24}"/>
               </a:ext>
             </a:extLst>
           </p:cNvPr>
@@ -6922,7 +6922,7 @@
           <p:cNvPr id="9" name="">
             <a:extLst xmlns:a="http://schemas.openxmlformats.org/drawingml/2006/main">
               <a:ext uri="{FF2B5EF4-FFF2-40B4-BE49-F238E27FC236}">
-                <a16:creationId xmlns:a16="http://schemas.microsoft.com/office/drawing/2014/main" id="{036CF0B1-1112-4A4F-8188-BEEF82F63F6D}"/>
+                <a16:creationId xmlns:a16="http://schemas.microsoft.com/office/drawing/2014/main" id="{6AAE4562-7E72-41C0-8BB8-72C47125098D}"/>
               </a:ext>
             </a:extLst>
           </p:cNvPr>
@@ -6955,7 +6955,7 @@
           <p:cNvPr id="10" name="">
             <a:extLst xmlns:a="http://schemas.openxmlformats.org/drawingml/2006/main">
               <a:ext uri="{FF2B5EF4-FFF2-40B4-BE49-F238E27FC236}">
-                <a16:creationId xmlns:a16="http://schemas.microsoft.com/office/drawing/2014/main" id="{711350F7-E996-4C47-A80B-1AB8401990CA}"/>
+                <a16:creationId xmlns:a16="http://schemas.microsoft.com/office/drawing/2014/main" id="{5F949982-24F8-46D3-8F9B-FA4F5D939909}"/>
               </a:ext>
             </a:extLst>
           </p:cNvPr>
@@ -7019,7 +7019,7 @@
           <p:cNvPr id="11" name="">
             <a:extLst xmlns:a="http://schemas.openxmlformats.org/drawingml/2006/main">
               <a:ext uri="{FF2B5EF4-FFF2-40B4-BE49-F238E27FC236}">
-                <a16:creationId xmlns:a16="http://schemas.microsoft.com/office/drawing/2014/main" id="{8CD3BF4E-42FE-4D61-AEA6-E306CE37304E}"/>
+                <a16:creationId xmlns:a16="http://schemas.microsoft.com/office/drawing/2014/main" id="{70CE4C7E-ABC2-4F8A-AB2F-A78EA348819A}"/>
               </a:ext>
             </a:extLst>
           </p:cNvPr>
@@ -7052,7 +7052,7 @@
           <p:cNvPr id="12" name="">
             <a:extLst xmlns:a="http://schemas.openxmlformats.org/drawingml/2006/main">
               <a:ext uri="{FF2B5EF4-FFF2-40B4-BE49-F238E27FC236}">
-                <a16:creationId xmlns:a16="http://schemas.microsoft.com/office/drawing/2014/main" id="{9F2C9692-B318-401D-9857-7E6FECC61D33}"/>
+                <a16:creationId xmlns:a16="http://schemas.microsoft.com/office/drawing/2014/main" id="{21040846-A407-44C2-87B3-05C52172C746}"/>
               </a:ext>
             </a:extLst>
           </p:cNvPr>
@@ -7116,7 +7116,7 @@
           <p:cNvPr id="13" name="">
             <a:extLst xmlns:a="http://schemas.openxmlformats.org/drawingml/2006/main">
               <a:ext uri="{FF2B5EF4-FFF2-40B4-BE49-F238E27FC236}">
-                <a16:creationId xmlns:a16="http://schemas.microsoft.com/office/drawing/2014/main" id="{B7BCA5B6-BE51-4BEE-8B3C-42A95D1F38CF}"/>
+                <a16:creationId xmlns:a16="http://schemas.microsoft.com/office/drawing/2014/main" id="{B8A0FCEF-FD89-4F04-897A-4B115DE3E2D6}"/>
               </a:ext>
             </a:extLst>
           </p:cNvPr>
@@ -7149,7 +7149,7 @@
           <p:cNvPr id="14" name="">
             <a:extLst xmlns:a="http://schemas.openxmlformats.org/drawingml/2006/main">
               <a:ext uri="{FF2B5EF4-FFF2-40B4-BE49-F238E27FC236}">
-                <a16:creationId xmlns:a16="http://schemas.microsoft.com/office/drawing/2014/main" id="{0B8D2F99-E51D-4EAB-BEE0-F2C4BFBF4E00}"/>
+                <a16:creationId xmlns:a16="http://schemas.microsoft.com/office/drawing/2014/main" id="{FE5B71FC-66F0-485F-B3E7-CD665929E7D2}"/>
               </a:ext>
             </a:extLst>
           </p:cNvPr>
@@ -7213,7 +7213,7 @@
           <p:cNvPr id="15" name="">
             <a:extLst xmlns:a="http://schemas.openxmlformats.org/drawingml/2006/main">
               <a:ext uri="{FF2B5EF4-FFF2-40B4-BE49-F238E27FC236}">
-                <a16:creationId xmlns:a16="http://schemas.microsoft.com/office/drawing/2014/main" id="{C7A3E724-67C0-4239-9596-52EC190DECF6}"/>
+                <a16:creationId xmlns:a16="http://schemas.microsoft.com/office/drawing/2014/main" id="{4EAD6F46-5FE8-4C15-AAAD-396B40962CEA}"/>
               </a:ext>
             </a:extLst>
           </p:cNvPr>
@@ -7246,7 +7246,7 @@
           <p:cNvPr id="16" name="">
             <a:extLst xmlns:a="http://schemas.openxmlformats.org/drawingml/2006/main">
               <a:ext uri="{FF2B5EF4-FFF2-40B4-BE49-F238E27FC236}">
-                <a16:creationId xmlns:a16="http://schemas.microsoft.com/office/drawing/2014/main" id="{D5BD96A4-968F-4467-B473-3F8720911399}"/>
+                <a16:creationId xmlns:a16="http://schemas.microsoft.com/office/drawing/2014/main" id="{C9426DC0-8863-4438-937C-349E508E9A2E}"/>
               </a:ext>
             </a:extLst>
           </p:cNvPr>
@@ -7310,7 +7310,7 @@
           <p:cNvPr id="17" name="">
             <a:extLst xmlns:a="http://schemas.openxmlformats.org/drawingml/2006/main">
               <a:ext uri="{FF2B5EF4-FFF2-40B4-BE49-F238E27FC236}">
-                <a16:creationId xmlns:a16="http://schemas.microsoft.com/office/drawing/2014/main" id="{50CDB996-12A3-440B-B28C-ED332B829719}"/>
+                <a16:creationId xmlns:a16="http://schemas.microsoft.com/office/drawing/2014/main" id="{1D7955EB-5760-45C5-A690-E1CA584B6290}"/>
               </a:ext>
             </a:extLst>
           </p:cNvPr>
@@ -7343,7 +7343,7 @@
           <p:cNvPr id="18" name="">
             <a:extLst xmlns:a="http://schemas.openxmlformats.org/drawingml/2006/main">
               <a:ext uri="{FF2B5EF4-FFF2-40B4-BE49-F238E27FC236}">
-                <a16:creationId xmlns:a16="http://schemas.microsoft.com/office/drawing/2014/main" id="{3DA222CF-27A3-4567-81E2-1A2E1A68E2A9}"/>
+                <a16:creationId xmlns:a16="http://schemas.microsoft.com/office/drawing/2014/main" id="{6F56FD0D-1D59-421B-951A-2C582174ECAD}"/>
               </a:ext>
             </a:extLst>
           </p:cNvPr>
@@ -7407,7 +7407,7 @@
           <p:cNvPr id="19" name="">
             <a:extLst xmlns:a="http://schemas.openxmlformats.org/drawingml/2006/main">
               <a:ext uri="{FF2B5EF4-FFF2-40B4-BE49-F238E27FC236}">
-                <a16:creationId xmlns:a16="http://schemas.microsoft.com/office/drawing/2014/main" id="{C08E83C3-2A4F-4236-9BCC-8D0B5E3A80B1}"/>
+                <a16:creationId xmlns:a16="http://schemas.microsoft.com/office/drawing/2014/main" id="{58EE8719-F0FB-4894-A6FC-5C6C0499391F}"/>
               </a:ext>
             </a:extLst>
           </p:cNvPr>
@@ -7440,7 +7440,7 @@
           <p:cNvPr id="20" name="">
             <a:extLst xmlns:a="http://schemas.openxmlformats.org/drawingml/2006/main">
               <a:ext uri="{FF2B5EF4-FFF2-40B4-BE49-F238E27FC236}">
-                <a16:creationId xmlns:a16="http://schemas.microsoft.com/office/drawing/2014/main" id="{56AEEFF4-DA32-4E60-8147-B414877EF449}"/>
+                <a16:creationId xmlns:a16="http://schemas.microsoft.com/office/drawing/2014/main" id="{A8C8C3AE-8C6C-4687-A238-6BD1C6C0E7CA}"/>
               </a:ext>
             </a:extLst>
           </p:cNvPr>
@@ -7504,7 +7504,7 @@
           <p:cNvPr id="21" name="">
             <a:extLst xmlns:a="http://schemas.openxmlformats.org/drawingml/2006/main">
               <a:ext uri="{FF2B5EF4-FFF2-40B4-BE49-F238E27FC236}">
-                <a16:creationId xmlns:a16="http://schemas.microsoft.com/office/drawing/2014/main" id="{E1448539-AD9D-4E6C-A42C-2499063A2A53}"/>
+                <a16:creationId xmlns:a16="http://schemas.microsoft.com/office/drawing/2014/main" id="{699DBC97-5148-48A1-B6A6-E42B6450FCB9}"/>
               </a:ext>
             </a:extLst>
           </p:cNvPr>
@@ -7537,7 +7537,7 @@
           <p:cNvPr id="22" name="">
             <a:extLst xmlns:a="http://schemas.openxmlformats.org/drawingml/2006/main">
               <a:ext uri="{FF2B5EF4-FFF2-40B4-BE49-F238E27FC236}">
-                <a16:creationId xmlns:a16="http://schemas.microsoft.com/office/drawing/2014/main" id="{38F85073-64FF-4E0F-920E-E26278C3F5CB}"/>
+                <a16:creationId xmlns:a16="http://schemas.microsoft.com/office/drawing/2014/main" id="{0E0D8E7D-DAF4-4FB3-806B-90A603F16C05}"/>
               </a:ext>
             </a:extLst>
           </p:cNvPr>
@@ -7601,7 +7601,7 @@
           <p:cNvPr id="23" name="">
             <a:extLst xmlns:a="http://schemas.openxmlformats.org/drawingml/2006/main">
               <a:ext uri="{FF2B5EF4-FFF2-40B4-BE49-F238E27FC236}">
-                <a16:creationId xmlns:a16="http://schemas.microsoft.com/office/drawing/2014/main" id="{E70C0916-29A8-4236-BD65-F49180A0F9E5}"/>
+                <a16:creationId xmlns:a16="http://schemas.microsoft.com/office/drawing/2014/main" id="{0573ABFB-A411-4EE7-9F5D-EB75BEFC856A}"/>
               </a:ext>
             </a:extLst>
           </p:cNvPr>
@@ -7634,7 +7634,7 @@
           <p:cNvPr id="24" name="">
             <a:extLst xmlns:a="http://schemas.openxmlformats.org/drawingml/2006/main">
               <a:ext uri="{FF2B5EF4-FFF2-40B4-BE49-F238E27FC236}">
-                <a16:creationId xmlns:a16="http://schemas.microsoft.com/office/drawing/2014/main" id="{A8F6B1B1-2504-4E8C-A093-9A664BAE7998}"/>
+                <a16:creationId xmlns:a16="http://schemas.microsoft.com/office/drawing/2014/main" id="{F70F9ACC-7D75-4D5B-95BB-46EB241034B1}"/>
               </a:ext>
             </a:extLst>
           </p:cNvPr>
@@ -7698,7 +7698,7 @@
           <p:cNvPr id="25" name="">
             <a:extLst xmlns:a="http://schemas.openxmlformats.org/drawingml/2006/main">
               <a:ext uri="{FF2B5EF4-FFF2-40B4-BE49-F238E27FC236}">
-                <a16:creationId xmlns:a16="http://schemas.microsoft.com/office/drawing/2014/main" id="{CFD5E511-88CF-45F5-BA76-9712F398C519}"/>
+                <a16:creationId xmlns:a16="http://schemas.microsoft.com/office/drawing/2014/main" id="{72519487-62BB-4EDA-B5A9-EC10FFD77863}"/>
               </a:ext>
             </a:extLst>
           </p:cNvPr>
@@ -7731,7 +7731,7 @@
           <p:cNvPr id="26" name="">
             <a:extLst xmlns:a="http://schemas.openxmlformats.org/drawingml/2006/main">
               <a:ext uri="{FF2B5EF4-FFF2-40B4-BE49-F238E27FC236}">
-                <a16:creationId xmlns:a16="http://schemas.microsoft.com/office/drawing/2014/main" id="{A04DBC35-78D3-42FB-BFC9-8FFBA4C0F2E4}"/>
+                <a16:creationId xmlns:a16="http://schemas.microsoft.com/office/drawing/2014/main" id="{B1AFAC99-ED8F-4196-B91A-BFA0A71CE91F}"/>
               </a:ext>
             </a:extLst>
           </p:cNvPr>
@@ -7795,7 +7795,7 @@
           <p:cNvPr id="27" name="">
             <a:extLst xmlns:a="http://schemas.openxmlformats.org/drawingml/2006/main">
               <a:ext uri="{FF2B5EF4-FFF2-40B4-BE49-F238E27FC236}">
-                <a16:creationId xmlns:a16="http://schemas.microsoft.com/office/drawing/2014/main" id="{3C91064A-B0F6-472E-86A2-722B9074FC35}"/>
+                <a16:creationId xmlns:a16="http://schemas.microsoft.com/office/drawing/2014/main" id="{4AF31A92-8E9D-4321-A767-6E7215DFD6B3}"/>
               </a:ext>
             </a:extLst>
           </p:cNvPr>
@@ -7828,7 +7828,7 @@
           <p:cNvPr id="28" name="">
             <a:extLst xmlns:a="http://schemas.openxmlformats.org/drawingml/2006/main">
               <a:ext uri="{FF2B5EF4-FFF2-40B4-BE49-F238E27FC236}">
-                <a16:creationId xmlns:a16="http://schemas.microsoft.com/office/drawing/2014/main" id="{AA17CD8F-63F7-455B-9C9B-A3182AAA468C}"/>
+                <a16:creationId xmlns:a16="http://schemas.microsoft.com/office/drawing/2014/main" id="{25A14CDA-E8C7-4D3B-9C86-80225A94EE6B}"/>
               </a:ext>
             </a:extLst>
           </p:cNvPr>
@@ -7892,7 +7892,7 @@
           <p:cNvPr id="29" name="">
             <a:extLst xmlns:a="http://schemas.openxmlformats.org/drawingml/2006/main">
               <a:ext uri="{FF2B5EF4-FFF2-40B4-BE49-F238E27FC236}">
-                <a16:creationId xmlns:a16="http://schemas.microsoft.com/office/drawing/2014/main" id="{D7A85DAE-A641-46D8-9DCE-3FA55E1145AE}"/>
+                <a16:creationId xmlns:a16="http://schemas.microsoft.com/office/drawing/2014/main" id="{046323FD-CB30-4248-A342-70471161ED73}"/>
               </a:ext>
             </a:extLst>
           </p:cNvPr>
@@ -7925,7 +7925,7 @@
           <p:cNvPr id="30" name="">
             <a:extLst xmlns:a="http://schemas.openxmlformats.org/drawingml/2006/main">
               <a:ext uri="{FF2B5EF4-FFF2-40B4-BE49-F238E27FC236}">
-                <a16:creationId xmlns:a16="http://schemas.microsoft.com/office/drawing/2014/main" id="{A083D69C-DC14-4CCD-8FA0-226B7689F3CF}"/>
+                <a16:creationId xmlns:a16="http://schemas.microsoft.com/office/drawing/2014/main" id="{A0B17841-1864-4605-9377-4E9FB046449A}"/>
               </a:ext>
             </a:extLst>
           </p:cNvPr>
@@ -7989,7 +7989,7 @@
           <p:cNvPr id="31" name="">
             <a:extLst xmlns:a="http://schemas.openxmlformats.org/drawingml/2006/main">
               <a:ext uri="{FF2B5EF4-FFF2-40B4-BE49-F238E27FC236}">
-                <a16:creationId xmlns:a16="http://schemas.microsoft.com/office/drawing/2014/main" id="{8C771F2E-6F72-44CE-A12F-FEEE2696B2E2}"/>
+                <a16:creationId xmlns:a16="http://schemas.microsoft.com/office/drawing/2014/main" id="{F932CF8D-B4F7-495A-9F72-C6A67CC9F32D}"/>
               </a:ext>
             </a:extLst>
           </p:cNvPr>
@@ -8022,7 +8022,7 @@
           <p:cNvPr id="32" name="">
             <a:extLst xmlns:a="http://schemas.openxmlformats.org/drawingml/2006/main">
               <a:ext uri="{FF2B5EF4-FFF2-40B4-BE49-F238E27FC236}">
-                <a16:creationId xmlns:a16="http://schemas.microsoft.com/office/drawing/2014/main" id="{AA3A5923-7F69-4957-AC31-62F34FF75998}"/>
+                <a16:creationId xmlns:a16="http://schemas.microsoft.com/office/drawing/2014/main" id="{21B72981-2DDA-4CE8-BEA7-BB989F909896}"/>
               </a:ext>
             </a:extLst>
           </p:cNvPr>
@@ -8086,7 +8086,7 @@
           <p:cNvPr id="33" name="">
             <a:extLst xmlns:a="http://schemas.openxmlformats.org/drawingml/2006/main">
               <a:ext uri="{FF2B5EF4-FFF2-40B4-BE49-F238E27FC236}">
-                <a16:creationId xmlns:a16="http://schemas.microsoft.com/office/drawing/2014/main" id="{3D34DDBA-204F-4CC2-8350-CD70502CE1AE}"/>
+                <a16:creationId xmlns:a16="http://schemas.microsoft.com/office/drawing/2014/main" id="{C18D2C9B-2F0C-4C41-B0E1-FBF4C4DB5467}"/>
               </a:ext>
             </a:extLst>
           </p:cNvPr>
@@ -8119,7 +8119,7 @@
           <p:cNvPr id="34" name="">
             <a:extLst xmlns:a="http://schemas.openxmlformats.org/drawingml/2006/main">
               <a:ext uri="{FF2B5EF4-FFF2-40B4-BE49-F238E27FC236}">
-                <a16:creationId xmlns:a16="http://schemas.microsoft.com/office/drawing/2014/main" id="{A51616A9-9520-4FC9-8555-7B82A7E3A8D8}"/>
+                <a16:creationId xmlns:a16="http://schemas.microsoft.com/office/drawing/2014/main" id="{A7185CAE-FC73-4B91-8A5A-A5A5EC5887CF}"/>
               </a:ext>
             </a:extLst>
           </p:cNvPr>
@@ -8183,7 +8183,7 @@
           <p:cNvPr id="35" name="">
             <a:extLst xmlns:a="http://schemas.openxmlformats.org/drawingml/2006/main">
               <a:ext uri="{FF2B5EF4-FFF2-40B4-BE49-F238E27FC236}">
-                <a16:creationId xmlns:a16="http://schemas.microsoft.com/office/drawing/2014/main" id="{0CF808D7-1A9B-4931-AAEF-B4DAEEE8A2C5}"/>
+                <a16:creationId xmlns:a16="http://schemas.microsoft.com/office/drawing/2014/main" id="{BE0E07C3-CB06-4B60-BC37-93A6EDAA4BEF}"/>
               </a:ext>
             </a:extLst>
           </p:cNvPr>
@@ -8216,7 +8216,7 @@
           <p:cNvPr id="36" name="">
             <a:extLst xmlns:a="http://schemas.openxmlformats.org/drawingml/2006/main">
               <a:ext uri="{FF2B5EF4-FFF2-40B4-BE49-F238E27FC236}">
-                <a16:creationId xmlns:a16="http://schemas.microsoft.com/office/drawing/2014/main" id="{061F3381-07DA-4B3C-99B4-09509C8E84FD}"/>
+                <a16:creationId xmlns:a16="http://schemas.microsoft.com/office/drawing/2014/main" id="{50ADD6F3-B1D7-4438-BF2A-D1E563C96574}"/>
               </a:ext>
             </a:extLst>
           </p:cNvPr>
@@ -8280,7 +8280,7 @@
           <p:cNvPr id="37" name="">
             <a:extLst xmlns:a="http://schemas.openxmlformats.org/drawingml/2006/main">
               <a:ext uri="{FF2B5EF4-FFF2-40B4-BE49-F238E27FC236}">
-                <a16:creationId xmlns:a16="http://schemas.microsoft.com/office/drawing/2014/main" id="{E8CFC2A5-AF67-4C87-BBDB-1A6144A4F63A}"/>
+                <a16:creationId xmlns:a16="http://schemas.microsoft.com/office/drawing/2014/main" id="{F16B71EB-52DB-4D9F-ADAC-50110EE18E75}"/>
               </a:ext>
             </a:extLst>
           </p:cNvPr>
@@ -8313,7 +8313,7 @@
           <p:cNvPr id="38" name="">
             <a:extLst xmlns:a="http://schemas.openxmlformats.org/drawingml/2006/main">
               <a:ext uri="{FF2B5EF4-FFF2-40B4-BE49-F238E27FC236}">
-                <a16:creationId xmlns:a16="http://schemas.microsoft.com/office/drawing/2014/main" id="{577588DC-5D98-4368-9941-31E83BA21731}"/>
+                <a16:creationId xmlns:a16="http://schemas.microsoft.com/office/drawing/2014/main" id="{6F8D6611-FB92-4E40-BFF3-A5682274EFE0}"/>
               </a:ext>
             </a:extLst>
           </p:cNvPr>
@@ -8377,7 +8377,7 @@
           <p:cNvPr id="39" name="">
             <a:extLst xmlns:a="http://schemas.openxmlformats.org/drawingml/2006/main">
               <a:ext uri="{FF2B5EF4-FFF2-40B4-BE49-F238E27FC236}">
-                <a16:creationId xmlns:a16="http://schemas.microsoft.com/office/drawing/2014/main" id="{F7BBCAB8-EBE7-425A-86B0-A6ECA1B766F5}"/>
+                <a16:creationId xmlns:a16="http://schemas.microsoft.com/office/drawing/2014/main" id="{CFBF966B-9E57-49A7-90F4-D57272945BE2}"/>
               </a:ext>
             </a:extLst>
           </p:cNvPr>
@@ -8410,7 +8410,7 @@
           <p:cNvPr id="40" name="">
             <a:extLst xmlns:a="http://schemas.openxmlformats.org/drawingml/2006/main">
               <a:ext uri="{FF2B5EF4-FFF2-40B4-BE49-F238E27FC236}">
-                <a16:creationId xmlns:a16="http://schemas.microsoft.com/office/drawing/2014/main" id="{5BDAA8AA-042A-42EC-882D-F7B13699CB5D}"/>
+                <a16:creationId xmlns:a16="http://schemas.microsoft.com/office/drawing/2014/main" id="{FC9C0856-C2D8-4550-8A94-D2E249A4914E}"/>
               </a:ext>
             </a:extLst>
           </p:cNvPr>
@@ -8474,7 +8474,7 @@
           <p:cNvPr id="41" name="">
             <a:extLst xmlns:a="http://schemas.openxmlformats.org/drawingml/2006/main">
               <a:ext uri="{FF2B5EF4-FFF2-40B4-BE49-F238E27FC236}">
-                <a16:creationId xmlns:a16="http://schemas.microsoft.com/office/drawing/2014/main" id="{467397ED-3FC9-485A-880C-0FEFE5EB1BB2}"/>
+                <a16:creationId xmlns:a16="http://schemas.microsoft.com/office/drawing/2014/main" id="{A8990ABF-703E-469D-A940-519C7B916C0D}"/>
               </a:ext>
             </a:extLst>
           </p:cNvPr>
@@ -8507,7 +8507,7 @@
           <p:cNvPr id="42" name="">
             <a:extLst xmlns:a="http://schemas.openxmlformats.org/drawingml/2006/main">
               <a:ext uri="{FF2B5EF4-FFF2-40B4-BE49-F238E27FC236}">
-                <a16:creationId xmlns:a16="http://schemas.microsoft.com/office/drawing/2014/main" id="{F767F69F-536F-464A-BC05-F5276F6474C6}"/>
+                <a16:creationId xmlns:a16="http://schemas.microsoft.com/office/drawing/2014/main" id="{070AB2DF-04D4-49A2-8C6A-65C7F933AE2C}"/>
               </a:ext>
             </a:extLst>
           </p:cNvPr>
@@ -8571,7 +8571,7 @@
           <p:cNvPr id="43" name="">
             <a:extLst xmlns:a="http://schemas.openxmlformats.org/drawingml/2006/main">
               <a:ext uri="{FF2B5EF4-FFF2-40B4-BE49-F238E27FC236}">
-                <a16:creationId xmlns:a16="http://schemas.microsoft.com/office/drawing/2014/main" id="{BE3E6563-2FA8-4386-A247-86EA4B2C2F53}"/>
+                <a16:creationId xmlns:a16="http://schemas.microsoft.com/office/drawing/2014/main" id="{F750F2DC-E13A-456E-B13D-97FE11976382}"/>
               </a:ext>
             </a:extLst>
           </p:cNvPr>
@@ -8604,7 +8604,7 @@
           <p:cNvPr id="44" name="">
             <a:extLst xmlns:a="http://schemas.openxmlformats.org/drawingml/2006/main">
               <a:ext uri="{FF2B5EF4-FFF2-40B4-BE49-F238E27FC236}">
-                <a16:creationId xmlns:a16="http://schemas.microsoft.com/office/drawing/2014/main" id="{1C6F54BB-D422-4B65-93D2-34915A81DC93}"/>
+                <a16:creationId xmlns:a16="http://schemas.microsoft.com/office/drawing/2014/main" id="{5D43AE63-FD60-4A41-8AD2-83DB347396A8}"/>
               </a:ext>
             </a:extLst>
           </p:cNvPr>
@@ -8668,7 +8668,7 @@
           <p:cNvPr id="45" name="">
             <a:extLst xmlns:a="http://schemas.openxmlformats.org/drawingml/2006/main">
               <a:ext uri="{FF2B5EF4-FFF2-40B4-BE49-F238E27FC236}">
-                <a16:creationId xmlns:a16="http://schemas.microsoft.com/office/drawing/2014/main" id="{E1C2AC5F-3F32-4A77-8CC6-A5E208B18788}"/>
+                <a16:creationId xmlns:a16="http://schemas.microsoft.com/office/drawing/2014/main" id="{555C81FB-5729-4D42-9541-2C69AE660E2B}"/>
               </a:ext>
             </a:extLst>
           </p:cNvPr>
@@ -8701,7 +8701,7 @@
           <p:cNvPr id="46" name="">
             <a:extLst xmlns:a="http://schemas.openxmlformats.org/drawingml/2006/main">
               <a:ext uri="{FF2B5EF4-FFF2-40B4-BE49-F238E27FC236}">
-                <a16:creationId xmlns:a16="http://schemas.microsoft.com/office/drawing/2014/main" id="{846D02F6-5B5A-456E-A35F-993700261324}"/>
+                <a16:creationId xmlns:a16="http://schemas.microsoft.com/office/drawing/2014/main" id="{E0E9DD9A-B061-4977-887A-B1568E2B3E11}"/>
               </a:ext>
             </a:extLst>
           </p:cNvPr>
@@ -8765,7 +8765,7 @@
           <p:cNvPr id="47" name="">
             <a:extLst xmlns:a="http://schemas.openxmlformats.org/drawingml/2006/main">
               <a:ext uri="{FF2B5EF4-FFF2-40B4-BE49-F238E27FC236}">
-                <a16:creationId xmlns:a16="http://schemas.microsoft.com/office/drawing/2014/main" id="{1CEB6190-A660-4E9C-8EA8-FFE958FC1650}"/>
+                <a16:creationId xmlns:a16="http://schemas.microsoft.com/office/drawing/2014/main" id="{6ED876B0-9694-438F-A891-FC7B2EC8A098}"/>
               </a:ext>
             </a:extLst>
           </p:cNvPr>
@@ -8798,7 +8798,7 @@
           <p:cNvPr id="48" name="">
             <a:extLst xmlns:a="http://schemas.openxmlformats.org/drawingml/2006/main">
               <a:ext uri="{FF2B5EF4-FFF2-40B4-BE49-F238E27FC236}">
-                <a16:creationId xmlns:a16="http://schemas.microsoft.com/office/drawing/2014/main" id="{C5A0ADE2-5CAA-4227-8F45-E452CACBA290}"/>
+                <a16:creationId xmlns:a16="http://schemas.microsoft.com/office/drawing/2014/main" id="{72EA2E86-3543-4211-9C41-C82AAC353D28}"/>
               </a:ext>
             </a:extLst>
           </p:cNvPr>
@@ -8862,7 +8862,7 @@
           <p:cNvPr id="49" name="">
             <a:extLst xmlns:a="http://schemas.openxmlformats.org/drawingml/2006/main">
               <a:ext uri="{FF2B5EF4-FFF2-40B4-BE49-F238E27FC236}">
-                <a16:creationId xmlns:a16="http://schemas.microsoft.com/office/drawing/2014/main" id="{58B65923-D631-4091-A67C-631CA41E44C0}"/>
+                <a16:creationId xmlns:a16="http://schemas.microsoft.com/office/drawing/2014/main" id="{F9203EB1-4153-4991-820A-F400018FB1D0}"/>
               </a:ext>
             </a:extLst>
           </p:cNvPr>
@@ -8895,7 +8895,7 @@
           <p:cNvPr id="50" name="">
             <a:extLst xmlns:a="http://schemas.openxmlformats.org/drawingml/2006/main">
               <a:ext uri="{FF2B5EF4-FFF2-40B4-BE49-F238E27FC236}">
-                <a16:creationId xmlns:a16="http://schemas.microsoft.com/office/drawing/2014/main" id="{D9E71547-03DB-4EB1-8D39-42D5EE80DDBA}"/>
+                <a16:creationId xmlns:a16="http://schemas.microsoft.com/office/drawing/2014/main" id="{8B140648-B302-47A6-BC27-439134FAC441}"/>
               </a:ext>
             </a:extLst>
           </p:cNvPr>
@@ -8959,7 +8959,7 @@
           <p:cNvPr id="51" name="">
             <a:extLst xmlns:a="http://schemas.openxmlformats.org/drawingml/2006/main">
               <a:ext uri="{FF2B5EF4-FFF2-40B4-BE49-F238E27FC236}">
-                <a16:creationId xmlns:a16="http://schemas.microsoft.com/office/drawing/2014/main" id="{72A488F3-74FE-48EE-AE98-DAC996BEADDA}"/>
+                <a16:creationId xmlns:a16="http://schemas.microsoft.com/office/drawing/2014/main" id="{96305658-F801-4ED9-8D6B-24010D2419D3}"/>
               </a:ext>
             </a:extLst>
           </p:cNvPr>
@@ -8992,7 +8992,7 @@
           <p:cNvPr id="52" name="">
             <a:extLst xmlns:a="http://schemas.openxmlformats.org/drawingml/2006/main">
               <a:ext uri="{FF2B5EF4-FFF2-40B4-BE49-F238E27FC236}">
-                <a16:creationId xmlns:a16="http://schemas.microsoft.com/office/drawing/2014/main" id="{8F8AFF1E-DB6B-433A-9D46-021AE228865F}"/>
+                <a16:creationId xmlns:a16="http://schemas.microsoft.com/office/drawing/2014/main" id="{36A504C9-DFEB-46BC-ACB7-EB6833C1746B}"/>
               </a:ext>
             </a:extLst>
           </p:cNvPr>
@@ -9056,7 +9056,7 @@
           <p:cNvPr id="53" name="">
             <a:extLst xmlns:a="http://schemas.openxmlformats.org/drawingml/2006/main">
               <a:ext uri="{FF2B5EF4-FFF2-40B4-BE49-F238E27FC236}">
-                <a16:creationId xmlns:a16="http://schemas.microsoft.com/office/drawing/2014/main" id="{C7298F0C-2ADB-412E-A289-5CE36531F8B5}"/>
+                <a16:creationId xmlns:a16="http://schemas.microsoft.com/office/drawing/2014/main" id="{460E4041-594E-4AA6-921D-C794D9662C2C}"/>
               </a:ext>
             </a:extLst>
           </p:cNvPr>
@@ -9089,7 +9089,7 @@
           <p:cNvPr id="54" name="">
             <a:extLst xmlns:a="http://schemas.openxmlformats.org/drawingml/2006/main">
               <a:ext uri="{FF2B5EF4-FFF2-40B4-BE49-F238E27FC236}">
-                <a16:creationId xmlns:a16="http://schemas.microsoft.com/office/drawing/2014/main" id="{6FC79E2D-67D7-4ADA-BD45-E86AC4C00FB7}"/>
+                <a16:creationId xmlns:a16="http://schemas.microsoft.com/office/drawing/2014/main" id="{18ABA048-7AE9-41DB-A8CF-CE9630BFA5BF}"/>
               </a:ext>
             </a:extLst>
           </p:cNvPr>
@@ -9153,7 +9153,7 @@
           <p:cNvPr id="55" name="">
             <a:extLst xmlns:a="http://schemas.openxmlformats.org/drawingml/2006/main">
               <a:ext uri="{FF2B5EF4-FFF2-40B4-BE49-F238E27FC236}">
-                <a16:creationId xmlns:a16="http://schemas.microsoft.com/office/drawing/2014/main" id="{737EC2B2-0652-4F0A-AEBF-81BF048D449A}"/>
+                <a16:creationId xmlns:a16="http://schemas.microsoft.com/office/drawing/2014/main" id="{D57877B2-7562-4B31-9949-EE7BB032957D}"/>
               </a:ext>
             </a:extLst>
           </p:cNvPr>
@@ -9186,7 +9186,7 @@
           <p:cNvPr id="56" name="">
             <a:extLst xmlns:a="http://schemas.openxmlformats.org/drawingml/2006/main">
               <a:ext uri="{FF2B5EF4-FFF2-40B4-BE49-F238E27FC236}">
-                <a16:creationId xmlns:a16="http://schemas.microsoft.com/office/drawing/2014/main" id="{E33EA40A-F16B-46C4-902E-363E0A3D3883}"/>
+                <a16:creationId xmlns:a16="http://schemas.microsoft.com/office/drawing/2014/main" id="{34349D70-D64F-4AFA-951A-F5D4D2B27C9C}"/>
               </a:ext>
             </a:extLst>
           </p:cNvPr>
@@ -9250,7 +9250,7 @@
           <p:cNvPr id="57" name="">
             <a:extLst xmlns:a="http://schemas.openxmlformats.org/drawingml/2006/main">
               <a:ext uri="{FF2B5EF4-FFF2-40B4-BE49-F238E27FC236}">
-                <a16:creationId xmlns:a16="http://schemas.microsoft.com/office/drawing/2014/main" id="{B3A89544-FACE-4662-96F9-707012529898}"/>
+                <a16:creationId xmlns:a16="http://schemas.microsoft.com/office/drawing/2014/main" id="{B095795D-742E-4A17-BBE8-2E428A8818C8}"/>
               </a:ext>
             </a:extLst>
           </p:cNvPr>
@@ -9283,7 +9283,7 @@
           <p:cNvPr id="58" name="">
             <a:extLst xmlns:a="http://schemas.openxmlformats.org/drawingml/2006/main">
               <a:ext uri="{FF2B5EF4-FFF2-40B4-BE49-F238E27FC236}">
-                <a16:creationId xmlns:a16="http://schemas.microsoft.com/office/drawing/2014/main" id="{DA9CD486-ABAB-4C27-A1BB-7278B179C0F0}"/>
+                <a16:creationId xmlns:a16="http://schemas.microsoft.com/office/drawing/2014/main" id="{1A46FE6E-89BA-48FC-8DD8-397AD38B8787}"/>
               </a:ext>
             </a:extLst>
           </p:cNvPr>
@@ -9347,7 +9347,7 @@
           <p:cNvPr id="59" name="">
             <a:extLst xmlns:a="http://schemas.openxmlformats.org/drawingml/2006/main">
               <a:ext uri="{FF2B5EF4-FFF2-40B4-BE49-F238E27FC236}">
-                <a16:creationId xmlns:a16="http://schemas.microsoft.com/office/drawing/2014/main" id="{C55EB55C-77EB-49F6-A0B3-3A05D02B6D22}"/>
+                <a16:creationId xmlns:a16="http://schemas.microsoft.com/office/drawing/2014/main" id="{58DAF104-519F-4E66-A451-72C6A46F65BC}"/>
               </a:ext>
             </a:extLst>
           </p:cNvPr>
@@ -9380,7 +9380,7 @@
           <p:cNvPr id="60" name="">
             <a:extLst xmlns:a="http://schemas.openxmlformats.org/drawingml/2006/main">
               <a:ext uri="{FF2B5EF4-FFF2-40B4-BE49-F238E27FC236}">
-                <a16:creationId xmlns:a16="http://schemas.microsoft.com/office/drawing/2014/main" id="{E676A126-D89B-4050-9FE5-6403DF50526F}"/>
+                <a16:creationId xmlns:a16="http://schemas.microsoft.com/office/drawing/2014/main" id="{2AC3A976-BBBE-4954-8E61-09D0F29A3237}"/>
               </a:ext>
             </a:extLst>
           </p:cNvPr>
@@ -9444,7 +9444,7 @@
           <p:cNvPr id="61" name="">
             <a:extLst xmlns:a="http://schemas.openxmlformats.org/drawingml/2006/main">
               <a:ext uri="{FF2B5EF4-FFF2-40B4-BE49-F238E27FC236}">
-                <a16:creationId xmlns:a16="http://schemas.microsoft.com/office/drawing/2014/main" id="{D4935B76-CCF9-4DDF-801C-81C7B74910E0}"/>
+                <a16:creationId xmlns:a16="http://schemas.microsoft.com/office/drawing/2014/main" id="{6BBE8A97-87FA-459C-BC96-4E3FD88E98B7}"/>
               </a:ext>
             </a:extLst>
           </p:cNvPr>
@@ -9477,7 +9477,7 @@
           <p:cNvPr id="62" name="">
             <a:extLst xmlns:a="http://schemas.openxmlformats.org/drawingml/2006/main">
               <a:ext uri="{FF2B5EF4-FFF2-40B4-BE49-F238E27FC236}">
-                <a16:creationId xmlns:a16="http://schemas.microsoft.com/office/drawing/2014/main" id="{8C5AB233-3F4C-4DE3-A612-6F49E36EBDAF}"/>
+                <a16:creationId xmlns:a16="http://schemas.microsoft.com/office/drawing/2014/main" id="{0CB54A7B-D677-4112-BB62-E3C35F20C9C9}"/>
               </a:ext>
             </a:extLst>
           </p:cNvPr>
@@ -9541,7 +9541,7 @@
           <p:cNvPr id="63" name="">
             <a:extLst xmlns:a="http://schemas.openxmlformats.org/drawingml/2006/main">
               <a:ext uri="{FF2B5EF4-FFF2-40B4-BE49-F238E27FC236}">
-                <a16:creationId xmlns:a16="http://schemas.microsoft.com/office/drawing/2014/main" id="{4C4A1270-68FC-46EA-9CEB-176C5F6B5DA7}"/>
+                <a16:creationId xmlns:a16="http://schemas.microsoft.com/office/drawing/2014/main" id="{EEEC9C2E-27DA-4649-A828-EF7B14A356A7}"/>
               </a:ext>
             </a:extLst>
           </p:cNvPr>
@@ -9574,7 +9574,7 @@
           <p:cNvPr id="64" name="">
             <a:extLst xmlns:a="http://schemas.openxmlformats.org/drawingml/2006/main">
               <a:ext uri="{FF2B5EF4-FFF2-40B4-BE49-F238E27FC236}">
-                <a16:creationId xmlns:a16="http://schemas.microsoft.com/office/drawing/2014/main" id="{08AB22B4-B2BC-4B36-AE1E-69B4750AF4FD}"/>
+                <a16:creationId xmlns:a16="http://schemas.microsoft.com/office/drawing/2014/main" id="{0DFF972E-DCBE-4729-BE16-D2BBFAE8C454}"/>
               </a:ext>
             </a:extLst>
           </p:cNvPr>
@@ -9638,7 +9638,7 @@
           <p:cNvPr id="65" name="">
             <a:extLst xmlns:a="http://schemas.openxmlformats.org/drawingml/2006/main">
               <a:ext uri="{FF2B5EF4-FFF2-40B4-BE49-F238E27FC236}">
-                <a16:creationId xmlns:a16="http://schemas.microsoft.com/office/drawing/2014/main" id="{928D3F89-7428-4CB7-A9FB-306D1E18CCC6}"/>
+                <a16:creationId xmlns:a16="http://schemas.microsoft.com/office/drawing/2014/main" id="{C953AC0D-81CB-4893-80A1-54950C4E40AB}"/>
               </a:ext>
             </a:extLst>
           </p:cNvPr>
@@ -9671,7 +9671,7 @@
           <p:cNvPr id="66" name="">
             <a:extLst xmlns:a="http://schemas.openxmlformats.org/drawingml/2006/main">
               <a:ext uri="{FF2B5EF4-FFF2-40B4-BE49-F238E27FC236}">
-                <a16:creationId xmlns:a16="http://schemas.microsoft.com/office/drawing/2014/main" id="{5055EFD4-CCDB-418C-A72E-C38E039B3726}"/>
+                <a16:creationId xmlns:a16="http://schemas.microsoft.com/office/drawing/2014/main" id="{013448C6-FA3A-4365-A281-D58FE19A8BED}"/>
               </a:ext>
             </a:extLst>
           </p:cNvPr>
@@ -9735,7 +9735,7 @@
           <p:cNvPr id="67" name="">
             <a:extLst xmlns:a="http://schemas.openxmlformats.org/drawingml/2006/main">
               <a:ext uri="{FF2B5EF4-FFF2-40B4-BE49-F238E27FC236}">
-                <a16:creationId xmlns:a16="http://schemas.microsoft.com/office/drawing/2014/main" id="{07BB745E-54FA-417E-9692-F8E87C8B81D3}"/>
+                <a16:creationId xmlns:a16="http://schemas.microsoft.com/office/drawing/2014/main" id="{EA0B506D-818B-4676-82A3-9959657E2A79}"/>
               </a:ext>
             </a:extLst>
           </p:cNvPr>
@@ -9768,7 +9768,7 @@
           <p:cNvPr id="68" name="">
             <a:extLst xmlns:a="http://schemas.openxmlformats.org/drawingml/2006/main">
               <a:ext uri="{FF2B5EF4-FFF2-40B4-BE49-F238E27FC236}">
-                <a16:creationId xmlns:a16="http://schemas.microsoft.com/office/drawing/2014/main" id="{D948503C-FBA0-4802-8DC3-972B6AD645FD}"/>
+                <a16:creationId xmlns:a16="http://schemas.microsoft.com/office/drawing/2014/main" id="{02421ED4-7C80-4016-B7F5-9E906DA07E26}"/>
               </a:ext>
             </a:extLst>
           </p:cNvPr>
@@ -9832,7 +9832,7 @@
           <p:cNvPr id="69" name="">
             <a:extLst xmlns:a="http://schemas.openxmlformats.org/drawingml/2006/main">
               <a:ext uri="{FF2B5EF4-FFF2-40B4-BE49-F238E27FC236}">
-                <a16:creationId xmlns:a16="http://schemas.microsoft.com/office/drawing/2014/main" id="{D23B1F0A-215E-4E9C-B671-96BF38F54DF8}"/>
+                <a16:creationId xmlns:a16="http://schemas.microsoft.com/office/drawing/2014/main" id="{6CA2F45A-47F1-46EA-8B3F-4E78E20D4822}"/>
               </a:ext>
             </a:extLst>
           </p:cNvPr>
@@ -9865,7 +9865,7 @@
           <p:cNvPr id="70" name="">
             <a:extLst xmlns:a="http://schemas.openxmlformats.org/drawingml/2006/main">
               <a:ext uri="{FF2B5EF4-FFF2-40B4-BE49-F238E27FC236}">
-                <a16:creationId xmlns:a16="http://schemas.microsoft.com/office/drawing/2014/main" id="{91A4EF83-E1E8-4D4E-9995-5BA17B44718C}"/>
+                <a16:creationId xmlns:a16="http://schemas.microsoft.com/office/drawing/2014/main" id="{DCF429B4-83C0-4654-8E16-19FC1FCD9FBC}"/>
               </a:ext>
             </a:extLst>
           </p:cNvPr>
@@ -9929,7 +9929,7 @@
           <p:cNvPr id="71" name="">
             <a:extLst xmlns:a="http://schemas.openxmlformats.org/drawingml/2006/main">
               <a:ext uri="{FF2B5EF4-FFF2-40B4-BE49-F238E27FC236}">
-                <a16:creationId xmlns:a16="http://schemas.microsoft.com/office/drawing/2014/main" id="{AAEE0D67-F2CD-4FE1-8754-ED801874874A}"/>
+                <a16:creationId xmlns:a16="http://schemas.microsoft.com/office/drawing/2014/main" id="{F7036775-516E-4CAE-A9C9-4A5D19BB7302}"/>
               </a:ext>
             </a:extLst>
           </p:cNvPr>
@@ -9962,7 +9962,7 @@
           <p:cNvPr id="72" name="">
             <a:extLst xmlns:a="http://schemas.openxmlformats.org/drawingml/2006/main">
               <a:ext uri="{FF2B5EF4-FFF2-40B4-BE49-F238E27FC236}">
-                <a16:creationId xmlns:a16="http://schemas.microsoft.com/office/drawing/2014/main" id="{FB3727F7-E03B-499A-85C4-C1506002A223}"/>
+                <a16:creationId xmlns:a16="http://schemas.microsoft.com/office/drawing/2014/main" id="{A5DF8BD1-17A6-4A1F-9F85-9018E65C73CD}"/>
               </a:ext>
             </a:extLst>
           </p:cNvPr>
@@ -10026,7 +10026,7 @@
           <p:cNvPr id="73" name="">
             <a:extLst xmlns:a="http://schemas.openxmlformats.org/drawingml/2006/main">
               <a:ext uri="{FF2B5EF4-FFF2-40B4-BE49-F238E27FC236}">
-                <a16:creationId xmlns:a16="http://schemas.microsoft.com/office/drawing/2014/main" id="{1DB5F304-C979-45E7-8707-3FA64F67F4F8}"/>
+                <a16:creationId xmlns:a16="http://schemas.microsoft.com/office/drawing/2014/main" id="{76EE9488-7AE0-4384-BAB6-A602DCFA09BE}"/>
               </a:ext>
             </a:extLst>
           </p:cNvPr>
@@ -10059,7 +10059,7 @@
           <p:cNvPr id="74" name="">
             <a:extLst xmlns:a="http://schemas.openxmlformats.org/drawingml/2006/main">
               <a:ext uri="{FF2B5EF4-FFF2-40B4-BE49-F238E27FC236}">
-                <a16:creationId xmlns:a16="http://schemas.microsoft.com/office/drawing/2014/main" id="{66284167-7A78-4CF3-837F-7AF78140E40C}"/>
+                <a16:creationId xmlns:a16="http://schemas.microsoft.com/office/drawing/2014/main" id="{836FFEE0-559C-4ED9-87C5-2BC2E8DF495A}"/>
               </a:ext>
             </a:extLst>
           </p:cNvPr>
@@ -10092,7 +10092,7 @@
           <p:cNvPr id="75" name="">
             <a:extLst xmlns:a="http://schemas.openxmlformats.org/drawingml/2006/main">
               <a:ext uri="{FF2B5EF4-FFF2-40B4-BE49-F238E27FC236}">
-                <a16:creationId xmlns:a16="http://schemas.microsoft.com/office/drawing/2014/main" id="{D78357F4-1C82-475D-B4F8-633D8005D87E}"/>
+                <a16:creationId xmlns:a16="http://schemas.microsoft.com/office/drawing/2014/main" id="{C3AF5E5E-A13B-4F13-9933-18E0D29F16F9}"/>
               </a:ext>
             </a:extLst>
           </p:cNvPr>
@@ -10156,7 +10156,7 @@
           <p:cNvPr id="76" name="">
             <a:extLst xmlns:a="http://schemas.openxmlformats.org/drawingml/2006/main">
               <a:ext uri="{FF2B5EF4-FFF2-40B4-BE49-F238E27FC236}">
-                <a16:creationId xmlns:a16="http://schemas.microsoft.com/office/drawing/2014/main" id="{E5D2FDC3-73A6-4FBB-B59B-F2AB09156A1A}"/>
+                <a16:creationId xmlns:a16="http://schemas.microsoft.com/office/drawing/2014/main" id="{2B92D5B9-F3AC-470B-BF1F-C48E5E08E77B}"/>
               </a:ext>
             </a:extLst>
           </p:cNvPr>
@@ -10210,7 +10210,7 @@
                 <a:ea typeface="Aptos"/>
                 <a:cs typeface="Aptos"/>
               </a:rPr>
-              <a:t>峰值 ~396 tok/s</a:t>
+              <a:t>58 → 130 tok/s</a:t>
             </a:r>
           </a:p>
         </p:txBody>
@@ -10220,7 +10220,7 @@
           <p:cNvPr id="77" name="">
             <a:extLst xmlns:a="http://schemas.openxmlformats.org/drawingml/2006/main">
               <a:ext uri="{FF2B5EF4-FFF2-40B4-BE49-F238E27FC236}">
-                <a16:creationId xmlns:a16="http://schemas.microsoft.com/office/drawing/2014/main" id="{09CB706C-4C32-4FB9-91A6-952EA7590461}"/>
+                <a16:creationId xmlns:a16="http://schemas.microsoft.com/office/drawing/2014/main" id="{5A479FA0-3134-4475-99BC-E83A8FB2D2B8}"/>
               </a:ext>
             </a:extLst>
           </p:cNvPr>
@@ -10274,7 +10274,7 @@
                 <a:ea typeface="Aptos"/>
                 <a:cs typeface="Aptos"/>
               </a:rPr>
-              <a:t>2K ctx 实测最高约 396.4 tok/s；128K ctx 下降到约 290.6 tok/s</a:t>
+              <a:t>512 ctx 约 58 tok/s；64K/128K ctx 分别约 125/130 tok/s，长上下文首响仍慢</a:t>
             </a:r>
           </a:p>
         </p:txBody>
@@ -10284,7 +10284,7 @@
           <p:cNvPr id="78" name="">
             <a:extLst xmlns:a="http://schemas.openxmlformats.org/drawingml/2006/main">
               <a:ext uri="{FF2B5EF4-FFF2-40B4-BE49-F238E27FC236}">
-                <a16:creationId xmlns:a16="http://schemas.microsoft.com/office/drawing/2014/main" id="{14FB1037-F9E2-4457-B6C3-E8769FA37788}"/>
+                <a16:creationId xmlns:a16="http://schemas.microsoft.com/office/drawing/2014/main" id="{2316C99D-9F5F-4936-B1C4-71D57A6A3169}"/>
               </a:ext>
             </a:extLst>
           </p:cNvPr>
@@ -10317,7 +10317,7 @@
           <p:cNvPr id="79" name="">
             <a:extLst xmlns:a="http://schemas.openxmlformats.org/drawingml/2006/main">
               <a:ext uri="{FF2B5EF4-FFF2-40B4-BE49-F238E27FC236}">
-                <a16:creationId xmlns:a16="http://schemas.microsoft.com/office/drawing/2014/main" id="{1F5BD0FF-9DB7-4418-8B0D-9AE054EC8E73}"/>
+                <a16:creationId xmlns:a16="http://schemas.microsoft.com/office/drawing/2014/main" id="{69F4D0E7-AB98-4742-B615-DDC628C2FC6F}"/>
               </a:ext>
             </a:extLst>
           </p:cNvPr>
@@ -10350,7 +10350,7 @@
           <p:cNvPr id="80" name="">
             <a:extLst xmlns:a="http://schemas.openxmlformats.org/drawingml/2006/main">
               <a:ext uri="{FF2B5EF4-FFF2-40B4-BE49-F238E27FC236}">
-                <a16:creationId xmlns:a16="http://schemas.microsoft.com/office/drawing/2014/main" id="{DB2303D0-4D90-4BEE-B8AC-1C5D5981673F}"/>
+                <a16:creationId xmlns:a16="http://schemas.microsoft.com/office/drawing/2014/main" id="{E307A8A3-0759-43E8-A975-B12BCD505F09}"/>
               </a:ext>
             </a:extLst>
           </p:cNvPr>
@@ -10414,7 +10414,7 @@
           <p:cNvPr id="81" name="">
             <a:extLst xmlns:a="http://schemas.openxmlformats.org/drawingml/2006/main">
               <a:ext uri="{FF2B5EF4-FFF2-40B4-BE49-F238E27FC236}">
-                <a16:creationId xmlns:a16="http://schemas.microsoft.com/office/drawing/2014/main" id="{61A35267-18E2-4326-9AD3-5D89679828D0}"/>
+                <a16:creationId xmlns:a16="http://schemas.microsoft.com/office/drawing/2014/main" id="{F7FEB7A9-50A9-47E1-85AA-DADA4DF57419}"/>
               </a:ext>
             </a:extLst>
           </p:cNvPr>
@@ -10468,7 +10468,7 @@
                 <a:ea typeface="Aptos"/>
                 <a:cs typeface="Aptos"/>
               </a:rPr>
-              <a:t>10.7–16.1 tok/s</a:t>
+              <a:t>8.15 → 4.2 tok/s</a:t>
             </a:r>
           </a:p>
         </p:txBody>
@@ -10478,7 +10478,7 @@
           <p:cNvPr id="82" name="">
             <a:extLst xmlns:a="http://schemas.openxmlformats.org/drawingml/2006/main">
               <a:ext uri="{FF2B5EF4-FFF2-40B4-BE49-F238E27FC236}">
-                <a16:creationId xmlns:a16="http://schemas.microsoft.com/office/drawing/2014/main" id="{B0691C0B-0C77-479C-8F02-D5987507B3DF}"/>
+                <a16:creationId xmlns:a16="http://schemas.microsoft.com/office/drawing/2014/main" id="{B525D5CE-E20E-4537-9DDD-5754FCD1BEEF}"/>
               </a:ext>
             </a:extLst>
           </p:cNvPr>
@@ -10532,7 +10532,7 @@
                 <a:ea typeface="Aptos"/>
                 <a:cs typeface="Aptos"/>
               </a:rPr>
-              <a:t>128 ctx 约 16.1 tok/s；128K ctx 约 10.7 tok/s，仍明显受长上下文影响</a:t>
+              <a:t>512 ctx 约 8.15 tok/s；64K ctx 约 5.3 tok/s；128K ctx 约 4.2 tok/s</a:t>
             </a:r>
           </a:p>
         </p:txBody>
@@ -10542,7 +10542,7 @@
           <p:cNvPr id="83" name="">
             <a:extLst xmlns:a="http://schemas.openxmlformats.org/drawingml/2006/main">
               <a:ext uri="{FF2B5EF4-FFF2-40B4-BE49-F238E27FC236}">
-                <a16:creationId xmlns:a16="http://schemas.microsoft.com/office/drawing/2014/main" id="{B1C60AB0-D12E-4DE1-B758-751B2E5B1B85}"/>
+                <a16:creationId xmlns:a16="http://schemas.microsoft.com/office/drawing/2014/main" id="{2175598A-6B40-4908-A1CB-72346CA91128}"/>
               </a:ext>
             </a:extLst>
           </p:cNvPr>
@@ -10575,7 +10575,7 @@
           <p:cNvPr id="84" name="">
             <a:extLst xmlns:a="http://schemas.openxmlformats.org/drawingml/2006/main">
               <a:ext uri="{FF2B5EF4-FFF2-40B4-BE49-F238E27FC236}">
-                <a16:creationId xmlns:a16="http://schemas.microsoft.com/office/drawing/2014/main" id="{39A641D1-7A1B-476F-9A48-8E0E01B319F7}"/>
+                <a16:creationId xmlns:a16="http://schemas.microsoft.com/office/drawing/2014/main" id="{2C193EBB-0F98-4D0F-A5C8-7531F8A99D47}"/>
               </a:ext>
             </a:extLst>
           </p:cNvPr>
@@ -10608,7 +10608,7 @@
           <p:cNvPr id="85" name="">
             <a:extLst xmlns:a="http://schemas.openxmlformats.org/drawingml/2006/main">
               <a:ext uri="{FF2B5EF4-FFF2-40B4-BE49-F238E27FC236}">
-                <a16:creationId xmlns:a16="http://schemas.microsoft.com/office/drawing/2014/main" id="{10C6BC9E-C219-4295-8732-7603E46D5FDF}"/>
+                <a16:creationId xmlns:a16="http://schemas.microsoft.com/office/drawing/2014/main" id="{5FDBEDBF-6E65-45D2-8027-1E6007EA581D}"/>
               </a:ext>
             </a:extLst>
           </p:cNvPr>
@@ -10672,7 +10672,7 @@
           <p:cNvPr id="86" name="">
             <a:extLst xmlns:a="http://schemas.openxmlformats.org/drawingml/2006/main">
               <a:ext uri="{FF2B5EF4-FFF2-40B4-BE49-F238E27FC236}">
-                <a16:creationId xmlns:a16="http://schemas.microsoft.com/office/drawing/2014/main" id="{766AE7A4-17EA-4CCE-9096-7C2EBA57F67E}"/>
+                <a16:creationId xmlns:a16="http://schemas.microsoft.com/office/drawing/2014/main" id="{E6694805-D1B3-4AED-82F0-CACCE3E26063}"/>
               </a:ext>
             </a:extLst>
           </p:cNvPr>
@@ -10736,7 +10736,7 @@
           <p:cNvPr id="87" name="">
             <a:extLst xmlns:a="http://schemas.openxmlformats.org/drawingml/2006/main">
               <a:ext uri="{FF2B5EF4-FFF2-40B4-BE49-F238E27FC236}">
-                <a16:creationId xmlns:a16="http://schemas.microsoft.com/office/drawing/2014/main" id="{C1CDFCB8-80E1-4F92-B78C-003D2ED7CB1F}"/>
+                <a16:creationId xmlns:a16="http://schemas.microsoft.com/office/drawing/2014/main" id="{FAE53F75-CA0E-44B6-82FD-A7F12D655E6E}"/>
               </a:ext>
             </a:extLst>
           </p:cNvPr>
@@ -10800,7 +10800,7 @@
           <p:cNvPr id="88" name="">
             <a:extLst xmlns:a="http://schemas.openxmlformats.org/drawingml/2006/main">
               <a:ext uri="{FF2B5EF4-FFF2-40B4-BE49-F238E27FC236}">
-                <a16:creationId xmlns:a16="http://schemas.microsoft.com/office/drawing/2014/main" id="{01A4607F-1EB3-42C5-A1BB-311F1240340D}"/>
+                <a16:creationId xmlns:a16="http://schemas.microsoft.com/office/drawing/2014/main" id="{472C3B2A-F974-4F67-A73B-473875AAEE67}"/>
               </a:ext>
             </a:extLst>
           </p:cNvPr>
@@ -10833,7 +10833,7 @@
           <p:cNvPr id="89" name="">
             <a:extLst xmlns:a="http://schemas.openxmlformats.org/drawingml/2006/main">
               <a:ext uri="{FF2B5EF4-FFF2-40B4-BE49-F238E27FC236}">
-                <a16:creationId xmlns:a16="http://schemas.microsoft.com/office/drawing/2014/main" id="{3E2E90DE-C562-4C18-966D-C53ECF805E2C}"/>
+                <a16:creationId xmlns:a16="http://schemas.microsoft.com/office/drawing/2014/main" id="{BD4FAC01-19EC-4A82-8258-6E9BA02F6013}"/>
               </a:ext>
             </a:extLst>
           </p:cNvPr>
@@ -10897,7 +10897,7 @@
           <p:cNvPr id="90" name="">
             <a:extLst xmlns:a="http://schemas.openxmlformats.org/drawingml/2006/main">
               <a:ext uri="{FF2B5EF4-FFF2-40B4-BE49-F238E27FC236}">
-                <a16:creationId xmlns:a16="http://schemas.microsoft.com/office/drawing/2014/main" id="{020BB564-2CDB-4469-AA5D-C594AFC10EA7}"/>
+                <a16:creationId xmlns:a16="http://schemas.microsoft.com/office/drawing/2014/main" id="{472A1908-D0F0-4914-8D28-CBD415581A39}"/>
               </a:ext>
             </a:extLst>
           </p:cNvPr>
@@ -10930,7 +10930,7 @@
           <p:cNvPr id="91" name="">
             <a:extLst xmlns:a="http://schemas.openxmlformats.org/drawingml/2006/main">
               <a:ext uri="{FF2B5EF4-FFF2-40B4-BE49-F238E27FC236}">
-                <a16:creationId xmlns:a16="http://schemas.microsoft.com/office/drawing/2014/main" id="{BD7F9450-26AD-4402-A44E-311230F0A551}"/>
+                <a16:creationId xmlns:a16="http://schemas.microsoft.com/office/drawing/2014/main" id="{C22A5607-22B6-4CE4-91DE-F6D46C969F8A}"/>
               </a:ext>
             </a:extLst>
           </p:cNvPr>
@@ -10963,7 +10963,7 @@
           <p:cNvPr id="92" name="">
             <a:extLst xmlns:a="http://schemas.openxmlformats.org/drawingml/2006/main">
               <a:ext uri="{FF2B5EF4-FFF2-40B4-BE49-F238E27FC236}">
-                <a16:creationId xmlns:a16="http://schemas.microsoft.com/office/drawing/2014/main" id="{A7BE127A-91A9-402F-8169-DAB23A04669B}"/>
+                <a16:creationId xmlns:a16="http://schemas.microsoft.com/office/drawing/2014/main" id="{EF70846F-27F5-4208-B83B-0EE3AEBCBECF}"/>
               </a:ext>
             </a:extLst>
           </p:cNvPr>
@@ -11017,7 +11017,7 @@
                 <a:ea typeface="Aptos"/>
                 <a:cs typeface="Aptos"/>
               </a:rPr>
-              <a:t>代表性实测数据：短上下文可用，长上下文与复杂任务仍明显掉体验</a:t>
+              <a:t>代表性实测数据：上下文增大后 decode 明显下降，整体仍达不到高质量体验</a:t>
             </a:r>
           </a:p>
         </p:txBody>
@@ -11027,7 +11027,7 @@
           <p:cNvPr id="93" name="">
             <a:extLst xmlns:a="http://schemas.openxmlformats.org/drawingml/2006/main">
               <a:ext uri="{FF2B5EF4-FFF2-40B4-BE49-F238E27FC236}">
-                <a16:creationId xmlns:a16="http://schemas.microsoft.com/office/drawing/2014/main" id="{B3767081-4587-46AC-BFB6-2ED2C713B06A}"/>
+                <a16:creationId xmlns:a16="http://schemas.microsoft.com/office/drawing/2014/main" id="{F223AF3E-9050-4F75-B80C-6DCEA9851CA7}"/>
               </a:ext>
             </a:extLst>
           </p:cNvPr>
@@ -11060,7 +11060,7 @@
           <p:cNvPr id="94" name="">
             <a:extLst xmlns:a="http://schemas.openxmlformats.org/drawingml/2006/main">
               <a:ext uri="{FF2B5EF4-FFF2-40B4-BE49-F238E27FC236}">
-                <a16:creationId xmlns:a16="http://schemas.microsoft.com/office/drawing/2014/main" id="{92A451A8-597E-4F2A-B174-205E72585510}"/>
+                <a16:creationId xmlns:a16="http://schemas.microsoft.com/office/drawing/2014/main" id="{62E7FCF1-BE2D-4242-A91C-99CFDA41AF6C}"/>
               </a:ext>
             </a:extLst>
           </p:cNvPr>
@@ -11124,7 +11124,7 @@
           <p:cNvPr id="95" name="">
             <a:extLst xmlns:a="http://schemas.openxmlformats.org/drawingml/2006/main">
               <a:ext uri="{FF2B5EF4-FFF2-40B4-BE49-F238E27FC236}">
-                <a16:creationId xmlns:a16="http://schemas.microsoft.com/office/drawing/2014/main" id="{E18D3C84-A79A-4E74-81F2-C8B8ABB76ED0}"/>
+                <a16:creationId xmlns:a16="http://schemas.microsoft.com/office/drawing/2014/main" id="{06A7E7F8-023C-42DF-8FCA-7B44915F80E2}"/>
               </a:ext>
             </a:extLst>
           </p:cNvPr>
@@ -11157,7 +11157,7 @@
           <p:cNvPr id="96" name="">
             <a:extLst xmlns:a="http://schemas.openxmlformats.org/drawingml/2006/main">
               <a:ext uri="{FF2B5EF4-FFF2-40B4-BE49-F238E27FC236}">
-                <a16:creationId xmlns:a16="http://schemas.microsoft.com/office/drawing/2014/main" id="{F99ECE26-BF49-4014-BC01-E63A50D7B54A}"/>
+                <a16:creationId xmlns:a16="http://schemas.microsoft.com/office/drawing/2014/main" id="{9AB9F340-B5CB-4F41-9A91-7D35A4A3E9E2}"/>
               </a:ext>
             </a:extLst>
           </p:cNvPr>
@@ -11221,7 +11221,7 @@
           <p:cNvPr id="97" name="">
             <a:extLst xmlns:a="http://schemas.openxmlformats.org/drawingml/2006/main">
               <a:ext uri="{FF2B5EF4-FFF2-40B4-BE49-F238E27FC236}">
-                <a16:creationId xmlns:a16="http://schemas.microsoft.com/office/drawing/2014/main" id="{1FCD30A1-91E6-4280-BD83-2BAE49AFC545}"/>
+                <a16:creationId xmlns:a16="http://schemas.microsoft.com/office/drawing/2014/main" id="{E885D1FE-E773-4698-B9FB-76B36CF4F621}"/>
               </a:ext>
             </a:extLst>
           </p:cNvPr>
@@ -11254,7 +11254,7 @@
           <p:cNvPr id="98" name="">
             <a:extLst xmlns:a="http://schemas.openxmlformats.org/drawingml/2006/main">
               <a:ext uri="{FF2B5EF4-FFF2-40B4-BE49-F238E27FC236}">
-                <a16:creationId xmlns:a16="http://schemas.microsoft.com/office/drawing/2014/main" id="{82BC9FA0-18A4-4E43-B267-4BD6CE26C32D}"/>
+                <a16:creationId xmlns:a16="http://schemas.microsoft.com/office/drawing/2014/main" id="{28C89FBD-E6B1-4C81-BE65-819E6337A83E}"/>
               </a:ext>
             </a:extLst>
           </p:cNvPr>
@@ -11318,7 +11318,7 @@
           <p:cNvPr id="99" name="">
             <a:extLst xmlns:a="http://schemas.openxmlformats.org/drawingml/2006/main">
               <a:ext uri="{FF2B5EF4-FFF2-40B4-BE49-F238E27FC236}">
-                <a16:creationId xmlns:a16="http://schemas.microsoft.com/office/drawing/2014/main" id="{4440C46F-1D41-4DCE-AAE1-B87D7EBB2E72}"/>
+                <a16:creationId xmlns:a16="http://schemas.microsoft.com/office/drawing/2014/main" id="{5451731A-BA3E-441F-ADEC-604628C8D451}"/>
               </a:ext>
             </a:extLst>
           </p:cNvPr>
@@ -11351,7 +11351,7 @@
           <p:cNvPr id="100" name="">
             <a:extLst xmlns:a="http://schemas.openxmlformats.org/drawingml/2006/main">
               <a:ext uri="{FF2B5EF4-FFF2-40B4-BE49-F238E27FC236}">
-                <a16:creationId xmlns:a16="http://schemas.microsoft.com/office/drawing/2014/main" id="{620D2043-65A6-4FDF-8ADC-8548E68656CA}"/>
+                <a16:creationId xmlns:a16="http://schemas.microsoft.com/office/drawing/2014/main" id="{24396243-EC36-4674-BA8C-66EAAF44A345}"/>
               </a:ext>
             </a:extLst>
           </p:cNvPr>
@@ -11415,7 +11415,7 @@
           <p:cNvPr id="101" name="">
             <a:extLst xmlns:a="http://schemas.openxmlformats.org/drawingml/2006/main">
               <a:ext uri="{FF2B5EF4-FFF2-40B4-BE49-F238E27FC236}">
-                <a16:creationId xmlns:a16="http://schemas.microsoft.com/office/drawing/2014/main" id="{44255747-39B0-4821-8BC5-74C96F465941}"/>
+                <a16:creationId xmlns:a16="http://schemas.microsoft.com/office/drawing/2014/main" id="{C6DC8B15-A376-4A54-AB16-01CA5B8F10FD}"/>
               </a:ext>
             </a:extLst>
           </p:cNvPr>
@@ -11448,7 +11448,7 @@
           <p:cNvPr id="102" name="">
             <a:extLst xmlns:a="http://schemas.openxmlformats.org/drawingml/2006/main">
               <a:ext uri="{FF2B5EF4-FFF2-40B4-BE49-F238E27FC236}">
-                <a16:creationId xmlns:a16="http://schemas.microsoft.com/office/drawing/2014/main" id="{44C6F4EC-5171-41D5-A18A-37FD53EC290D}"/>
+                <a16:creationId xmlns:a16="http://schemas.microsoft.com/office/drawing/2014/main" id="{4F323D2C-2179-41C8-BF5C-B055A75A6A13}"/>
               </a:ext>
             </a:extLst>
           </p:cNvPr>
@@ -11512,7 +11512,7 @@
           <p:cNvPr id="103" name="">
             <a:extLst xmlns:a="http://schemas.openxmlformats.org/drawingml/2006/main">
               <a:ext uri="{FF2B5EF4-FFF2-40B4-BE49-F238E27FC236}">
-                <a16:creationId xmlns:a16="http://schemas.microsoft.com/office/drawing/2014/main" id="{3511F1B1-7052-4407-879F-3603D8E87111}"/>
+                <a16:creationId xmlns:a16="http://schemas.microsoft.com/office/drawing/2014/main" id="{F17EB4B0-623E-41C3-A2A3-1B387B0A8F85}"/>
               </a:ext>
             </a:extLst>
           </p:cNvPr>
@@ -11545,7 +11545,7 @@
           <p:cNvPr id="104" name="">
             <a:extLst xmlns:a="http://schemas.openxmlformats.org/drawingml/2006/main">
               <a:ext uri="{FF2B5EF4-FFF2-40B4-BE49-F238E27FC236}">
-                <a16:creationId xmlns:a16="http://schemas.microsoft.com/office/drawing/2014/main" id="{4013CAC0-87CF-4B95-AE83-509114C91CA2}"/>
+                <a16:creationId xmlns:a16="http://schemas.microsoft.com/office/drawing/2014/main" id="{AC76DB29-63D4-454C-B732-F2F86AAC4BD7}"/>
               </a:ext>
             </a:extLst>
           </p:cNvPr>
@@ -11609,7 +11609,7 @@
           <p:cNvPr id="105" name="">
             <a:extLst xmlns:a="http://schemas.openxmlformats.org/drawingml/2006/main">
               <a:ext uri="{FF2B5EF4-FFF2-40B4-BE49-F238E27FC236}">
-                <a16:creationId xmlns:a16="http://schemas.microsoft.com/office/drawing/2014/main" id="{AA375854-EAD8-4F87-A979-2A6D76C1B5D6}"/>
+                <a16:creationId xmlns:a16="http://schemas.microsoft.com/office/drawing/2014/main" id="{9C8A9323-0A2F-4DBD-8612-BE3471F2E55B}"/>
               </a:ext>
             </a:extLst>
           </p:cNvPr>
@@ -11642,7 +11642,7 @@
           <p:cNvPr id="106" name="">
             <a:extLst xmlns:a="http://schemas.openxmlformats.org/drawingml/2006/main">
               <a:ext uri="{FF2B5EF4-FFF2-40B4-BE49-F238E27FC236}">
-                <a16:creationId xmlns:a16="http://schemas.microsoft.com/office/drawing/2014/main" id="{7B6DEC97-1387-4773-BFAE-43B7F706F06F}"/>
+                <a16:creationId xmlns:a16="http://schemas.microsoft.com/office/drawing/2014/main" id="{A84CEF90-CAA5-4ACA-924C-B1D8CD6E9100}"/>
               </a:ext>
             </a:extLst>
           </p:cNvPr>
@@ -11696,7 +11696,7 @@
                 <a:ea typeface="Aptos"/>
                 <a:cs typeface="Aptos"/>
               </a:rPr>
-              <a:t>128</a:t>
+              <a:t>512</a:t>
             </a:r>
           </a:p>
         </p:txBody>
@@ -11706,7 +11706,7 @@
           <p:cNvPr id="107" name="">
             <a:extLst xmlns:a="http://schemas.openxmlformats.org/drawingml/2006/main">
               <a:ext uri="{FF2B5EF4-FFF2-40B4-BE49-F238E27FC236}">
-                <a16:creationId xmlns:a16="http://schemas.microsoft.com/office/drawing/2014/main" id="{8877C7A4-EE3D-4FBC-9C0A-81C6B9A84E6F}"/>
+                <a16:creationId xmlns:a16="http://schemas.microsoft.com/office/drawing/2014/main" id="{A194AA58-B150-4817-84A3-EE094A9DBB14}"/>
               </a:ext>
             </a:extLst>
           </p:cNvPr>
@@ -11739,7 +11739,7 @@
           <p:cNvPr id="108" name="">
             <a:extLst xmlns:a="http://schemas.openxmlformats.org/drawingml/2006/main">
               <a:ext uri="{FF2B5EF4-FFF2-40B4-BE49-F238E27FC236}">
-                <a16:creationId xmlns:a16="http://schemas.microsoft.com/office/drawing/2014/main" id="{7D5EE7D9-3384-4165-B50B-CB3103DCED50}"/>
+                <a16:creationId xmlns:a16="http://schemas.microsoft.com/office/drawing/2014/main" id="{E4CBBB29-BA26-4151-9D05-5EAB4FA057FB}"/>
               </a:ext>
             </a:extLst>
           </p:cNvPr>
@@ -11793,7 +11793,7 @@
                 <a:ea typeface="Aptos"/>
                 <a:cs typeface="Aptos"/>
               </a:rPr>
-              <a:t>148.98</a:t>
+              <a:t>58</a:t>
             </a:r>
           </a:p>
         </p:txBody>
@@ -11803,7 +11803,7 @@
           <p:cNvPr id="109" name="">
             <a:extLst xmlns:a="http://schemas.openxmlformats.org/drawingml/2006/main">
               <a:ext uri="{FF2B5EF4-FFF2-40B4-BE49-F238E27FC236}">
-                <a16:creationId xmlns:a16="http://schemas.microsoft.com/office/drawing/2014/main" id="{E87B3238-3D95-49EC-A58C-62BF6E3ABF73}"/>
+                <a16:creationId xmlns:a16="http://schemas.microsoft.com/office/drawing/2014/main" id="{C7513EAE-AB64-4A7E-9793-E155DB00CADF}"/>
               </a:ext>
             </a:extLst>
           </p:cNvPr>
@@ -11836,7 +11836,7 @@
           <p:cNvPr id="110" name="">
             <a:extLst xmlns:a="http://schemas.openxmlformats.org/drawingml/2006/main">
               <a:ext uri="{FF2B5EF4-FFF2-40B4-BE49-F238E27FC236}">
-                <a16:creationId xmlns:a16="http://schemas.microsoft.com/office/drawing/2014/main" id="{3BF9BBE5-32A8-4DEC-969C-4A6B50F70E5D}"/>
+                <a16:creationId xmlns:a16="http://schemas.microsoft.com/office/drawing/2014/main" id="{C01B2FB8-E966-4DD9-AE54-F4A10F218A84}"/>
               </a:ext>
             </a:extLst>
           </p:cNvPr>
@@ -11890,7 +11890,7 @@
                 <a:ea typeface="Aptos"/>
                 <a:cs typeface="Aptos"/>
               </a:rPr>
-              <a:t>16.12</a:t>
+              <a:t>8.15</a:t>
             </a:r>
           </a:p>
         </p:txBody>
@@ -11900,7 +11900,7 @@
           <p:cNvPr id="111" name="">
             <a:extLst xmlns:a="http://schemas.openxmlformats.org/drawingml/2006/main">
               <a:ext uri="{FF2B5EF4-FFF2-40B4-BE49-F238E27FC236}">
-                <a16:creationId xmlns:a16="http://schemas.microsoft.com/office/drawing/2014/main" id="{76268660-E7D8-4B51-9260-B1AA1627121E}"/>
+                <a16:creationId xmlns:a16="http://schemas.microsoft.com/office/drawing/2014/main" id="{4069484E-548C-4D2A-BE36-72C6F1118BFE}"/>
               </a:ext>
             </a:extLst>
           </p:cNvPr>
@@ -11933,7 +11933,7 @@
           <p:cNvPr id="112" name="">
             <a:extLst xmlns:a="http://schemas.openxmlformats.org/drawingml/2006/main">
               <a:ext uri="{FF2B5EF4-FFF2-40B4-BE49-F238E27FC236}">
-                <a16:creationId xmlns:a16="http://schemas.microsoft.com/office/drawing/2014/main" id="{DBE2DCE4-3257-4B99-9F0F-E6A8E8A15FB9}"/>
+                <a16:creationId xmlns:a16="http://schemas.microsoft.com/office/drawing/2014/main" id="{8AD44A15-B17F-42FF-9F8C-ACB23E62C36A}"/>
               </a:ext>
             </a:extLst>
           </p:cNvPr>
@@ -11987,7 +11987,7 @@
                 <a:ea typeface="Aptos"/>
                 <a:cs typeface="Aptos"/>
               </a:rPr>
-              <a:t>首响可接受，但 prefill 还未进入甜点区</a:t>
+              <a:t>短上下文也未达到产品可接受甜点区</a:t>
             </a:r>
           </a:p>
         </p:txBody>
@@ -11997,7 +11997,7 @@
           <p:cNvPr id="113" name="">
             <a:extLst xmlns:a="http://schemas.openxmlformats.org/drawingml/2006/main">
               <a:ext uri="{FF2B5EF4-FFF2-40B4-BE49-F238E27FC236}">
-                <a16:creationId xmlns:a16="http://schemas.microsoft.com/office/drawing/2014/main" id="{370474BF-E4DE-441D-98DA-434AAF2A70E6}"/>
+                <a16:creationId xmlns:a16="http://schemas.microsoft.com/office/drawing/2014/main" id="{4B81B4C4-1294-4AD0-B441-A8B7DE975DD4}"/>
               </a:ext>
             </a:extLst>
           </p:cNvPr>
@@ -12030,7 +12030,7 @@
           <p:cNvPr id="114" name="">
             <a:extLst xmlns:a="http://schemas.openxmlformats.org/drawingml/2006/main">
               <a:ext uri="{FF2B5EF4-FFF2-40B4-BE49-F238E27FC236}">
-                <a16:creationId xmlns:a16="http://schemas.microsoft.com/office/drawing/2014/main" id="{8CEBB1C3-447A-42B2-B63E-954A53703258}"/>
+                <a16:creationId xmlns:a16="http://schemas.microsoft.com/office/drawing/2014/main" id="{D464E42F-224A-4695-8BFB-965574A58A6C}"/>
               </a:ext>
             </a:extLst>
           </p:cNvPr>
@@ -12084,7 +12084,7 @@
                 <a:ea typeface="Aptos"/>
                 <a:cs typeface="Aptos"/>
               </a:rPr>
-              <a:t>轻问答可用，回复速度一般</a:t>
+              <a:t>首响和回复都偏慢</a:t>
             </a:r>
           </a:p>
         </p:txBody>
@@ -12094,7 +12094,7 @@
           <p:cNvPr id="115" name="">
             <a:extLst xmlns:a="http://schemas.openxmlformats.org/drawingml/2006/main">
               <a:ext uri="{FF2B5EF4-FFF2-40B4-BE49-F238E27FC236}">
-                <a16:creationId xmlns:a16="http://schemas.microsoft.com/office/drawing/2014/main" id="{7827563C-DB53-40A0-9355-FE0DCA486575}"/>
+                <a16:creationId xmlns:a16="http://schemas.microsoft.com/office/drawing/2014/main" id="{76B07ECA-3B2A-4BF9-A868-1B16FF0C937A}"/>
               </a:ext>
             </a:extLst>
           </p:cNvPr>
@@ -12127,7 +12127,7 @@
           <p:cNvPr id="116" name="">
             <a:extLst xmlns:a="http://schemas.openxmlformats.org/drawingml/2006/main">
               <a:ext uri="{FF2B5EF4-FFF2-40B4-BE49-F238E27FC236}">
-                <a16:creationId xmlns:a16="http://schemas.microsoft.com/office/drawing/2014/main" id="{273CA050-6616-401F-A73E-FAA8DA7B8280}"/>
+                <a16:creationId xmlns:a16="http://schemas.microsoft.com/office/drawing/2014/main" id="{516EFCAB-5FC1-4015-8573-19ED9753265E}"/>
               </a:ext>
             </a:extLst>
           </p:cNvPr>
@@ -12181,7 +12181,7 @@
                 <a:ea typeface="Aptos"/>
                 <a:cs typeface="Aptos"/>
               </a:rPr>
-              <a:t>证明本地跑通了，但还不是高质量体验</a:t>
+              <a:t>说明当前版本已能跑通，但短上下文体验仍不够强</a:t>
             </a:r>
           </a:p>
         </p:txBody>
@@ -12191,7 +12191,7 @@
           <p:cNvPr id="117" name="">
             <a:extLst xmlns:a="http://schemas.openxmlformats.org/drawingml/2006/main">
               <a:ext uri="{FF2B5EF4-FFF2-40B4-BE49-F238E27FC236}">
-                <a16:creationId xmlns:a16="http://schemas.microsoft.com/office/drawing/2014/main" id="{C3B2448F-D84C-4524-8E97-B13EB58EB3A5}"/>
+                <a16:creationId xmlns:a16="http://schemas.microsoft.com/office/drawing/2014/main" id="{734CD8CF-55DC-483B-91FF-E5BBB59562D9}"/>
               </a:ext>
             </a:extLst>
           </p:cNvPr>
@@ -12224,7 +12224,7 @@
           <p:cNvPr id="118" name="">
             <a:extLst xmlns:a="http://schemas.openxmlformats.org/drawingml/2006/main">
               <a:ext uri="{FF2B5EF4-FFF2-40B4-BE49-F238E27FC236}">
-                <a16:creationId xmlns:a16="http://schemas.microsoft.com/office/drawing/2014/main" id="{376BF846-3302-4C84-BC6A-480BB57177A8}"/>
+                <a16:creationId xmlns:a16="http://schemas.microsoft.com/office/drawing/2014/main" id="{F7E692F9-7F7E-4212-BB04-7CCF9488E398}"/>
               </a:ext>
             </a:extLst>
           </p:cNvPr>
@@ -12278,7 +12278,7 @@
                 <a:ea typeface="Aptos"/>
                 <a:cs typeface="Aptos"/>
               </a:rPr>
-              <a:t>2,048</a:t>
+              <a:t>64K</a:t>
             </a:r>
           </a:p>
         </p:txBody>
@@ -12288,7 +12288,7 @@
           <p:cNvPr id="119" name="">
             <a:extLst xmlns:a="http://schemas.openxmlformats.org/drawingml/2006/main">
               <a:ext uri="{FF2B5EF4-FFF2-40B4-BE49-F238E27FC236}">
-                <a16:creationId xmlns:a16="http://schemas.microsoft.com/office/drawing/2014/main" id="{8B006A8A-990B-4A16-B666-A246B4EF0FBF}"/>
+                <a16:creationId xmlns:a16="http://schemas.microsoft.com/office/drawing/2014/main" id="{A493B242-8C1C-4721-908A-C051E8A63ACB}"/>
               </a:ext>
             </a:extLst>
           </p:cNvPr>
@@ -12321,7 +12321,7 @@
           <p:cNvPr id="120" name="">
             <a:extLst xmlns:a="http://schemas.openxmlformats.org/drawingml/2006/main">
               <a:ext uri="{FF2B5EF4-FFF2-40B4-BE49-F238E27FC236}">
-                <a16:creationId xmlns:a16="http://schemas.microsoft.com/office/drawing/2014/main" id="{87C2F4E6-1088-45F8-AE93-43E9D500DD12}"/>
+                <a16:creationId xmlns:a16="http://schemas.microsoft.com/office/drawing/2014/main" id="{26EE33E0-EA90-4A2F-8DDC-C0574E942512}"/>
               </a:ext>
             </a:extLst>
           </p:cNvPr>
@@ -12375,7 +12375,7 @@
                 <a:ea typeface="Aptos"/>
                 <a:cs typeface="Aptos"/>
               </a:rPr>
-              <a:t>396.40</a:t>
+              <a:t>125</a:t>
             </a:r>
           </a:p>
         </p:txBody>
@@ -12385,7 +12385,7 @@
           <p:cNvPr id="121" name="">
             <a:extLst xmlns:a="http://schemas.openxmlformats.org/drawingml/2006/main">
               <a:ext uri="{FF2B5EF4-FFF2-40B4-BE49-F238E27FC236}">
-                <a16:creationId xmlns:a16="http://schemas.microsoft.com/office/drawing/2014/main" id="{69BB767E-45AE-4197-A24F-245EB21E3005}"/>
+                <a16:creationId xmlns:a16="http://schemas.microsoft.com/office/drawing/2014/main" id="{0F1C21BF-FF8D-496E-BA1C-2C5DCAE2A962}"/>
               </a:ext>
             </a:extLst>
           </p:cNvPr>
@@ -12418,7 +12418,7 @@
           <p:cNvPr id="122" name="">
             <a:extLst xmlns:a="http://schemas.openxmlformats.org/drawingml/2006/main">
               <a:ext uri="{FF2B5EF4-FFF2-40B4-BE49-F238E27FC236}">
-                <a16:creationId xmlns:a16="http://schemas.microsoft.com/office/drawing/2014/main" id="{D3CDFC75-C67B-4429-BDD8-9C43CAB20DC0}"/>
+                <a16:creationId xmlns:a16="http://schemas.microsoft.com/office/drawing/2014/main" id="{0C6FD718-D771-4C0A-A32D-B82C9A21E672}"/>
               </a:ext>
             </a:extLst>
           </p:cNvPr>
@@ -12472,7 +12472,7 @@
                 <a:ea typeface="Aptos"/>
                 <a:cs typeface="Aptos"/>
               </a:rPr>
-              <a:t>14.58</a:t>
+              <a:t>5.3</a:t>
             </a:r>
           </a:p>
         </p:txBody>
@@ -12482,7 +12482,7 @@
           <p:cNvPr id="123" name="">
             <a:extLst xmlns:a="http://schemas.openxmlformats.org/drawingml/2006/main">
               <a:ext uri="{FF2B5EF4-FFF2-40B4-BE49-F238E27FC236}">
-                <a16:creationId xmlns:a16="http://schemas.microsoft.com/office/drawing/2014/main" id="{4394B190-592E-418A-A031-12457D5746B5}"/>
+                <a16:creationId xmlns:a16="http://schemas.microsoft.com/office/drawing/2014/main" id="{7563D64A-FA82-43E6-BDB7-219BAEF70949}"/>
               </a:ext>
             </a:extLst>
           </p:cNvPr>
@@ -12515,7 +12515,7 @@
           <p:cNvPr id="124" name="">
             <a:extLst xmlns:a="http://schemas.openxmlformats.org/drawingml/2006/main">
               <a:ext uri="{FF2B5EF4-FFF2-40B4-BE49-F238E27FC236}">
-                <a16:creationId xmlns:a16="http://schemas.microsoft.com/office/drawing/2014/main" id="{046F5908-102C-426F-B4BE-2AA6EAC1E78B}"/>
+                <a16:creationId xmlns:a16="http://schemas.microsoft.com/office/drawing/2014/main" id="{BA9F28FD-ACAD-4B7F-876B-3AC891CE6D25}"/>
               </a:ext>
             </a:extLst>
           </p:cNvPr>
@@ -12569,7 +12569,7 @@
                 <a:ea typeface="Aptos"/>
                 <a:cs typeface="Aptos"/>
               </a:rPr>
-              <a:t>当前 GB10 端侧最优工作点之一</a:t>
+              <a:t>prefill 提升，但 decode 明显被长上下文拖慢</a:t>
             </a:r>
           </a:p>
         </p:txBody>
@@ -12579,7 +12579,7 @@
           <p:cNvPr id="125" name="">
             <a:extLst xmlns:a="http://schemas.openxmlformats.org/drawingml/2006/main">
               <a:ext uri="{FF2B5EF4-FFF2-40B4-BE49-F238E27FC236}">
-                <a16:creationId xmlns:a16="http://schemas.microsoft.com/office/drawing/2014/main" id="{D208E213-DE66-4E35-A00B-67F063391BE9}"/>
+                <a16:creationId xmlns:a16="http://schemas.microsoft.com/office/drawing/2014/main" id="{6087C76A-721D-4613-9213-BDB506A5206C}"/>
               </a:ext>
             </a:extLst>
           </p:cNvPr>
@@ -12612,7 +12612,7 @@
           <p:cNvPr id="126" name="">
             <a:extLst xmlns:a="http://schemas.openxmlformats.org/drawingml/2006/main">
               <a:ext uri="{FF2B5EF4-FFF2-40B4-BE49-F238E27FC236}">
-                <a16:creationId xmlns:a16="http://schemas.microsoft.com/office/drawing/2014/main" id="{C97AFF23-D4BB-4288-87BE-7931908F02EB}"/>
+                <a16:creationId xmlns:a16="http://schemas.microsoft.com/office/drawing/2014/main" id="{63477450-5FBD-4B53-A157-36E2B1DF8F16}"/>
               </a:ext>
             </a:extLst>
           </p:cNvPr>
@@ -12666,7 +12666,7 @@
                 <a:ea typeface="Aptos"/>
                 <a:cs typeface="Aptos"/>
               </a:rPr>
-              <a:t>常见问答可运行，但复杂任务仍偏慢</a:t>
+              <a:t>长文档回复等待感强</a:t>
             </a:r>
           </a:p>
         </p:txBody>
@@ -12676,7 +12676,7 @@
           <p:cNvPr id="127" name="">
             <a:extLst xmlns:a="http://schemas.openxmlformats.org/drawingml/2006/main">
               <a:ext uri="{FF2B5EF4-FFF2-40B4-BE49-F238E27FC236}">
-                <a16:creationId xmlns:a16="http://schemas.microsoft.com/office/drawing/2014/main" id="{B7E3019D-44DC-4C8C-AE30-C123B9D27364}"/>
+                <a16:creationId xmlns:a16="http://schemas.microsoft.com/office/drawing/2014/main" id="{CC1DA6B6-678D-4AF6-8A86-22D78404BD81}"/>
               </a:ext>
             </a:extLst>
           </p:cNvPr>
@@ -12709,7 +12709,7 @@
           <p:cNvPr id="128" name="">
             <a:extLst xmlns:a="http://schemas.openxmlformats.org/drawingml/2006/main">
               <a:ext uri="{FF2B5EF4-FFF2-40B4-BE49-F238E27FC236}">
-                <a16:creationId xmlns:a16="http://schemas.microsoft.com/office/drawing/2014/main" id="{A623F147-0D23-4F88-9DD7-7E2741FC3B36}"/>
+                <a16:creationId xmlns:a16="http://schemas.microsoft.com/office/drawing/2014/main" id="{88594BB3-40A5-4D51-8150-AC0CD41F39BF}"/>
               </a:ext>
             </a:extLst>
           </p:cNvPr>
@@ -12763,7 +12763,7 @@
                 <a:ea typeface="Aptos"/>
                 <a:cs typeface="Aptos"/>
               </a:rPr>
-              <a:t>后端优化已基本释放短上下文硬件潜力</a:t>
+              <a:t>长上下文场景下，用户体验已明显落后于云端预期</a:t>
             </a:r>
           </a:p>
         </p:txBody>
@@ -12773,7 +12773,7 @@
           <p:cNvPr id="129" name="">
             <a:extLst xmlns:a="http://schemas.openxmlformats.org/drawingml/2006/main">
               <a:ext uri="{FF2B5EF4-FFF2-40B4-BE49-F238E27FC236}">
-                <a16:creationId xmlns:a16="http://schemas.microsoft.com/office/drawing/2014/main" id="{C8DD2BE8-1B8F-4B3A-9872-01D9CB3C80FB}"/>
+                <a16:creationId xmlns:a16="http://schemas.microsoft.com/office/drawing/2014/main" id="{61BD0DE4-8203-4FD2-BE2E-5C740D65BBB2}"/>
               </a:ext>
             </a:extLst>
           </p:cNvPr>
@@ -12806,7 +12806,7 @@
           <p:cNvPr id="130" name="">
             <a:extLst xmlns:a="http://schemas.openxmlformats.org/drawingml/2006/main">
               <a:ext uri="{FF2B5EF4-FFF2-40B4-BE49-F238E27FC236}">
-                <a16:creationId xmlns:a16="http://schemas.microsoft.com/office/drawing/2014/main" id="{69ECCCD6-583F-49E6-8246-E2A6CE26A487}"/>
+                <a16:creationId xmlns:a16="http://schemas.microsoft.com/office/drawing/2014/main" id="{947DBAA8-8D5C-47F6-BC36-DAEEC866618C}"/>
               </a:ext>
             </a:extLst>
           </p:cNvPr>
@@ -12860,7 +12860,7 @@
                 <a:ea typeface="Aptos"/>
                 <a:cs typeface="Aptos"/>
               </a:rPr>
-              <a:t>131,072</a:t>
+              <a:t>128K</a:t>
             </a:r>
           </a:p>
         </p:txBody>
@@ -12870,7 +12870,7 @@
           <p:cNvPr id="131" name="">
             <a:extLst xmlns:a="http://schemas.openxmlformats.org/drawingml/2006/main">
               <a:ext uri="{FF2B5EF4-FFF2-40B4-BE49-F238E27FC236}">
-                <a16:creationId xmlns:a16="http://schemas.microsoft.com/office/drawing/2014/main" id="{57D0E30E-538A-497F-A84B-C59E263888ED}"/>
+                <a16:creationId xmlns:a16="http://schemas.microsoft.com/office/drawing/2014/main" id="{2835C1C0-8593-4EBF-9046-4DDF5835DB14}"/>
               </a:ext>
             </a:extLst>
           </p:cNvPr>
@@ -12903,7 +12903,7 @@
           <p:cNvPr id="132" name="">
             <a:extLst xmlns:a="http://schemas.openxmlformats.org/drawingml/2006/main">
               <a:ext uri="{FF2B5EF4-FFF2-40B4-BE49-F238E27FC236}">
-                <a16:creationId xmlns:a16="http://schemas.microsoft.com/office/drawing/2014/main" id="{645A2010-91CC-4481-9DFC-9C0C0132130B}"/>
+                <a16:creationId xmlns:a16="http://schemas.microsoft.com/office/drawing/2014/main" id="{96E64673-759A-48BC-94DA-9BB365636B57}"/>
               </a:ext>
             </a:extLst>
           </p:cNvPr>
@@ -12957,7 +12957,7 @@
                 <a:ea typeface="Aptos"/>
                 <a:cs typeface="Aptos"/>
               </a:rPr>
-              <a:t>290.63</a:t>
+              <a:t>130</a:t>
             </a:r>
           </a:p>
         </p:txBody>
@@ -12967,7 +12967,7 @@
           <p:cNvPr id="133" name="">
             <a:extLst xmlns:a="http://schemas.openxmlformats.org/drawingml/2006/main">
               <a:ext uri="{FF2B5EF4-FFF2-40B4-BE49-F238E27FC236}">
-                <a16:creationId xmlns:a16="http://schemas.microsoft.com/office/drawing/2014/main" id="{64BEA526-9B12-4201-AD59-AEE4683B7E59}"/>
+                <a16:creationId xmlns:a16="http://schemas.microsoft.com/office/drawing/2014/main" id="{25FDB35F-B072-4AB9-AF79-1151996A51D6}"/>
               </a:ext>
             </a:extLst>
           </p:cNvPr>
@@ -13000,7 +13000,7 @@
           <p:cNvPr id="134" name="">
             <a:extLst xmlns:a="http://schemas.openxmlformats.org/drawingml/2006/main">
               <a:ext uri="{FF2B5EF4-FFF2-40B4-BE49-F238E27FC236}">
-                <a16:creationId xmlns:a16="http://schemas.microsoft.com/office/drawing/2014/main" id="{867ED570-E192-45D9-80B8-ED6359B0AA61}"/>
+                <a16:creationId xmlns:a16="http://schemas.microsoft.com/office/drawing/2014/main" id="{C4880D15-7C4C-4117-B152-1C344BA5D6A4}"/>
               </a:ext>
             </a:extLst>
           </p:cNvPr>
@@ -13054,7 +13054,7 @@
                 <a:ea typeface="Aptos"/>
                 <a:cs typeface="Aptos"/>
               </a:rPr>
-              <a:t>10.73</a:t>
+              <a:t>4.2</a:t>
             </a:r>
           </a:p>
         </p:txBody>
@@ -13064,7 +13064,7 @@
           <p:cNvPr id="135" name="">
             <a:extLst xmlns:a="http://schemas.openxmlformats.org/drawingml/2006/main">
               <a:ext uri="{FF2B5EF4-FFF2-40B4-BE49-F238E27FC236}">
-                <a16:creationId xmlns:a16="http://schemas.microsoft.com/office/drawing/2014/main" id="{CEE45780-6A35-46D4-B802-9D9F44B83F9B}"/>
+                <a16:creationId xmlns:a16="http://schemas.microsoft.com/office/drawing/2014/main" id="{4DE5D9AE-1155-44D8-A7D9-7DD3C4531960}"/>
               </a:ext>
             </a:extLst>
           </p:cNvPr>
@@ -13097,7 +13097,7 @@
           <p:cNvPr id="136" name="">
             <a:extLst xmlns:a="http://schemas.openxmlformats.org/drawingml/2006/main">
               <a:ext uri="{FF2B5EF4-FFF2-40B4-BE49-F238E27FC236}">
-                <a16:creationId xmlns:a16="http://schemas.microsoft.com/office/drawing/2014/main" id="{CDE45C36-8053-4E95-A7F9-8376E49054CF}"/>
+                <a16:creationId xmlns:a16="http://schemas.microsoft.com/office/drawing/2014/main" id="{BE287D04-ED1D-4F3D-9C5D-867B7FDF0FD9}"/>
               </a:ext>
             </a:extLst>
           </p:cNvPr>
@@ -13151,7 +13151,7 @@
                 <a:ea typeface="Aptos"/>
                 <a:cs typeface="Aptos"/>
               </a:rPr>
-              <a:t>长上下文下 prefill / decode 同时退化</a:t>
+              <a:t>prefill 基本见顶，decode 进一步下探</a:t>
             </a:r>
           </a:p>
         </p:txBody>
@@ -13161,7 +13161,7 @@
           <p:cNvPr id="137" name="">
             <a:extLst xmlns:a="http://schemas.openxmlformats.org/drawingml/2006/main">
               <a:ext uri="{FF2B5EF4-FFF2-40B4-BE49-F238E27FC236}">
-                <a16:creationId xmlns:a16="http://schemas.microsoft.com/office/drawing/2014/main" id="{4E36CA13-7B3E-4231-8A09-1570DFB38D35}"/>
+                <a16:creationId xmlns:a16="http://schemas.microsoft.com/office/drawing/2014/main" id="{564235F5-582B-4B50-B712-97B047CF20AC}"/>
               </a:ext>
             </a:extLst>
           </p:cNvPr>
@@ -13194,7 +13194,7 @@
           <p:cNvPr id="138" name="">
             <a:extLst xmlns:a="http://schemas.openxmlformats.org/drawingml/2006/main">
               <a:ext uri="{FF2B5EF4-FFF2-40B4-BE49-F238E27FC236}">
-                <a16:creationId xmlns:a16="http://schemas.microsoft.com/office/drawing/2014/main" id="{404D9CC4-0E05-43A0-BF58-500BA0A6B267}"/>
+                <a16:creationId xmlns:a16="http://schemas.microsoft.com/office/drawing/2014/main" id="{2F952426-96C6-4C15-9EA9-1634BCA9684B}"/>
               </a:ext>
             </a:extLst>
           </p:cNvPr>
@@ -13248,7 +13248,7 @@
                 <a:ea typeface="Aptos"/>
                 <a:cs typeface="Aptos"/>
               </a:rPr>
-              <a:t>长文档与复杂任务等待感明显</a:t>
+              <a:t>复杂任务和长文档体感更差</a:t>
             </a:r>
           </a:p>
         </p:txBody>
@@ -13258,7 +13258,7 @@
           <p:cNvPr id="139" name="">
             <a:extLst xmlns:a="http://schemas.openxmlformats.org/drawingml/2006/main">
               <a:ext uri="{FF2B5EF4-FFF2-40B4-BE49-F238E27FC236}">
-                <a16:creationId xmlns:a16="http://schemas.microsoft.com/office/drawing/2014/main" id="{A8CA68BD-A561-4EC6-BED7-A9559CFA1DD9}"/>
+                <a16:creationId xmlns:a16="http://schemas.microsoft.com/office/drawing/2014/main" id="{EE921E87-DC24-46FA-AD3D-98E0650759CA}"/>
               </a:ext>
             </a:extLst>
           </p:cNvPr>
@@ -13291,7 +13291,7 @@
           <p:cNvPr id="140" name="">
             <a:extLst xmlns:a="http://schemas.openxmlformats.org/drawingml/2006/main">
               <a:ext uri="{FF2B5EF4-FFF2-40B4-BE49-F238E27FC236}">
-                <a16:creationId xmlns:a16="http://schemas.microsoft.com/office/drawing/2014/main" id="{718A63D8-D3BB-43D8-AD05-B246BFCB7510}"/>
+                <a16:creationId xmlns:a16="http://schemas.microsoft.com/office/drawing/2014/main" id="{C807D2B2-AC21-481F-A177-2BB348DD70C0}"/>
               </a:ext>
             </a:extLst>
           </p:cNvPr>
@@ -13355,7 +13355,7 @@
           <p:cNvPr id="141" name="">
             <a:extLst xmlns:a="http://schemas.openxmlformats.org/drawingml/2006/main">
               <a:ext uri="{FF2B5EF4-FFF2-40B4-BE49-F238E27FC236}">
-                <a16:creationId xmlns:a16="http://schemas.microsoft.com/office/drawing/2014/main" id="{480C292F-422D-424F-9F43-EE875804CB23}"/>
+                <a16:creationId xmlns:a16="http://schemas.microsoft.com/office/drawing/2014/main" id="{9FBD66C7-405B-467C-9002-5994E1A4D8D7}"/>
               </a:ext>
             </a:extLst>
           </p:cNvPr>
@@ -13388,7 +13388,7 @@
           <p:cNvPr id="142" name="">
             <a:extLst xmlns:a="http://schemas.openxmlformats.org/drawingml/2006/main">
               <a:ext uri="{FF2B5EF4-FFF2-40B4-BE49-F238E27FC236}">
-                <a16:creationId xmlns:a16="http://schemas.microsoft.com/office/drawing/2014/main" id="{FB2E4F38-5B73-4A25-9A87-C45A27846A9E}"/>
+                <a16:creationId xmlns:a16="http://schemas.microsoft.com/office/drawing/2014/main" id="{05063E43-4409-4582-A575-0CEBE1018F2F}"/>
               </a:ext>
             </a:extLst>
           </p:cNvPr>
@@ -13421,7 +13421,7 @@
           <p:cNvPr id="143" name="">
             <a:extLst xmlns:a="http://schemas.openxmlformats.org/drawingml/2006/main">
               <a:ext uri="{FF2B5EF4-FFF2-40B4-BE49-F238E27FC236}">
-                <a16:creationId xmlns:a16="http://schemas.microsoft.com/office/drawing/2014/main" id="{72293B76-A238-433F-9E95-0626EAB5D692}"/>
+                <a16:creationId xmlns:a16="http://schemas.microsoft.com/office/drawing/2014/main" id="{8106D0C1-582D-4754-8738-74A73A1C02E7}"/>
               </a:ext>
             </a:extLst>
           </p:cNvPr>
@@ -13485,7 +13485,7 @@
           <p:cNvPr id="144" name="">
             <a:extLst xmlns:a="http://schemas.openxmlformats.org/drawingml/2006/main">
               <a:ext uri="{FF2B5EF4-FFF2-40B4-BE49-F238E27FC236}">
-                <a16:creationId xmlns:a16="http://schemas.microsoft.com/office/drawing/2014/main" id="{7A758C47-25E6-4992-AE9A-34AB76B561F0}"/>
+                <a16:creationId xmlns:a16="http://schemas.microsoft.com/office/drawing/2014/main" id="{EA5E516B-2BE3-4D1F-8DA6-8F82D40BBF93}"/>
               </a:ext>
             </a:extLst>
           </p:cNvPr>
@@ -13518,7 +13518,7 @@
           <p:cNvPr id="145" name="">
             <a:extLst xmlns:a="http://schemas.openxmlformats.org/drawingml/2006/main">
               <a:ext uri="{FF2B5EF4-FFF2-40B4-BE49-F238E27FC236}">
-                <a16:creationId xmlns:a16="http://schemas.microsoft.com/office/drawing/2014/main" id="{8ED3DBDB-7661-4882-A3DD-B4713A29DC84}"/>
+                <a16:creationId xmlns:a16="http://schemas.microsoft.com/office/drawing/2014/main" id="{0CAF46C7-CD63-4C6F-8758-33E750C26CE0}"/>
               </a:ext>
             </a:extLst>
           </p:cNvPr>
@@ -13551,7 +13551,7 @@
           <p:cNvPr id="146" name="">
             <a:extLst xmlns:a="http://schemas.openxmlformats.org/drawingml/2006/main">
               <a:ext uri="{FF2B5EF4-FFF2-40B4-BE49-F238E27FC236}">
-                <a16:creationId xmlns:a16="http://schemas.microsoft.com/office/drawing/2014/main" id="{A622A1D1-D12B-4DB4-8AC5-37753972D14C}"/>
+                <a16:creationId xmlns:a16="http://schemas.microsoft.com/office/drawing/2014/main" id="{FD94166D-76EC-474A-8391-02DE2CF2207F}"/>
               </a:ext>
             </a:extLst>
           </p:cNvPr>
@@ -13615,7 +13615,7 @@
           <p:cNvPr id="147" name="">
             <a:extLst xmlns:a="http://schemas.openxmlformats.org/drawingml/2006/main">
               <a:ext uri="{FF2B5EF4-FFF2-40B4-BE49-F238E27FC236}">
-                <a16:creationId xmlns:a16="http://schemas.microsoft.com/office/drawing/2014/main" id="{D81093B4-9BC2-4B9B-AC3E-86AE2E0432AA}"/>
+                <a16:creationId xmlns:a16="http://schemas.microsoft.com/office/drawing/2014/main" id="{AE23715C-BD71-4398-B0F6-5289115BDE64}"/>
               </a:ext>
             </a:extLst>
           </p:cNvPr>
@@ -13648,7 +13648,7 @@
           <p:cNvPr id="148" name="">
             <a:extLst xmlns:a="http://schemas.openxmlformats.org/drawingml/2006/main">
               <a:ext uri="{FF2B5EF4-FFF2-40B4-BE49-F238E27FC236}">
-                <a16:creationId xmlns:a16="http://schemas.microsoft.com/office/drawing/2014/main" id="{E3925F99-24D8-440F-9DA3-A92955260365}"/>
+                <a16:creationId xmlns:a16="http://schemas.microsoft.com/office/drawing/2014/main" id="{A40DA984-9320-4621-B1ED-851ECB060258}"/>
               </a:ext>
             </a:extLst>
           </p:cNvPr>
@@ -13681,7 +13681,7 @@
           <p:cNvPr id="149" name="">
             <a:extLst xmlns:a="http://schemas.openxmlformats.org/drawingml/2006/main">
               <a:ext uri="{FF2B5EF4-FFF2-40B4-BE49-F238E27FC236}">
-                <a16:creationId xmlns:a16="http://schemas.microsoft.com/office/drawing/2014/main" id="{95A3C727-79AA-42A7-B18B-66893D2D522A}"/>
+                <a16:creationId xmlns:a16="http://schemas.microsoft.com/office/drawing/2014/main" id="{8F90E4A8-255A-4B9B-BB3B-6ECC881C9878}"/>
               </a:ext>
             </a:extLst>
           </p:cNvPr>
@@ -13745,7 +13745,7 @@
           <p:cNvPr id="150" name="">
             <a:extLst xmlns:a="http://schemas.openxmlformats.org/drawingml/2006/main">
               <a:ext uri="{FF2B5EF4-FFF2-40B4-BE49-F238E27FC236}">
-                <a16:creationId xmlns:a16="http://schemas.microsoft.com/office/drawing/2014/main" id="{F017DF4D-47EA-4F71-B008-007BBA0136CF}"/>
+                <a16:creationId xmlns:a16="http://schemas.microsoft.com/office/drawing/2014/main" id="{46ACA033-BD3F-4FE7-8C68-ADD4A02CCF8E}"/>
               </a:ext>
             </a:extLst>
           </p:cNvPr>
@@ -13809,7 +13809,7 @@
           <p:cNvPr id="151" name="">
             <a:extLst xmlns:a="http://schemas.openxmlformats.org/drawingml/2006/main">
               <a:ext uri="{FF2B5EF4-FFF2-40B4-BE49-F238E27FC236}">
-                <a16:creationId xmlns:a16="http://schemas.microsoft.com/office/drawing/2014/main" id="{C86EFB3E-722E-49FE-8552-C20A35283579}"/>
+                <a16:creationId xmlns:a16="http://schemas.microsoft.com/office/drawing/2014/main" id="{203D23BA-1260-48EF-91D4-834FC4389384}"/>
               </a:ext>
             </a:extLst>
           </p:cNvPr>
@@ -13873,7 +13873,7 @@
           <p:cNvPr id="152" name="">
             <a:extLst xmlns:a="http://schemas.openxmlformats.org/drawingml/2006/main">
               <a:ext uri="{FF2B5EF4-FFF2-40B4-BE49-F238E27FC236}">
-                <a16:creationId xmlns:a16="http://schemas.microsoft.com/office/drawing/2014/main" id="{877B9989-42E4-4EB2-A89B-4F04CD89810A}"/>
+                <a16:creationId xmlns:a16="http://schemas.microsoft.com/office/drawing/2014/main" id="{4BD0CAF5-838A-4CB9-95F0-C065AB29F260}"/>
               </a:ext>
             </a:extLst>
           </p:cNvPr>
@@ -13937,7 +13937,7 @@
           <p:cNvPr id="153" name="">
             <a:extLst xmlns:a="http://schemas.openxmlformats.org/drawingml/2006/main">
               <a:ext uri="{FF2B5EF4-FFF2-40B4-BE49-F238E27FC236}">
-                <a16:creationId xmlns:a16="http://schemas.microsoft.com/office/drawing/2014/main" id="{689D4981-8574-4AB6-ACB6-8A00BDDFCA82}"/>
+                <a16:creationId xmlns:a16="http://schemas.microsoft.com/office/drawing/2014/main" id="{3AC1D83D-0FE8-40E7-8925-AFEC5ACA1F71}"/>
               </a:ext>
             </a:extLst>
           </p:cNvPr>
@@ -14001,7 +14001,7 @@
           <p:cNvPr id="154" name="">
             <a:extLst xmlns:a="http://schemas.openxmlformats.org/drawingml/2006/main">
               <a:ext uri="{FF2B5EF4-FFF2-40B4-BE49-F238E27FC236}">
-                <a16:creationId xmlns:a16="http://schemas.microsoft.com/office/drawing/2014/main" id="{D796266C-9BA3-4D97-BF1B-FEFB95563C64}"/>
+                <a16:creationId xmlns:a16="http://schemas.microsoft.com/office/drawing/2014/main" id="{B51923AA-4077-48E9-901A-357C8590FC45}"/>
               </a:ext>
             </a:extLst>
           </p:cNvPr>
@@ -14065,7 +14065,7 @@
           <p:cNvPr id="155" name="">
             <a:extLst xmlns:a="http://schemas.openxmlformats.org/drawingml/2006/main">
               <a:ext uri="{FF2B5EF4-FFF2-40B4-BE49-F238E27FC236}">
-                <a16:creationId xmlns:a16="http://schemas.microsoft.com/office/drawing/2014/main" id="{FCB4AF65-DE90-4DAB-BBBB-6F20ADE7049C}"/>
+                <a16:creationId xmlns:a16="http://schemas.microsoft.com/office/drawing/2014/main" id="{A6A8A3A2-95F5-4E0D-BBB4-4CF630D5EAB4}"/>
               </a:ext>
             </a:extLst>
           </p:cNvPr>
@@ -14129,7 +14129,7 @@
           <p:cNvPr id="156" name="">
             <a:extLst xmlns:a="http://schemas.openxmlformats.org/drawingml/2006/main">
               <a:ext uri="{FF2B5EF4-FFF2-40B4-BE49-F238E27FC236}">
-                <a16:creationId xmlns:a16="http://schemas.microsoft.com/office/drawing/2014/main" id="{BC3F81BB-7928-4AA6-9DED-1CCD9246BF74}"/>
+                <a16:creationId xmlns:a16="http://schemas.microsoft.com/office/drawing/2014/main" id="{0530964A-FDC6-4434-A9A7-F69D9D2DB1C7}"/>
               </a:ext>
             </a:extLst>
           </p:cNvPr>
@@ -14193,7 +14193,7 @@
           <p:cNvPr id="157" name="">
             <a:extLst xmlns:a="http://schemas.openxmlformats.org/drawingml/2006/main">
               <a:ext uri="{FF2B5EF4-FFF2-40B4-BE49-F238E27FC236}">
-                <a16:creationId xmlns:a16="http://schemas.microsoft.com/office/drawing/2014/main" id="{DBC892FB-1FC3-4B46-A582-CCAD23F371C8}"/>
+                <a16:creationId xmlns:a16="http://schemas.microsoft.com/office/drawing/2014/main" id="{7A00EF7E-F0B4-466E-BB12-98FA3D2D83BA}"/>
               </a:ext>
             </a:extLst>
           </p:cNvPr>
@@ -14257,7 +14257,7 @@
           <p:cNvPr id="158" name="">
             <a:extLst xmlns:a="http://schemas.openxmlformats.org/drawingml/2006/main">
               <a:ext uri="{FF2B5EF4-FFF2-40B4-BE49-F238E27FC236}">
-                <a16:creationId xmlns:a16="http://schemas.microsoft.com/office/drawing/2014/main" id="{5BED15BB-2025-4109-98A2-349BDD28FCAF}"/>
+                <a16:creationId xmlns:a16="http://schemas.microsoft.com/office/drawing/2014/main" id="{2F1C4DC1-C875-49F3-9E46-4A8A0A54D48A}"/>
               </a:ext>
             </a:extLst>
           </p:cNvPr>
@@ -14321,7 +14321,7 @@
           <p:cNvPr id="159" name="">
             <a:extLst xmlns:a="http://schemas.openxmlformats.org/drawingml/2006/main">
               <a:ext uri="{FF2B5EF4-FFF2-40B4-BE49-F238E27FC236}">
-                <a16:creationId xmlns:a16="http://schemas.microsoft.com/office/drawing/2014/main" id="{E32595E0-F87E-4AC0-919A-C8DF8C5B46C8}"/>
+                <a16:creationId xmlns:a16="http://schemas.microsoft.com/office/drawing/2014/main" id="{51E470F0-4324-47B2-AA12-2C3442367BCA}"/>
               </a:ext>
             </a:extLst>
           </p:cNvPr>
@@ -14354,7 +14354,7 @@
           <p:cNvPr id="160" name="">
             <a:extLst xmlns:a="http://schemas.openxmlformats.org/drawingml/2006/main">
               <a:ext uri="{FF2B5EF4-FFF2-40B4-BE49-F238E27FC236}">
-                <a16:creationId xmlns:a16="http://schemas.microsoft.com/office/drawing/2014/main" id="{526094F6-B412-4634-B981-E50AA21E206F}"/>
+                <a16:creationId xmlns:a16="http://schemas.microsoft.com/office/drawing/2014/main" id="{29FEA1C0-FE25-4777-9669-5DD416819D36}"/>
               </a:ext>
             </a:extLst>
           </p:cNvPr>
@@ -14408,7 +14408,7 @@
                 <a:ea typeface="Aptos"/>
                 <a:cs typeface="Aptos"/>
               </a:rPr>
-              <a:t>核心结论：我们已经把 GB10 端侧后端优化到“能跑、能测、能迭代”的阶段，实测 prefill 峰值约 396 tok/s、decode 约 10.7–16.1 tok/s；但真正限制用户体验的，已经不只是后端实现，而是模型能力、长上下文质量和复杂任务 tail latency。因此下一步必须用云端模型补齐体验上限。</a:t>
+              <a:t>核心结论：我们已经把 GB10 端侧后端优化到“能跑、能测、能迭代”的阶段，但当前实测仅约为：512 ctx prefill/decode = 58 / 8.15 tok/s，64K ctx = 125 / 5.3 tok/s，128K ctx = 130 / 4.2 tok/s。真正限制用户体验的，已经不只是后端实现，而是模型能力、长上下文质量和复杂任务 tail latency。因此下一步必须用云端模型补齐体验上限。</a:t>
             </a:r>
           </a:p>
         </p:txBody>
@@ -14418,7 +14418,7 @@
           <p:cNvPr id="161" name="">
             <a:extLst xmlns:a="http://schemas.openxmlformats.org/drawingml/2006/main">
               <a:ext uri="{FF2B5EF4-FFF2-40B4-BE49-F238E27FC236}">
-                <a16:creationId xmlns:a16="http://schemas.microsoft.com/office/drawing/2014/main" id="{4ED7F907-F552-4179-A5A0-1C2AF3350CAF}"/>
+                <a16:creationId xmlns:a16="http://schemas.microsoft.com/office/drawing/2014/main" id="{1FA57F86-7292-4448-9F29-81D2EE581124}"/>
               </a:ext>
             </a:extLst>
           </p:cNvPr>
@@ -14451,7 +14451,7 @@
           <p:cNvPr id="162" name="">
             <a:extLst xmlns:a="http://schemas.openxmlformats.org/drawingml/2006/main">
               <a:ext uri="{FF2B5EF4-FFF2-40B4-BE49-F238E27FC236}">
-                <a16:creationId xmlns:a16="http://schemas.microsoft.com/office/drawing/2014/main" id="{0A6B4509-2DD5-4889-AB45-8483C73716CE}"/>
+                <a16:creationId xmlns:a16="http://schemas.microsoft.com/office/drawing/2014/main" id="{073BA5E7-ADB0-4863-B238-E9D0305E2DA0}"/>
               </a:ext>
             </a:extLst>
           </p:cNvPr>
@@ -14513,7 +14513,7 @@
     </p:spTree>
     <p:extLst>
       <p:ext uri="{BB962C8B-B14F-4D97-AF65-F5344CB8AC3E}">
-        <p14:creationId xmlns:p14="http://schemas.microsoft.com/office/powerpoint/2010/main" val="1653837123"/>
+        <p14:creationId xmlns:p14="http://schemas.microsoft.com/office/powerpoint/2010/main" val="1975304976"/>
       </p:ext>
     </p:extLst>
   </p:cSld>

</xml_diff>